<commit_message>
docs: generalize tech stack, remove roadmap deadlines, and specify accurate author workplace
</commit_message>
<xml_diff>
--- a/grant-presentation/Tarixi-Timeline_Tauelsizdik_urpaqtary.pptx
+++ b/grant-presentation/Tarixi-Timeline_Tauelsizdik_urpaqtary.pptx
@@ -2122,7 +2122,7 @@
                 <a:ea typeface="Calibri" pitchFamily="34" charset="-122"/>
                 <a:cs typeface="Calibri" pitchFamily="34" charset="-120"/>
               </a:rPr>
-              <a:t>Bekassyl Karazhan · Бас бағдарламашы, техника ғылымдарының магистрі</a:t>
+              <a:t>Bekassyl Karazhan · ҚР ПІБ МТҚБ Инженерлік орталығының бас бағдарламашысы, техника ғылымдарының магистрі</a:t>
             </a:r>
             <a:endParaRPr lang="en-US" sz="1300" dirty="0"/>
           </a:p>
@@ -2416,7 +2416,7 @@
                 <a:ea typeface="Calibri" pitchFamily="34" charset="-122"/>
                 <a:cs typeface="Calibri" pitchFamily="34" charset="-120"/>
               </a:rPr>
-              <a:t>1-3 ай</a:t>
+              <a:t>1-кезең</a:t>
             </a:r>
             <a:endParaRPr lang="en-US" sz="1200" dirty="0"/>
           </a:p>
@@ -2576,7 +2576,7 @@
                 <a:ea typeface="Calibri" pitchFamily="34" charset="-122"/>
                 <a:cs typeface="Calibri" pitchFamily="34" charset="-120"/>
               </a:rPr>
-              <a:t>4-6 ай</a:t>
+              <a:t>2-кезең</a:t>
             </a:r>
             <a:endParaRPr lang="en-US" sz="1200" dirty="0"/>
           </a:p>
@@ -2736,7 +2736,7 @@
                 <a:ea typeface="Calibri" pitchFamily="34" charset="-122"/>
                 <a:cs typeface="Calibri" pitchFamily="34" charset="-120"/>
               </a:rPr>
-              <a:t>7-9 ай</a:t>
+              <a:t>3-кезең</a:t>
             </a:r>
             <a:endParaRPr lang="en-US" sz="1200" dirty="0"/>
           </a:p>
@@ -2896,7 +2896,7 @@
                 <a:ea typeface="Calibri" pitchFamily="34" charset="-122"/>
                 <a:cs typeface="Calibri" pitchFamily="34" charset="-120"/>
               </a:rPr>
-              <a:t>10-12 ай</a:t>
+              <a:t>4-кезең</a:t>
             </a:r>
             <a:endParaRPr lang="en-US" sz="1200" dirty="0"/>
           </a:p>
@@ -8241,7 +8241,7 @@
                 <a:ea typeface="Georgia" pitchFamily="34" charset="-122"/>
                 <a:cs typeface="Georgia" pitchFamily="34" charset="-120"/>
               </a:rPr>
-              <a:t>C# · .NET 8+</a:t>
+              <a:t>Заманауи веб-технологиялар</a:t>
             </a:r>
             <a:endParaRPr lang="en-US" sz="1700" dirty="0"/>
           </a:p>
@@ -8398,7 +8398,7 @@
                 <a:ea typeface="Georgia" pitchFamily="34" charset="-122"/>
                 <a:cs typeface="Georgia" pitchFamily="34" charset="-120"/>
               </a:rPr>
-              <a:t>PostgreSQL</a:t>
+              <a:t>Сенімді ДҚБЖ</a:t>
             </a:r>
             <a:endParaRPr lang="en-US" sz="1700" dirty="0"/>
           </a:p>
@@ -8440,7 +8440,7 @@
                 <a:ea typeface="Calibri" pitchFamily="34" charset="-122"/>
                 <a:cs typeface="Calibri" pitchFamily="34" charset="-120"/>
               </a:rPr>
-              <a:t>Тарихи деректермен жұмыстың домендік логикасы реляциялық ДҚБЖ-мен инкапсуляцияланған.</a:t>
+              <a:t>Тарихи деректермен жұмыстың домендік логикасы реляциялық дерекқормен инкапсуляцияланған.</a:t>
             </a:r>
             <a:endParaRPr lang="en-US" sz="1250" dirty="0"/>
           </a:p>
@@ -8597,7 +8597,7 @@
                 <a:ea typeface="Calibri" pitchFamily="34" charset="-122"/>
                 <a:cs typeface="Calibri" pitchFamily="34" charset="-120"/>
               </a:rPr>
-              <a:t>OpenAI / Anthropic API жеке инфрақұрылым қабатында - vendor lock-in минималды, миграция оңай.</a:t>
+              <a:t>OpenAI / Anthropic / Groq API жеке инфрақұрылым қабатында - vendor lock-in минималды, миграция оңай.</a:t>
             </a:r>
             <a:endParaRPr lang="en-US" sz="1250" dirty="0"/>
           </a:p>
@@ -8877,7 +8877,7 @@
                 <a:ea typeface="Calibri" pitchFamily="34" charset="-122"/>
                 <a:cs typeface="Calibri" pitchFamily="34" charset="-120"/>
               </a:rPr>
-              <a:t>Бас бағдарламашы, техника ғылымдарының магистрі, мемлекеттік инжинирингтік орталық қызметкері. .NET платформасында ПО әзірлеудің толық циклін басқару тәжірибесі.</a:t>
+              <a:t>ҚР ПІБ МТҚБ Инженерлік орталығының бас бағдарламашысы, техника ғылымдарының магистрі. ПО әзірлеудің толық циклін басқару тәжірибесі.</a:t>
             </a:r>
             <a:endParaRPr lang="en-US" sz="1350" dirty="0"/>
           </a:p>

</xml_diff>

<commit_message>
fix: adjust text bounds and font sizes in presentation to prevent overflow
</commit_message>
<xml_diff>
--- a/grant-presentation/Tarixi-Timeline_Tauelsizdik_urpaqtary.pptx
+++ b/grant-presentation/Tarixi-Timeline_Tauelsizdik_urpaqtary.pptx
@@ -2098,23 +2098,23 @@
         <p:spPr>
           <a:xfrm>
             <a:off x="822960" y="5943600"/>
-            <a:ext cx="10058400" cy="365760"/>
-          </a:xfrm>
-          <a:prstGeom prst="rect">
-            <a:avLst/>
-          </a:prstGeom>
-          <a:noFill/>
-          <a:ln/>
-        </p:spPr>
-        <p:txBody>
-          <a:bodyPr wrap="square" lIns="0" tIns="0" rIns="0" bIns="0" rtlCol="0" anchor="ctr"/>
-          <a:lstStyle/>
-          <a:p>
-            <a:pPr indent="0" marL="0">
-              <a:buNone/>
-            </a:pPr>
-            <a:r>
-              <a:rPr lang="en-US" sz="1300" i="1" dirty="0">
+            <a:ext cx="10972800" cy="365760"/>
+          </a:xfrm>
+          <a:prstGeom prst="rect">
+            <a:avLst/>
+          </a:prstGeom>
+          <a:noFill/>
+          <a:ln/>
+        </p:spPr>
+        <p:txBody>
+          <a:bodyPr wrap="square" lIns="0" tIns="0" rIns="0" bIns="0" rtlCol="0" anchor="ctr"/>
+          <a:lstStyle/>
+          <a:p>
+            <a:pPr indent="0" marL="0">
+              <a:buNone/>
+            </a:pPr>
+            <a:r>
+              <a:rPr lang="en-US" sz="1200" i="1" dirty="0">
                 <a:solidFill>
                   <a:srgbClr val="AFC3CE"/>
                 </a:solidFill>
@@ -2124,7 +2124,7 @@
               </a:rPr>
               <a:t>Bekassyl Karazhan · ҚР ПІБ МТҚБ Инженерлік орталығының бас бағдарламашысы, техника ғылымдарының магистрі</a:t>
             </a:r>
-            <a:endParaRPr lang="en-US" sz="1300" dirty="0"/>
+            <a:endParaRPr lang="en-US" sz="1200" dirty="0"/>
           </a:p>
         </p:txBody>
       </p:sp>
@@ -3083,7 +3083,7 @@
         <p:spPr>
           <a:xfrm>
             <a:off x="1691640" y="4343400"/>
-            <a:ext cx="5486400" cy="457200"/>
+            <a:ext cx="8686800" cy="457200"/>
           </a:xfrm>
           <a:prstGeom prst="rect">
             <a:avLst/>
@@ -3420,23 +3420,23 @@
         <p:spPr>
           <a:xfrm>
             <a:off x="640080" y="457200"/>
-            <a:ext cx="7315200" cy="320040"/>
-          </a:xfrm>
-          <a:prstGeom prst="rect">
-            <a:avLst/>
-          </a:prstGeom>
-          <a:noFill/>
-          <a:ln/>
-        </p:spPr>
-        <p:txBody>
-          <a:bodyPr wrap="square" lIns="0" tIns="0" rIns="0" bIns="0" rtlCol="0" anchor="ctr"/>
-          <a:lstStyle/>
-          <a:p>
-            <a:pPr indent="0" marL="0">
-              <a:buNone/>
-            </a:pPr>
-            <a:r>
-              <a:rPr lang="en-US" sz="1200" b="1" spc="300" kern="0" dirty="0">
+            <a:ext cx="10515600" cy="320040"/>
+          </a:xfrm>
+          <a:prstGeom prst="rect">
+            <a:avLst/>
+          </a:prstGeom>
+          <a:noFill/>
+          <a:ln/>
+        </p:spPr>
+        <p:txBody>
+          <a:bodyPr wrap="square" lIns="0" tIns="0" rIns="0" bIns="0" rtlCol="0" anchor="ctr"/>
+          <a:lstStyle/>
+          <a:p>
+            <a:pPr indent="0" marL="0">
+              <a:buNone/>
+            </a:pPr>
+            <a:r>
+              <a:rPr lang="en-US" sz="1200" b="1" spc="200" kern="0" dirty="0">
                 <a:solidFill>
                   <a:srgbClr val="E5B23C"/>
                 </a:solidFill>
@@ -4192,23 +4192,23 @@
         <p:spPr>
           <a:xfrm>
             <a:off x="640080" y="457200"/>
-            <a:ext cx="7315200" cy="320040"/>
-          </a:xfrm>
-          <a:prstGeom prst="rect">
-            <a:avLst/>
-          </a:prstGeom>
-          <a:noFill/>
-          <a:ln/>
-        </p:spPr>
-        <p:txBody>
-          <a:bodyPr wrap="square" lIns="0" tIns="0" rIns="0" bIns="0" rtlCol="0" anchor="ctr"/>
-          <a:lstStyle/>
-          <a:p>
-            <a:pPr indent="0" marL="0">
-              <a:buNone/>
-            </a:pPr>
-            <a:r>
-              <a:rPr lang="en-US" sz="1200" b="1" spc="300" kern="0" dirty="0">
+            <a:ext cx="10515600" cy="320040"/>
+          </a:xfrm>
+          <a:prstGeom prst="rect">
+            <a:avLst/>
+          </a:prstGeom>
+          <a:noFill/>
+          <a:ln/>
+        </p:spPr>
+        <p:txBody>
+          <a:bodyPr wrap="square" lIns="0" tIns="0" rIns="0" bIns="0" rtlCol="0" anchor="ctr"/>
+          <a:lstStyle/>
+          <a:p>
+            <a:pPr indent="0" marL="0">
+              <a:buNone/>
+            </a:pPr>
+            <a:r>
+              <a:rPr lang="en-US" sz="1200" b="1" spc="200" kern="0" dirty="0">
                 <a:solidFill>
                   <a:srgbClr val="E5B23C"/>
                 </a:solidFill>
@@ -4772,23 +4772,23 @@
         <p:spPr>
           <a:xfrm>
             <a:off x="640080" y="457200"/>
-            <a:ext cx="7315200" cy="320040"/>
-          </a:xfrm>
-          <a:prstGeom prst="rect">
-            <a:avLst/>
-          </a:prstGeom>
-          <a:noFill/>
-          <a:ln/>
-        </p:spPr>
-        <p:txBody>
-          <a:bodyPr wrap="square" lIns="0" tIns="0" rIns="0" bIns="0" rtlCol="0" anchor="ctr"/>
-          <a:lstStyle/>
-          <a:p>
-            <a:pPr indent="0" marL="0">
-              <a:buNone/>
-            </a:pPr>
-            <a:r>
-              <a:rPr lang="en-US" sz="1200" b="1" spc="300" kern="0" dirty="0">
+            <a:ext cx="10515600" cy="320040"/>
+          </a:xfrm>
+          <a:prstGeom prst="rect">
+            <a:avLst/>
+          </a:prstGeom>
+          <a:noFill/>
+          <a:ln/>
+        </p:spPr>
+        <p:txBody>
+          <a:bodyPr wrap="square" lIns="0" tIns="0" rIns="0" bIns="0" rtlCol="0" anchor="ctr"/>
+          <a:lstStyle/>
+          <a:p>
+            <a:pPr indent="0" marL="0">
+              <a:buNone/>
+            </a:pPr>
+            <a:r>
+              <a:rPr lang="en-US" sz="1200" b="1" spc="200" kern="0" dirty="0">
                 <a:solidFill>
                   <a:srgbClr val="E5B23C"/>
                 </a:solidFill>
@@ -4965,23 +4965,23 @@
         <p:spPr>
           <a:xfrm>
             <a:off x="914400" y="3063240"/>
-            <a:ext cx="3017520" cy="548640"/>
-          </a:xfrm>
-          <a:prstGeom prst="rect">
-            <a:avLst/>
-          </a:prstGeom>
-          <a:noFill/>
-          <a:ln/>
-        </p:spPr>
-        <p:txBody>
-          <a:bodyPr wrap="square" lIns="0" tIns="0" rIns="0" bIns="0" rtlCol="0" anchor="ctr"/>
-          <a:lstStyle/>
-          <a:p>
-            <a:pPr indent="0" marL="0">
-              <a:buNone/>
-            </a:pPr>
-            <a:r>
-              <a:rPr lang="en-US" sz="1800" b="1" dirty="0">
+            <a:ext cx="3154680" cy="548640"/>
+          </a:xfrm>
+          <a:prstGeom prst="rect">
+            <a:avLst/>
+          </a:prstGeom>
+          <a:noFill/>
+          <a:ln/>
+        </p:spPr>
+        <p:txBody>
+          <a:bodyPr wrap="square" lIns="0" tIns="0" rIns="0" bIns="0" rtlCol="0" anchor="ctr"/>
+          <a:lstStyle/>
+          <a:p>
+            <a:pPr indent="0" marL="0">
+              <a:buNone/>
+            </a:pPr>
+            <a:r>
+              <a:rPr lang="en-US" sz="1650" b="1" dirty="0">
                 <a:solidFill>
                   <a:srgbClr val="0B3D54"/>
                 </a:solidFill>
@@ -4991,7 +4991,7 @@
               </a:rPr>
               <a:t>Таймлайнды ашу</a:t>
             </a:r>
-            <a:endParaRPr lang="en-US" sz="1800" dirty="0"/>
+            <a:endParaRPr lang="en-US" sz="1650" dirty="0"/>
           </a:p>
         </p:txBody>
       </p:sp>
@@ -5004,7 +5004,7 @@
         <p:spPr>
           <a:xfrm>
             <a:off x="914400" y="3657600"/>
-            <a:ext cx="3017520" cy="1463040"/>
+            <a:ext cx="3154680" cy="1463040"/>
           </a:xfrm>
           <a:prstGeom prst="rect">
             <a:avLst/>
@@ -5023,7 +5023,7 @@
               <a:buNone/>
             </a:pPr>
             <a:r>
-              <a:rPr lang="en-US" sz="1300" dirty="0">
+              <a:rPr lang="en-US" sz="1250" dirty="0">
                 <a:solidFill>
                   <a:srgbClr val="1A2A33"/>
                 </a:solidFill>
@@ -5033,7 +5033,7 @@
               </a:rPr>
               <a:t>Оқушы дәуірді немесе оқиғаны таңдайды. Даталар, тұлғалар мен әдеби кезеңдер бір көрнекі осьте.</a:t>
             </a:r>
-            <a:endParaRPr lang="en-US" sz="1300" dirty="0"/>
+            <a:endParaRPr lang="en-US" sz="1250" dirty="0"/>
           </a:p>
         </p:txBody>
       </p:sp>
@@ -5161,23 +5161,23 @@
         <p:spPr>
           <a:xfrm>
             <a:off x="4636008" y="3063240"/>
-            <a:ext cx="3017520" cy="548640"/>
-          </a:xfrm>
-          <a:prstGeom prst="rect">
-            <a:avLst/>
-          </a:prstGeom>
-          <a:noFill/>
-          <a:ln/>
-        </p:spPr>
-        <p:txBody>
-          <a:bodyPr wrap="square" lIns="0" tIns="0" rIns="0" bIns="0" rtlCol="0" anchor="ctr"/>
-          <a:lstStyle/>
-          <a:p>
-            <a:pPr indent="0" marL="0">
-              <a:buNone/>
-            </a:pPr>
-            <a:r>
-              <a:rPr lang="en-US" sz="1800" b="1" dirty="0">
+            <a:ext cx="3154680" cy="548640"/>
+          </a:xfrm>
+          <a:prstGeom prst="rect">
+            <a:avLst/>
+          </a:prstGeom>
+          <a:noFill/>
+          <a:ln/>
+        </p:spPr>
+        <p:txBody>
+          <a:bodyPr wrap="square" lIns="0" tIns="0" rIns="0" bIns="0" rtlCol="0" anchor="ctr"/>
+          <a:lstStyle/>
+          <a:p>
+            <a:pPr indent="0" marL="0">
+              <a:buNone/>
+            </a:pPr>
+            <a:r>
+              <a:rPr lang="en-US" sz="1650" b="1" dirty="0">
                 <a:solidFill>
                   <a:srgbClr val="0B3D54"/>
                 </a:solidFill>
@@ -5187,7 +5187,7 @@
               </a:rPr>
               <a:t>Тұлғамен сөйлесу</a:t>
             </a:r>
-            <a:endParaRPr lang="en-US" sz="1800" dirty="0"/>
+            <a:endParaRPr lang="en-US" sz="1650" dirty="0"/>
           </a:p>
         </p:txBody>
       </p:sp>
@@ -5200,7 +5200,7 @@
         <p:spPr>
           <a:xfrm>
             <a:off x="4636008" y="3657600"/>
-            <a:ext cx="3017520" cy="1463040"/>
+            <a:ext cx="3154680" cy="1463040"/>
           </a:xfrm>
           <a:prstGeom prst="rect">
             <a:avLst/>
@@ -5219,7 +5219,7 @@
               <a:buNone/>
             </a:pPr>
             <a:r>
-              <a:rPr lang="en-US" sz="1300" dirty="0">
+              <a:rPr lang="en-US" sz="1250" dirty="0">
                 <a:solidFill>
                   <a:srgbClr val="1A2A33"/>
                 </a:solidFill>
@@ -5229,7 +5229,7 @@
               </a:rPr>
               <a:t>Әл-Фараби, Абай немесе хан-билермен ИИ арқылы сұхбаттасады - нақты адаммен сөйлескендей.</a:t>
             </a:r>
-            <a:endParaRPr lang="en-US" sz="1300" dirty="0"/>
+            <a:endParaRPr lang="en-US" sz="1250" dirty="0"/>
           </a:p>
         </p:txBody>
       </p:sp>
@@ -5357,23 +5357,23 @@
         <p:spPr>
           <a:xfrm>
             <a:off x="8357616" y="3063240"/>
-            <a:ext cx="3017520" cy="548640"/>
-          </a:xfrm>
-          <a:prstGeom prst="rect">
-            <a:avLst/>
-          </a:prstGeom>
-          <a:noFill/>
-          <a:ln/>
-        </p:spPr>
-        <p:txBody>
-          <a:bodyPr wrap="square" lIns="0" tIns="0" rIns="0" bIns="0" rtlCol="0" anchor="ctr"/>
-          <a:lstStyle/>
-          <a:p>
-            <a:pPr indent="0" marL="0">
-              <a:buNone/>
-            </a:pPr>
-            <a:r>
-              <a:rPr lang="en-US" sz="1800" b="1" dirty="0">
+            <a:ext cx="3154680" cy="548640"/>
+          </a:xfrm>
+          <a:prstGeom prst="rect">
+            <a:avLst/>
+          </a:prstGeom>
+          <a:noFill/>
+          <a:ln/>
+        </p:spPr>
+        <p:txBody>
+          <a:bodyPr wrap="square" lIns="0" tIns="0" rIns="0" bIns="0" rtlCol="0" anchor="ctr"/>
+          <a:lstStyle/>
+          <a:p>
+            <a:pPr indent="0" marL="0">
+              <a:buNone/>
+            </a:pPr>
+            <a:r>
+              <a:rPr lang="en-US" sz="1650" b="1" dirty="0">
                 <a:solidFill>
                   <a:srgbClr val="0B3D54"/>
                 </a:solidFill>
@@ -5383,7 +5383,7 @@
               </a:rPr>
               <a:t>Терең түсіну</a:t>
             </a:r>
-            <a:endParaRPr lang="en-US" sz="1800" dirty="0"/>
+            <a:endParaRPr lang="en-US" sz="1650" dirty="0"/>
           </a:p>
         </p:txBody>
       </p:sp>
@@ -5396,7 +5396,7 @@
         <p:spPr>
           <a:xfrm>
             <a:off x="8357616" y="3657600"/>
-            <a:ext cx="3017520" cy="1463040"/>
+            <a:ext cx="3154680" cy="1463040"/>
           </a:xfrm>
           <a:prstGeom prst="rect">
             <a:avLst/>
@@ -5415,7 +5415,7 @@
               <a:buNone/>
             </a:pPr>
             <a:r>
-              <a:rPr lang="en-US" sz="1300" dirty="0">
+              <a:rPr lang="en-US" sz="1250" dirty="0">
                 <a:solidFill>
                   <a:srgbClr val="1A2A33"/>
                 </a:solidFill>
@@ -5425,7 +5425,7 @@
               </a:rPr>
               <a:t>Эмоциялық тартылыс білімді есте сақтауды арттырады, тарихи ойлауды қалыптастырады.</a:t>
             </a:r>
-            <a:endParaRPr lang="en-US" sz="1300" dirty="0"/>
+            <a:endParaRPr lang="en-US" sz="1250" dirty="0"/>
           </a:p>
         </p:txBody>
       </p:sp>
@@ -5711,23 +5711,23 @@
         <p:spPr>
           <a:xfrm>
             <a:off x="640080" y="457200"/>
-            <a:ext cx="7315200" cy="320040"/>
-          </a:xfrm>
-          <a:prstGeom prst="rect">
-            <a:avLst/>
-          </a:prstGeom>
-          <a:noFill/>
-          <a:ln/>
-        </p:spPr>
-        <p:txBody>
-          <a:bodyPr wrap="square" lIns="0" tIns="0" rIns="0" bIns="0" rtlCol="0" anchor="ctr"/>
-          <a:lstStyle/>
-          <a:p>
-            <a:pPr indent="0" marL="0">
-              <a:buNone/>
-            </a:pPr>
-            <a:r>
-              <a:rPr lang="en-US" sz="1200" b="1" spc="300" kern="0" dirty="0">
+            <a:ext cx="10515600" cy="320040"/>
+          </a:xfrm>
+          <a:prstGeom prst="rect">
+            <a:avLst/>
+          </a:prstGeom>
+          <a:noFill/>
+          <a:ln/>
+        </p:spPr>
+        <p:txBody>
+          <a:bodyPr wrap="square" lIns="0" tIns="0" rIns="0" bIns="0" rtlCol="0" anchor="ctr"/>
+          <a:lstStyle/>
+          <a:p>
+            <a:pPr indent="0" marL="0">
+              <a:buNone/>
+            </a:pPr>
+            <a:r>
+              <a:rPr lang="en-US" sz="1200" b="1" spc="200" kern="0" dirty="0">
                 <a:solidFill>
                   <a:srgbClr val="E5B23C"/>
                 </a:solidFill>
@@ -6730,23 +6730,23 @@
         <p:spPr>
           <a:xfrm>
             <a:off x="640080" y="457200"/>
-            <a:ext cx="7315200" cy="320040"/>
-          </a:xfrm>
-          <a:prstGeom prst="rect">
-            <a:avLst/>
-          </a:prstGeom>
-          <a:noFill/>
-          <a:ln/>
-        </p:spPr>
-        <p:txBody>
-          <a:bodyPr wrap="square" lIns="0" tIns="0" rIns="0" bIns="0" rtlCol="0" anchor="ctr"/>
-          <a:lstStyle/>
-          <a:p>
-            <a:pPr indent="0" marL="0">
-              <a:buNone/>
-            </a:pPr>
-            <a:r>
-              <a:rPr lang="en-US" sz="1200" b="1" spc="300" kern="0" dirty="0">
+            <a:ext cx="10515600" cy="320040"/>
+          </a:xfrm>
+          <a:prstGeom prst="rect">
+            <a:avLst/>
+          </a:prstGeom>
+          <a:noFill/>
+          <a:ln/>
+        </p:spPr>
+        <p:txBody>
+          <a:bodyPr wrap="square" lIns="0" tIns="0" rIns="0" bIns="0" rtlCol="0" anchor="ctr"/>
+          <a:lstStyle/>
+          <a:p>
+            <a:pPr indent="0" marL="0">
+              <a:buNone/>
+            </a:pPr>
+            <a:r>
+              <a:rPr lang="en-US" sz="1200" b="1" spc="200" kern="0" dirty="0">
                 <a:solidFill>
                   <a:srgbClr val="E5B23C"/>
                 </a:solidFill>
@@ -7101,23 +7101,23 @@
         <p:spPr>
           <a:xfrm>
             <a:off x="640080" y="457200"/>
-            <a:ext cx="7315200" cy="320040"/>
-          </a:xfrm>
-          <a:prstGeom prst="rect">
-            <a:avLst/>
-          </a:prstGeom>
-          <a:noFill/>
-          <a:ln/>
-        </p:spPr>
-        <p:txBody>
-          <a:bodyPr wrap="square" lIns="0" tIns="0" rIns="0" bIns="0" rtlCol="0" anchor="ctr"/>
-          <a:lstStyle/>
-          <a:p>
-            <a:pPr indent="0" marL="0">
-              <a:buNone/>
-            </a:pPr>
-            <a:r>
-              <a:rPr lang="en-US" sz="1200" b="1" spc="300" kern="0" dirty="0">
+            <a:ext cx="10515600" cy="320040"/>
+          </a:xfrm>
+          <a:prstGeom prst="rect">
+            <a:avLst/>
+          </a:prstGeom>
+          <a:noFill/>
+          <a:ln/>
+        </p:spPr>
+        <p:txBody>
+          <a:bodyPr wrap="square" lIns="0" tIns="0" rIns="0" bIns="0" rtlCol="0" anchor="ctr"/>
+          <a:lstStyle/>
+          <a:p>
+            <a:pPr indent="0" marL="0">
+              <a:buNone/>
+            </a:pPr>
+            <a:r>
+              <a:rPr lang="en-US" sz="1200" b="1" spc="200" kern="0" dirty="0">
                 <a:solidFill>
                   <a:srgbClr val="E5B23C"/>
                 </a:solidFill>
@@ -7250,23 +7250,23 @@
         <p:spPr>
           <a:xfrm>
             <a:off x="960120" y="2788920"/>
-            <a:ext cx="2926080" cy="457200"/>
-          </a:xfrm>
-          <a:prstGeom prst="rect">
-            <a:avLst/>
-          </a:prstGeom>
-          <a:noFill/>
-          <a:ln/>
-        </p:spPr>
-        <p:txBody>
-          <a:bodyPr wrap="square" lIns="0" tIns="0" rIns="0" bIns="0" rtlCol="0" anchor="ctr"/>
-          <a:lstStyle/>
-          <a:p>
-            <a:pPr indent="0" marL="0">
-              <a:buNone/>
-            </a:pPr>
-            <a:r>
-              <a:rPr lang="en-US" sz="1800" b="1" dirty="0">
+            <a:ext cx="3154680" cy="457200"/>
+          </a:xfrm>
+          <a:prstGeom prst="rect">
+            <a:avLst/>
+          </a:prstGeom>
+          <a:noFill/>
+          <a:ln/>
+        </p:spPr>
+        <p:txBody>
+          <a:bodyPr wrap="square" lIns="0" tIns="0" rIns="0" bIns="0" rtlCol="0" anchor="ctr"/>
+          <a:lstStyle/>
+          <a:p>
+            <a:pPr indent="0" marL="0">
+              <a:buNone/>
+            </a:pPr>
+            <a:r>
+              <a:rPr lang="en-US" sz="1600" b="1" dirty="0">
                 <a:solidFill>
                   <a:srgbClr val="0B3D54"/>
                 </a:solidFill>
@@ -7276,7 +7276,7 @@
               </a:rPr>
               <a:t>Оқушылар мен студенттер</a:t>
             </a:r>
-            <a:endParaRPr lang="en-US" sz="1800" dirty="0"/>
+            <a:endParaRPr lang="en-US" sz="1600" dirty="0"/>
           </a:p>
         </p:txBody>
       </p:sp>
@@ -7288,8 +7288,8 @@
         </p:nvSpPr>
         <p:spPr>
           <a:xfrm>
-            <a:off x="960120" y="3154680"/>
-            <a:ext cx="2971800" cy="548640"/>
+            <a:off x="960120" y="3246120"/>
+            <a:ext cx="3154680" cy="548640"/>
           </a:xfrm>
           <a:prstGeom prst="rect">
             <a:avLst/>
@@ -7308,7 +7308,7 @@
               <a:buNone/>
             </a:pPr>
             <a:r>
-              <a:rPr lang="en-US" sz="1300" dirty="0">
+              <a:rPr lang="en-US" sz="1250" dirty="0">
                 <a:solidFill>
                   <a:srgbClr val="5E6B72"/>
                 </a:solidFill>
@@ -7318,7 +7318,7 @@
               </a:rPr>
               <a:t>Тарих пен әдебиетке қызығатын жастар</a:t>
             </a:r>
-            <a:endParaRPr lang="en-US" sz="1300" dirty="0"/>
+            <a:endParaRPr lang="en-US" sz="1250" dirty="0"/>
           </a:p>
         </p:txBody>
       </p:sp>
@@ -7402,23 +7402,23 @@
         <p:spPr>
           <a:xfrm>
             <a:off x="4681728" y="2788920"/>
-            <a:ext cx="2926080" cy="457200"/>
-          </a:xfrm>
-          <a:prstGeom prst="rect">
-            <a:avLst/>
-          </a:prstGeom>
-          <a:noFill/>
-          <a:ln/>
-        </p:spPr>
-        <p:txBody>
-          <a:bodyPr wrap="square" lIns="0" tIns="0" rIns="0" bIns="0" rtlCol="0" anchor="ctr"/>
-          <a:lstStyle/>
-          <a:p>
-            <a:pPr indent="0" marL="0">
-              <a:buNone/>
-            </a:pPr>
-            <a:r>
-              <a:rPr lang="en-US" sz="1800" b="1" dirty="0">
+            <a:ext cx="3154680" cy="457200"/>
+          </a:xfrm>
+          <a:prstGeom prst="rect">
+            <a:avLst/>
+          </a:prstGeom>
+          <a:noFill/>
+          <a:ln/>
+        </p:spPr>
+        <p:txBody>
+          <a:bodyPr wrap="square" lIns="0" tIns="0" rIns="0" bIns="0" rtlCol="0" anchor="ctr"/>
+          <a:lstStyle/>
+          <a:p>
+            <a:pPr indent="0" marL="0">
+              <a:buNone/>
+            </a:pPr>
+            <a:r>
+              <a:rPr lang="en-US" sz="1600" b="1" dirty="0">
                 <a:solidFill>
                   <a:srgbClr val="0B3D54"/>
                 </a:solidFill>
@@ -7428,7 +7428,7 @@
               </a:rPr>
               <a:t>Қосымша білім</a:t>
             </a:r>
-            <a:endParaRPr lang="en-US" sz="1800" dirty="0"/>
+            <a:endParaRPr lang="en-US" sz="1600" dirty="0"/>
           </a:p>
         </p:txBody>
       </p:sp>
@@ -7440,8 +7440,8 @@
         </p:nvSpPr>
         <p:spPr>
           <a:xfrm>
-            <a:off x="4681728" y="3154680"/>
-            <a:ext cx="2971800" cy="548640"/>
+            <a:off x="4681728" y="3246120"/>
+            <a:ext cx="3154680" cy="548640"/>
           </a:xfrm>
           <a:prstGeom prst="rect">
             <a:avLst/>
@@ -7460,7 +7460,7 @@
               <a:buNone/>
             </a:pPr>
             <a:r>
-              <a:rPr lang="en-US" sz="1300" dirty="0">
+              <a:rPr lang="en-US" sz="1250" dirty="0">
                 <a:solidFill>
                   <a:srgbClr val="5E6B72"/>
                 </a:solidFill>
@@ -7470,7 +7470,7 @@
               </a:rPr>
               <a:t>Тарих және әдебиет бойынша курстар, орталықтар</a:t>
             </a:r>
-            <a:endParaRPr lang="en-US" sz="1300" dirty="0"/>
+            <a:endParaRPr lang="en-US" sz="1250" dirty="0"/>
           </a:p>
         </p:txBody>
       </p:sp>
@@ -7554,23 +7554,23 @@
         <p:spPr>
           <a:xfrm>
             <a:off x="8403336" y="2788920"/>
-            <a:ext cx="2926080" cy="457200"/>
-          </a:xfrm>
-          <a:prstGeom prst="rect">
-            <a:avLst/>
-          </a:prstGeom>
-          <a:noFill/>
-          <a:ln/>
-        </p:spPr>
-        <p:txBody>
-          <a:bodyPr wrap="square" lIns="0" tIns="0" rIns="0" bIns="0" rtlCol="0" anchor="ctr"/>
-          <a:lstStyle/>
-          <a:p>
-            <a:pPr indent="0" marL="0">
-              <a:buNone/>
-            </a:pPr>
-            <a:r>
-              <a:rPr lang="en-US" sz="1800" b="1" dirty="0">
+            <a:ext cx="3154680" cy="457200"/>
+          </a:xfrm>
+          <a:prstGeom prst="rect">
+            <a:avLst/>
+          </a:prstGeom>
+          <a:noFill/>
+          <a:ln/>
+        </p:spPr>
+        <p:txBody>
+          <a:bodyPr wrap="square" lIns="0" tIns="0" rIns="0" bIns="0" rtlCol="0" anchor="ctr"/>
+          <a:lstStyle/>
+          <a:p>
+            <a:pPr indent="0" marL="0">
+              <a:buNone/>
+            </a:pPr>
+            <a:r>
+              <a:rPr lang="en-US" sz="1600" b="1" dirty="0">
                 <a:solidFill>
                   <a:srgbClr val="0B3D54"/>
                 </a:solidFill>
@@ -7580,7 +7580,7 @@
               </a:rPr>
               <a:t>Мұғалімдер</a:t>
             </a:r>
-            <a:endParaRPr lang="en-US" sz="1800" dirty="0"/>
+            <a:endParaRPr lang="en-US" sz="1600" dirty="0"/>
           </a:p>
         </p:txBody>
       </p:sp>
@@ -7592,8 +7592,8 @@
         </p:nvSpPr>
         <p:spPr>
           <a:xfrm>
-            <a:off x="8403336" y="3154680"/>
-            <a:ext cx="2971800" cy="548640"/>
+            <a:off x="8403336" y="3246120"/>
+            <a:ext cx="3154680" cy="548640"/>
           </a:xfrm>
           <a:prstGeom prst="rect">
             <a:avLst/>
@@ -7612,7 +7612,7 @@
               <a:buNone/>
             </a:pPr>
             <a:r>
-              <a:rPr lang="en-US" sz="1300" dirty="0">
+              <a:rPr lang="en-US" sz="1250" dirty="0">
                 <a:solidFill>
                   <a:srgbClr val="5E6B72"/>
                 </a:solidFill>
@@ -7622,7 +7622,7 @@
               </a:rPr>
               <a:t>Сабақты қызықты өткізудің цифрлық құралы</a:t>
             </a:r>
-            <a:endParaRPr lang="en-US" sz="1300" dirty="0"/>
+            <a:endParaRPr lang="en-US" sz="1250" dirty="0"/>
           </a:p>
         </p:txBody>
       </p:sp>
@@ -8063,23 +8063,23 @@
         <p:spPr>
           <a:xfrm>
             <a:off x="640080" y="457200"/>
-            <a:ext cx="7315200" cy="320040"/>
-          </a:xfrm>
-          <a:prstGeom prst="rect">
-            <a:avLst/>
-          </a:prstGeom>
-          <a:noFill/>
-          <a:ln/>
-        </p:spPr>
-        <p:txBody>
-          <a:bodyPr wrap="square" lIns="0" tIns="0" rIns="0" bIns="0" rtlCol="0" anchor="ctr"/>
-          <a:lstStyle/>
-          <a:p>
-            <a:pPr indent="0" marL="0">
-              <a:buNone/>
-            </a:pPr>
-            <a:r>
-              <a:rPr lang="en-US" sz="1200" b="1" spc="300" kern="0" dirty="0">
+            <a:ext cx="10515600" cy="320040"/>
+          </a:xfrm>
+          <a:prstGeom prst="rect">
+            <a:avLst/>
+          </a:prstGeom>
+          <a:noFill/>
+          <a:ln/>
+        </p:spPr>
+        <p:txBody>
+          <a:bodyPr wrap="square" lIns="0" tIns="0" rIns="0" bIns="0" rtlCol="0" anchor="ctr"/>
+          <a:lstStyle/>
+          <a:p>
+            <a:pPr indent="0" marL="0">
+              <a:buNone/>
+            </a:pPr>
+            <a:r>
+              <a:rPr lang="en-US" sz="1200" b="1" spc="200" kern="0" dirty="0">
                 <a:solidFill>
                   <a:srgbClr val="E5B23C"/>
                 </a:solidFill>
@@ -8217,23 +8217,23 @@
         <p:spPr>
           <a:xfrm>
             <a:off x="1965960" y="1965960"/>
-            <a:ext cx="3840480" cy="411480"/>
-          </a:xfrm>
-          <a:prstGeom prst="rect">
-            <a:avLst/>
-          </a:prstGeom>
-          <a:noFill/>
-          <a:ln/>
-        </p:spPr>
-        <p:txBody>
-          <a:bodyPr wrap="square" lIns="0" tIns="0" rIns="0" bIns="0" rtlCol="0" anchor="ctr"/>
-          <a:lstStyle/>
-          <a:p>
-            <a:pPr indent="0" marL="0">
-              <a:buNone/>
-            </a:pPr>
-            <a:r>
-              <a:rPr lang="en-US" sz="1700" b="1" dirty="0">
+            <a:ext cx="3931920" cy="411480"/>
+          </a:xfrm>
+          <a:prstGeom prst="rect">
+            <a:avLst/>
+          </a:prstGeom>
+          <a:noFill/>
+          <a:ln/>
+        </p:spPr>
+        <p:txBody>
+          <a:bodyPr wrap="square" lIns="0" tIns="0" rIns="0" bIns="0" rtlCol="0" anchor="ctr"/>
+          <a:lstStyle/>
+          <a:p>
+            <a:pPr indent="0" marL="0">
+              <a:buNone/>
+            </a:pPr>
+            <a:r>
+              <a:rPr lang="en-US" sz="1550" b="1" dirty="0">
                 <a:solidFill>
                   <a:srgbClr val="0B3D54"/>
                 </a:solidFill>
@@ -8243,7 +8243,7 @@
               </a:rPr>
               <a:t>Заманауи веб-технологиялар</a:t>
             </a:r>
-            <a:endParaRPr lang="en-US" sz="1700" dirty="0"/>
+            <a:endParaRPr lang="en-US" sz="1550" dirty="0"/>
           </a:p>
         </p:txBody>
       </p:sp>
@@ -8256,7 +8256,7 @@
         <p:spPr>
           <a:xfrm>
             <a:off x="1965960" y="2350008"/>
-            <a:ext cx="3840480" cy="777240"/>
+            <a:ext cx="3931920" cy="777240"/>
           </a:xfrm>
           <a:prstGeom prst="rect">
             <a:avLst/>
@@ -8275,7 +8275,7 @@
               <a:buNone/>
             </a:pPr>
             <a:r>
-              <a:rPr lang="en-US" sz="1250" dirty="0">
+              <a:rPr lang="en-US" sz="1200" dirty="0">
                 <a:solidFill>
                   <a:srgbClr val="1A2A33"/>
                 </a:solidFill>
@@ -8285,7 +8285,7 @@
               </a:rPr>
               <a:t>Clean Architecture және SOLID принциптері. MVP үшін домендік бөлінісі бар модульді монолит.</a:t>
             </a:r>
-            <a:endParaRPr lang="en-US" sz="1250" dirty="0"/>
+            <a:endParaRPr lang="en-US" sz="1200" dirty="0"/>
           </a:p>
         </p:txBody>
       </p:sp>
@@ -8374,23 +8374,23 @@
         <p:spPr>
           <a:xfrm>
             <a:off x="7543800" y="1965960"/>
-            <a:ext cx="3840480" cy="411480"/>
-          </a:xfrm>
-          <a:prstGeom prst="rect">
-            <a:avLst/>
-          </a:prstGeom>
-          <a:noFill/>
-          <a:ln/>
-        </p:spPr>
-        <p:txBody>
-          <a:bodyPr wrap="square" lIns="0" tIns="0" rIns="0" bIns="0" rtlCol="0" anchor="ctr"/>
-          <a:lstStyle/>
-          <a:p>
-            <a:pPr indent="0" marL="0">
-              <a:buNone/>
-            </a:pPr>
-            <a:r>
-              <a:rPr lang="en-US" sz="1700" b="1" dirty="0">
+            <a:ext cx="3931920" cy="411480"/>
+          </a:xfrm>
+          <a:prstGeom prst="rect">
+            <a:avLst/>
+          </a:prstGeom>
+          <a:noFill/>
+          <a:ln/>
+        </p:spPr>
+        <p:txBody>
+          <a:bodyPr wrap="square" lIns="0" tIns="0" rIns="0" bIns="0" rtlCol="0" anchor="ctr"/>
+          <a:lstStyle/>
+          <a:p>
+            <a:pPr indent="0" marL="0">
+              <a:buNone/>
+            </a:pPr>
+            <a:r>
+              <a:rPr lang="en-US" sz="1550" b="1" dirty="0">
                 <a:solidFill>
                   <a:srgbClr val="0B3D54"/>
                 </a:solidFill>
@@ -8400,7 +8400,7 @@
               </a:rPr>
               <a:t>Сенімді ДҚБЖ</a:t>
             </a:r>
-            <a:endParaRPr lang="en-US" sz="1700" dirty="0"/>
+            <a:endParaRPr lang="en-US" sz="1550" dirty="0"/>
           </a:p>
         </p:txBody>
       </p:sp>
@@ -8413,7 +8413,7 @@
         <p:spPr>
           <a:xfrm>
             <a:off x="7543800" y="2350008"/>
-            <a:ext cx="3840480" cy="777240"/>
+            <a:ext cx="3931920" cy="777240"/>
           </a:xfrm>
           <a:prstGeom prst="rect">
             <a:avLst/>
@@ -8432,7 +8432,7 @@
               <a:buNone/>
             </a:pPr>
             <a:r>
-              <a:rPr lang="en-US" sz="1250" dirty="0">
+              <a:rPr lang="en-US" sz="1200" dirty="0">
                 <a:solidFill>
                   <a:srgbClr val="1A2A33"/>
                 </a:solidFill>
@@ -8442,7 +8442,7 @@
               </a:rPr>
               <a:t>Тарихи деректермен жұмыстың домендік логикасы реляциялық дерекқормен инкапсуляцияланған.</a:t>
             </a:r>
-            <a:endParaRPr lang="en-US" sz="1250" dirty="0"/>
+            <a:endParaRPr lang="en-US" sz="1200" dirty="0"/>
           </a:p>
         </p:txBody>
       </p:sp>
@@ -8531,23 +8531,23 @@
         <p:spPr>
           <a:xfrm>
             <a:off x="1965960" y="3566160"/>
-            <a:ext cx="3840480" cy="411480"/>
-          </a:xfrm>
-          <a:prstGeom prst="rect">
-            <a:avLst/>
-          </a:prstGeom>
-          <a:noFill/>
-          <a:ln/>
-        </p:spPr>
-        <p:txBody>
-          <a:bodyPr wrap="square" lIns="0" tIns="0" rIns="0" bIns="0" rtlCol="0" anchor="ctr"/>
-          <a:lstStyle/>
-          <a:p>
-            <a:pPr indent="0" marL="0">
-              <a:buNone/>
-            </a:pPr>
-            <a:r>
-              <a:rPr lang="en-US" sz="1700" b="1" dirty="0">
+            <a:ext cx="3931920" cy="411480"/>
+          </a:xfrm>
+          <a:prstGeom prst="rect">
+            <a:avLst/>
+          </a:prstGeom>
+          <a:noFill/>
+          <a:ln/>
+        </p:spPr>
+        <p:txBody>
+          <a:bodyPr wrap="square" lIns="0" tIns="0" rIns="0" bIns="0" rtlCol="0" anchor="ctr"/>
+          <a:lstStyle/>
+          <a:p>
+            <a:pPr indent="0" marL="0">
+              <a:buNone/>
+            </a:pPr>
+            <a:r>
+              <a:rPr lang="en-US" sz="1550" b="1" dirty="0">
                 <a:solidFill>
                   <a:srgbClr val="0B3D54"/>
                 </a:solidFill>
@@ -8557,7 +8557,7 @@
               </a:rPr>
               <a:t>LLM интеграциясы</a:t>
             </a:r>
-            <a:endParaRPr lang="en-US" sz="1700" dirty="0"/>
+            <a:endParaRPr lang="en-US" sz="1550" dirty="0"/>
           </a:p>
         </p:txBody>
       </p:sp>
@@ -8570,7 +8570,7 @@
         <p:spPr>
           <a:xfrm>
             <a:off x="1965960" y="3950208"/>
-            <a:ext cx="3840480" cy="777240"/>
+            <a:ext cx="3931920" cy="777240"/>
           </a:xfrm>
           <a:prstGeom prst="rect">
             <a:avLst/>
@@ -8589,7 +8589,7 @@
               <a:buNone/>
             </a:pPr>
             <a:r>
-              <a:rPr lang="en-US" sz="1250" dirty="0">
+              <a:rPr lang="en-US" sz="1200" dirty="0">
                 <a:solidFill>
                   <a:srgbClr val="1A2A33"/>
                 </a:solidFill>
@@ -8599,7 +8599,7 @@
               </a:rPr>
               <a:t>OpenAI / Anthropic / Groq API жеке инфрақұрылым қабатында - vendor lock-in минималды, миграция оңай.</a:t>
             </a:r>
-            <a:endParaRPr lang="en-US" sz="1250" dirty="0"/>
+            <a:endParaRPr lang="en-US" sz="1200" dirty="0"/>
           </a:p>
         </p:txBody>
       </p:sp>
@@ -8688,23 +8688,23 @@
         <p:spPr>
           <a:xfrm>
             <a:off x="7543800" y="3566160"/>
-            <a:ext cx="3840480" cy="411480"/>
-          </a:xfrm>
-          <a:prstGeom prst="rect">
-            <a:avLst/>
-          </a:prstGeom>
-          <a:noFill/>
-          <a:ln/>
-        </p:spPr>
-        <p:txBody>
-          <a:bodyPr wrap="square" lIns="0" tIns="0" rIns="0" bIns="0" rtlCol="0" anchor="ctr"/>
-          <a:lstStyle/>
-          <a:p>
-            <a:pPr indent="0" marL="0">
-              <a:buNone/>
-            </a:pPr>
-            <a:r>
-              <a:rPr lang="en-US" sz="1700" b="1" dirty="0">
+            <a:ext cx="3931920" cy="411480"/>
+          </a:xfrm>
+          <a:prstGeom prst="rect">
+            <a:avLst/>
+          </a:prstGeom>
+          <a:noFill/>
+          <a:ln/>
+        </p:spPr>
+        <p:txBody>
+          <a:bodyPr wrap="square" lIns="0" tIns="0" rIns="0" bIns="0" rtlCol="0" anchor="ctr"/>
+          <a:lstStyle/>
+          <a:p>
+            <a:pPr indent="0" marL="0">
+              <a:buNone/>
+            </a:pPr>
+            <a:r>
+              <a:rPr lang="en-US" sz="1550" b="1" dirty="0">
                 <a:solidFill>
                   <a:srgbClr val="0B3D54"/>
                 </a:solidFill>
@@ -8714,7 +8714,7 @@
               </a:rPr>
               <a:t>Масштабталу</a:t>
             </a:r>
-            <a:endParaRPr lang="en-US" sz="1700" dirty="0"/>
+            <a:endParaRPr lang="en-US" sz="1550" dirty="0"/>
           </a:p>
         </p:txBody>
       </p:sp>
@@ -8727,7 +8727,7 @@
         <p:spPr>
           <a:xfrm>
             <a:off x="7543800" y="3950208"/>
-            <a:ext cx="3840480" cy="777240"/>
+            <a:ext cx="3931920" cy="777240"/>
           </a:xfrm>
           <a:prstGeom prst="rect">
             <a:avLst/>
@@ -8746,7 +8746,7 @@
               <a:buNone/>
             </a:pPr>
             <a:r>
-              <a:rPr lang="en-US" sz="1250" dirty="0">
+              <a:rPr lang="en-US" sz="1200" dirty="0">
                 <a:solidFill>
                   <a:srgbClr val="1A2A33"/>
                 </a:solidFill>
@@ -8756,7 +8756,7 @@
               </a:rPr>
               <a:t>REST API; жүктеме өскенде микросервистік архитектураға дейін кеңейтуге есептелген.</a:t>
             </a:r>
-            <a:endParaRPr lang="en-US" sz="1250" dirty="0"/>
+            <a:endParaRPr lang="en-US" sz="1200" dirty="0"/>
           </a:p>
         </p:txBody>
       </p:sp>
@@ -8852,7 +8852,7 @@
               <a:buNone/>
             </a:pPr>
             <a:r>
-              <a:rPr lang="en-US" sz="1350" b="1" dirty="0">
+              <a:rPr lang="en-US" sz="1250" b="1" dirty="0">
                 <a:solidFill>
                   <a:srgbClr val="E5B23C"/>
                 </a:solidFill>
@@ -8869,7 +8869,7 @@
               <a:buNone/>
             </a:pPr>
             <a:r>
-              <a:rPr lang="en-US" sz="1350" dirty="0">
+              <a:rPr lang="en-US" sz="1250" dirty="0">
                 <a:solidFill>
                   <a:srgbClr val="F6F2E9"/>
                 </a:solidFill>
@@ -8879,7 +8879,7 @@
               </a:rPr>
               <a:t>ҚР ПІБ МТҚБ Инженерлік орталығының бас бағдарламашысы, техника ғылымдарының магистрі. ПО әзірлеудің толық циклін басқару тәжірибесі.</a:t>
             </a:r>
-            <a:endParaRPr lang="en-US" sz="1350" dirty="0"/>
+            <a:endParaRPr lang="en-US" sz="1250" dirty="0"/>
           </a:p>
         </p:txBody>
       </p:sp>
@@ -9002,23 +9002,23 @@
         <p:spPr>
           <a:xfrm>
             <a:off x="640080" y="457200"/>
-            <a:ext cx="7315200" cy="320040"/>
-          </a:xfrm>
-          <a:prstGeom prst="rect">
-            <a:avLst/>
-          </a:prstGeom>
-          <a:noFill/>
-          <a:ln/>
-        </p:spPr>
-        <p:txBody>
-          <a:bodyPr wrap="square" lIns="0" tIns="0" rIns="0" bIns="0" rtlCol="0" anchor="ctr"/>
-          <a:lstStyle/>
-          <a:p>
-            <a:pPr indent="0" marL="0">
-              <a:buNone/>
-            </a:pPr>
-            <a:r>
-              <a:rPr lang="en-US" sz="1200" b="1" spc="300" kern="0" dirty="0">
+            <a:ext cx="10515600" cy="320040"/>
+          </a:xfrm>
+          <a:prstGeom prst="rect">
+            <a:avLst/>
+          </a:prstGeom>
+          <a:noFill/>
+          <a:ln/>
+        </p:spPr>
+        <p:txBody>
+          <a:bodyPr wrap="square" lIns="0" tIns="0" rIns="0" bIns="0" rtlCol="0" anchor="ctr"/>
+          <a:lstStyle/>
+          <a:p>
+            <a:pPr indent="0" marL="0">
+              <a:buNone/>
+            </a:pPr>
+            <a:r>
+              <a:rPr lang="en-US" sz="1200" b="1" spc="200" kern="0" dirty="0">
                 <a:solidFill>
                   <a:srgbClr val="E5B23C"/>
                 </a:solidFill>

</xml_diff>

<commit_message>
docs(presentation): real AI-chat screenshots + fix slide overflow
- Regenerate chat screenshots showing an actual Kazakh dialogue with
  Al-Farabi (mocked responses via headless Chrome, real chat UI)
- Fix detail-panel screenshot aspect ratio (was distorted) and re-crop
  to remove Marvel test-data contemporaries
- Slide 5/6: fix captions overflowing slide bottom
- Redesign slide 6: conversation as hero + feature points
- Add shoot-chat.js (reproducible chat screenshots), .gitignore for render artifacts

Co-Authored-By: Claude Opus 4.8 <noreply@anthropic.com>
</commit_message>
<xml_diff>
--- a/grant-presentation/Tarixi-Timeline_Tauelsizdik_urpaqtary.pptx
+++ b/grant-presentation/Tarixi-Timeline_Tauelsizdik_urpaqtary.pptx
@@ -1788,9 +1788,9 @@
                 <a:solidFill>
                   <a:srgbClr val="FFFFFF"/>
                 </a:solidFill>
-                <a:latin typeface="Georgia" pitchFamily="34" charset="0"/>
-                <a:ea typeface="Georgia" pitchFamily="34" charset="-122"/>
-                <a:cs typeface="Georgia" pitchFamily="34" charset="-120"/>
+                <a:latin typeface="Times New Roman" pitchFamily="34" charset="0"/>
+                <a:ea typeface="Times New Roman" pitchFamily="34" charset="-122"/>
+                <a:cs typeface="Times New Roman" pitchFamily="34" charset="-120"/>
               </a:rPr>
               <a:t>Tarixi-Timeline</a:t>
             </a:r>
@@ -2250,9 +2250,9 @@
                 <a:solidFill>
                   <a:srgbClr val="FFFFFF"/>
                 </a:solidFill>
-                <a:latin typeface="Georgia" pitchFamily="34" charset="0"/>
-                <a:ea typeface="Georgia" pitchFamily="34" charset="-122"/>
-                <a:cs typeface="Georgia" pitchFamily="34" charset="-120"/>
+                <a:latin typeface="Times New Roman" pitchFamily="34" charset="0"/>
+                <a:ea typeface="Times New Roman" pitchFamily="34" charset="-122"/>
+                <a:cs typeface="Times New Roman" pitchFamily="34" charset="-120"/>
               </a:rPr>
               <a:t>MVP-ден ұлттық платформаға дейін</a:t>
             </a:r>
@@ -2451,9 +2451,9 @@
                 <a:solidFill>
                   <a:srgbClr val="FFFFFF"/>
                 </a:solidFill>
-                <a:latin typeface="Georgia" pitchFamily="34" charset="0"/>
-                <a:ea typeface="Georgia" pitchFamily="34" charset="-122"/>
-                <a:cs typeface="Georgia" pitchFamily="34" charset="-120"/>
+                <a:latin typeface="Times New Roman" pitchFamily="34" charset="0"/>
+                <a:ea typeface="Times New Roman" pitchFamily="34" charset="-122"/>
+                <a:cs typeface="Times New Roman" pitchFamily="34" charset="-120"/>
               </a:rPr>
               <a:t>Іргетас</a:t>
             </a:r>
@@ -2611,9 +2611,9 @@
                 <a:solidFill>
                   <a:srgbClr val="FFFFFF"/>
                 </a:solidFill>
-                <a:latin typeface="Georgia" pitchFamily="34" charset="0"/>
-                <a:ea typeface="Georgia" pitchFamily="34" charset="-122"/>
-                <a:cs typeface="Georgia" pitchFamily="34" charset="-120"/>
+                <a:latin typeface="Times New Roman" pitchFamily="34" charset="0"/>
+                <a:ea typeface="Times New Roman" pitchFamily="34" charset="-122"/>
+                <a:cs typeface="Times New Roman" pitchFamily="34" charset="-120"/>
               </a:rPr>
               <a:t>ИИ-чат</a:t>
             </a:r>
@@ -2771,9 +2771,9 @@
                 <a:solidFill>
                   <a:srgbClr val="FFFFFF"/>
                 </a:solidFill>
-                <a:latin typeface="Georgia" pitchFamily="34" charset="0"/>
-                <a:ea typeface="Georgia" pitchFamily="34" charset="-122"/>
-                <a:cs typeface="Georgia" pitchFamily="34" charset="-120"/>
+                <a:latin typeface="Times New Roman" pitchFamily="34" charset="0"/>
+                <a:ea typeface="Times New Roman" pitchFamily="34" charset="-122"/>
+                <a:cs typeface="Times New Roman" pitchFamily="34" charset="-120"/>
               </a:rPr>
               <a:t>MVP</a:t>
             </a:r>
@@ -2931,9 +2931,9 @@
                 <a:solidFill>
                   <a:srgbClr val="FFFFFF"/>
                 </a:solidFill>
-                <a:latin typeface="Georgia" pitchFamily="34" charset="0"/>
-                <a:ea typeface="Georgia" pitchFamily="34" charset="-122"/>
-                <a:cs typeface="Georgia" pitchFamily="34" charset="-120"/>
+                <a:latin typeface="Times New Roman" pitchFamily="34" charset="0"/>
+                <a:ea typeface="Times New Roman" pitchFamily="34" charset="-122"/>
+                <a:cs typeface="Times New Roman" pitchFamily="34" charset="-120"/>
               </a:rPr>
               <a:t>Іске қосу</a:t>
             </a:r>
@@ -3103,9 +3103,9 @@
                 <a:solidFill>
                   <a:srgbClr val="0B3D54"/>
                 </a:solidFill>
-                <a:latin typeface="Georgia" pitchFamily="34" charset="0"/>
-                <a:ea typeface="Georgia" pitchFamily="34" charset="-122"/>
-                <a:cs typeface="Georgia" pitchFamily="34" charset="-120"/>
+                <a:latin typeface="Times New Roman" pitchFamily="34" charset="0"/>
+                <a:ea typeface="Times New Roman" pitchFamily="34" charset="-122"/>
+                <a:cs typeface="Times New Roman" pitchFamily="34" charset="-120"/>
               </a:rPr>
               <a:t>Келесі маңызды қадам: Интерактивті тарихи карта</a:t>
             </a:r>
@@ -3204,9 +3204,9 @@
                 <a:solidFill>
                   <a:srgbClr val="0B3D54"/>
                 </a:solidFill>
-                <a:latin typeface="Georgia" pitchFamily="34" charset="0"/>
-                <a:ea typeface="Georgia" pitchFamily="34" charset="-122"/>
-                <a:cs typeface="Georgia" pitchFamily="34" charset="-120"/>
+                <a:latin typeface="Times New Roman" pitchFamily="34" charset="0"/>
+                <a:ea typeface="Times New Roman" pitchFamily="34" charset="-122"/>
+                <a:cs typeface="Times New Roman" pitchFamily="34" charset="-120"/>
               </a:rPr>
               <a:t>Тарихты жаттатпай, сүйдіретін платформа.</a:t>
             </a:r>
@@ -3376,6 +3376,84 @@
               <a:t>github.com/bekarazhan/tarixi-timeline</a:t>
             </a:r>
             <a:endParaRPr lang="en-US" sz="1100" dirty="0"/>
+          </a:p>
+        </p:txBody>
+      </p:sp>
+      <p:sp>
+        <p:nvSpPr>
+          <p:cNvPr id="38" name="Text 33"/>
+          <p:cNvSpPr/>
+          <p:nvPr/>
+        </p:nvSpPr>
+        <p:spPr>
+          <a:xfrm>
+            <a:off x="10728655" y="6355080"/>
+            <a:ext cx="1005840" cy="274320"/>
+          </a:xfrm>
+          <a:prstGeom prst="rect">
+            <a:avLst/>
+          </a:prstGeom>
+          <a:noFill/>
+          <a:ln/>
+        </p:spPr>
+        <p:txBody>
+          <a:bodyPr wrap="square" lIns="0" tIns="0" rIns="0" bIns="0" rtlCol="0" anchor="ctr"/>
+          <a:lstStyle/>
+          <a:p>
+            <a:pPr algn="r" indent="0" marL="0">
+              <a:buNone/>
+            </a:pPr>
+            <a:r>
+              <a:rPr lang="en-US" sz="1000" dirty="0">
+                <a:solidFill>
+                  <a:srgbClr val="F6F2E9"/>
+                </a:solidFill>
+                <a:latin typeface="Calibri" pitchFamily="34" charset="0"/>
+                <a:ea typeface="Calibri" pitchFamily="34" charset="-122"/>
+                <a:cs typeface="Calibri" pitchFamily="34" charset="-120"/>
+              </a:rPr>
+              <a:t>10 / 10</a:t>
+            </a:r>
+            <a:endParaRPr lang="en-US" sz="1000" dirty="0"/>
+          </a:p>
+        </p:txBody>
+      </p:sp>
+      <p:sp>
+        <p:nvSpPr>
+          <p:cNvPr id="39" name="Text 34"/>
+          <p:cNvSpPr/>
+          <p:nvPr/>
+        </p:nvSpPr>
+        <p:spPr>
+          <a:xfrm>
+            <a:off x="640080" y="6355080"/>
+            <a:ext cx="3657600" cy="274320"/>
+          </a:xfrm>
+          <a:prstGeom prst="rect">
+            <a:avLst/>
+          </a:prstGeom>
+          <a:noFill/>
+          <a:ln/>
+        </p:spPr>
+        <p:txBody>
+          <a:bodyPr wrap="square" lIns="0" tIns="0" rIns="0" bIns="0" rtlCol="0" anchor="ctr"/>
+          <a:lstStyle/>
+          <a:p>
+            <a:pPr indent="0" marL="0">
+              <a:buNone/>
+            </a:pPr>
+            <a:r>
+              <a:rPr lang="en-US" sz="1000" dirty="0">
+                <a:solidFill>
+                  <a:srgbClr val="F6F2E9"/>
+                </a:solidFill>
+                <a:latin typeface="Calibri" pitchFamily="34" charset="0"/>
+                <a:ea typeface="Calibri" pitchFamily="34" charset="-122"/>
+                <a:cs typeface="Calibri" pitchFamily="34" charset="-120"/>
+              </a:rPr>
+              <a:t>Tarixi-Timeline</a:t>
+            </a:r>
+            <a:endParaRPr lang="en-US" sz="1000" dirty="0"/>
           </a:p>
         </p:txBody>
       </p:sp>
@@ -3479,9 +3557,9 @@
                 <a:solidFill>
                   <a:srgbClr val="0B3D54"/>
                 </a:solidFill>
-                <a:latin typeface="Georgia" pitchFamily="34" charset="0"/>
-                <a:ea typeface="Georgia" pitchFamily="34" charset="-122"/>
-                <a:cs typeface="Georgia" pitchFamily="34" charset="-120"/>
+                <a:latin typeface="Times New Roman" pitchFamily="34" charset="0"/>
+                <a:ea typeface="Times New Roman" pitchFamily="34" charset="-122"/>
+                <a:cs typeface="Times New Roman" pitchFamily="34" charset="-120"/>
               </a:rPr>
               <a:t>Тарих жаттауға айналды, түсінуге емес</a:t>
             </a:r>
@@ -3716,9 +3794,9 @@
                 <a:solidFill>
                   <a:srgbClr val="0B3D54"/>
                 </a:solidFill>
-                <a:latin typeface="Georgia" pitchFamily="34" charset="0"/>
-                <a:ea typeface="Georgia" pitchFamily="34" charset="-122"/>
-                <a:cs typeface="Georgia" pitchFamily="34" charset="-120"/>
+                <a:latin typeface="Times New Roman" pitchFamily="34" charset="0"/>
+                <a:ea typeface="Times New Roman" pitchFamily="34" charset="-122"/>
+                <a:cs typeface="Times New Roman" pitchFamily="34" charset="-120"/>
               </a:rPr>
               <a:t>Жаттау</a:t>
             </a:r>
@@ -3870,9 +3948,9 @@
                 <a:solidFill>
                   <a:srgbClr val="0B3D54"/>
                 </a:solidFill>
-                <a:latin typeface="Georgia" pitchFamily="34" charset="0"/>
-                <a:ea typeface="Georgia" pitchFamily="34" charset="-122"/>
-                <a:cs typeface="Georgia" pitchFamily="34" charset="-120"/>
+                <a:latin typeface="Times New Roman" pitchFamily="34" charset="0"/>
+                <a:ea typeface="Times New Roman" pitchFamily="34" charset="-122"/>
+                <a:cs typeface="Times New Roman" pitchFamily="34" charset="-120"/>
               </a:rPr>
               <a:t>Төмен қызығушылық</a:t>
             </a:r>
@@ -4024,9 +4102,9 @@
                 <a:solidFill>
                   <a:srgbClr val="0B3D54"/>
                 </a:solidFill>
-                <a:latin typeface="Georgia" pitchFamily="34" charset="0"/>
-                <a:ea typeface="Georgia" pitchFamily="34" charset="-122"/>
-                <a:cs typeface="Georgia" pitchFamily="34" charset="-120"/>
+                <a:latin typeface="Times New Roman" pitchFamily="34" charset="0"/>
+                <a:ea typeface="Times New Roman" pitchFamily="34" charset="-122"/>
+                <a:cs typeface="Times New Roman" pitchFamily="34" charset="-120"/>
               </a:rPr>
               <a:t>Фрагментті білім</a:t>
             </a:r>
@@ -4251,9 +4329,9 @@
                 <a:solidFill>
                   <a:srgbClr val="FFFFFF"/>
                 </a:solidFill>
-                <a:latin typeface="Georgia" pitchFamily="34" charset="0"/>
-                <a:ea typeface="Georgia" pitchFamily="34" charset="-122"/>
-                <a:cs typeface="Georgia" pitchFamily="34" charset="-120"/>
+                <a:latin typeface="Times New Roman" pitchFamily="34" charset="0"/>
+                <a:ea typeface="Times New Roman" pitchFamily="34" charset="-122"/>
+                <a:cs typeface="Times New Roman" pitchFamily="34" charset="-120"/>
               </a:rPr>
               <a:t>Оқудан - сұхбатқа</a:t>
             </a:r>
@@ -4426,9 +4504,9 @@
                 <a:solidFill>
                   <a:srgbClr val="0B3D54"/>
                 </a:solidFill>
-                <a:latin typeface="Georgia" pitchFamily="34" charset="0"/>
-                <a:ea typeface="Georgia" pitchFamily="34" charset="-122"/>
-                <a:cs typeface="Georgia" pitchFamily="34" charset="-120"/>
+                <a:latin typeface="Times New Roman" pitchFamily="34" charset="0"/>
+                <a:ea typeface="Times New Roman" pitchFamily="34" charset="-122"/>
+                <a:cs typeface="Times New Roman" pitchFamily="34" charset="-120"/>
               </a:rPr>
               <a:t>Интерактивті хронологиялық таймлайн</a:t>
             </a:r>
@@ -4601,9 +4679,9 @@
                 <a:solidFill>
                   <a:srgbClr val="0B3D54"/>
                 </a:solidFill>
-                <a:latin typeface="Georgia" pitchFamily="34" charset="0"/>
-                <a:ea typeface="Georgia" pitchFamily="34" charset="-122"/>
-                <a:cs typeface="Georgia" pitchFamily="34" charset="-120"/>
+                <a:latin typeface="Times New Roman" pitchFamily="34" charset="0"/>
+                <a:ea typeface="Times New Roman" pitchFamily="34" charset="-122"/>
+                <a:cs typeface="Times New Roman" pitchFamily="34" charset="-120"/>
               </a:rPr>
               <a:t>Тарихи тұлғалармен ИИ-чат</a:t>
             </a:r>
@@ -4831,9 +4909,9 @@
                 <a:solidFill>
                   <a:srgbClr val="0B3D54"/>
                 </a:solidFill>
-                <a:latin typeface="Georgia" pitchFamily="34" charset="0"/>
-                <a:ea typeface="Georgia" pitchFamily="34" charset="-122"/>
-                <a:cs typeface="Georgia" pitchFamily="34" charset="-120"/>
+                <a:latin typeface="Times New Roman" pitchFamily="34" charset="0"/>
+                <a:ea typeface="Times New Roman" pitchFamily="34" charset="-122"/>
+                <a:cs typeface="Times New Roman" pitchFamily="34" charset="-120"/>
               </a:rPr>
               <a:t>Үш қадамда - тарихпен жанды байланыс</a:t>
             </a:r>
@@ -4902,9 +4980,9 @@
                 <a:solidFill>
                   <a:srgbClr val="D6BE8C"/>
                 </a:solidFill>
-                <a:latin typeface="Georgia" pitchFamily="34" charset="0"/>
-                <a:ea typeface="Georgia" pitchFamily="34" charset="-122"/>
-                <a:cs typeface="Georgia" pitchFamily="34" charset="-120"/>
+                <a:latin typeface="Times New Roman" pitchFamily="34" charset="0"/>
+                <a:ea typeface="Times New Roman" pitchFamily="34" charset="-122"/>
+                <a:cs typeface="Times New Roman" pitchFamily="34" charset="-120"/>
               </a:rPr>
               <a:t>01</a:t>
             </a:r>
@@ -4985,9 +5063,9 @@
                 <a:solidFill>
                   <a:srgbClr val="0B3D54"/>
                 </a:solidFill>
-                <a:latin typeface="Georgia" pitchFamily="34" charset="0"/>
-                <a:ea typeface="Georgia" pitchFamily="34" charset="-122"/>
-                <a:cs typeface="Georgia" pitchFamily="34" charset="-120"/>
+                <a:latin typeface="Times New Roman" pitchFamily="34" charset="0"/>
+                <a:ea typeface="Times New Roman" pitchFamily="34" charset="-122"/>
+                <a:cs typeface="Times New Roman" pitchFamily="34" charset="-120"/>
               </a:rPr>
               <a:t>Таймлайнды ашу</a:t>
             </a:r>
@@ -5098,9 +5176,9 @@
                 <a:solidFill>
                   <a:srgbClr val="D6BE8C"/>
                 </a:solidFill>
-                <a:latin typeface="Georgia" pitchFamily="34" charset="0"/>
-                <a:ea typeface="Georgia" pitchFamily="34" charset="-122"/>
-                <a:cs typeface="Georgia" pitchFamily="34" charset="-120"/>
+                <a:latin typeface="Times New Roman" pitchFamily="34" charset="0"/>
+                <a:ea typeface="Times New Roman" pitchFamily="34" charset="-122"/>
+                <a:cs typeface="Times New Roman" pitchFamily="34" charset="-120"/>
               </a:rPr>
               <a:t>02</a:t>
             </a:r>
@@ -5181,9 +5259,9 @@
                 <a:solidFill>
                   <a:srgbClr val="0B3D54"/>
                 </a:solidFill>
-                <a:latin typeface="Georgia" pitchFamily="34" charset="0"/>
-                <a:ea typeface="Georgia" pitchFamily="34" charset="-122"/>
-                <a:cs typeface="Georgia" pitchFamily="34" charset="-120"/>
+                <a:latin typeface="Times New Roman" pitchFamily="34" charset="0"/>
+                <a:ea typeface="Times New Roman" pitchFamily="34" charset="-122"/>
+                <a:cs typeface="Times New Roman" pitchFamily="34" charset="-120"/>
               </a:rPr>
               <a:t>Тұлғамен сөйлесу</a:t>
             </a:r>
@@ -5294,9 +5372,9 @@
                 <a:solidFill>
                   <a:srgbClr val="D6BE8C"/>
                 </a:solidFill>
-                <a:latin typeface="Georgia" pitchFamily="34" charset="0"/>
-                <a:ea typeface="Georgia" pitchFamily="34" charset="-122"/>
-                <a:cs typeface="Georgia" pitchFamily="34" charset="-120"/>
+                <a:latin typeface="Times New Roman" pitchFamily="34" charset="0"/>
+                <a:ea typeface="Times New Roman" pitchFamily="34" charset="-122"/>
+                <a:cs typeface="Times New Roman" pitchFamily="34" charset="-120"/>
               </a:rPr>
               <a:t>03</a:t>
             </a:r>
@@ -5377,9 +5455,9 @@
                 <a:solidFill>
                   <a:srgbClr val="0B3D54"/>
                 </a:solidFill>
-                <a:latin typeface="Georgia" pitchFamily="34" charset="0"/>
-                <a:ea typeface="Georgia" pitchFamily="34" charset="-122"/>
-                <a:cs typeface="Georgia" pitchFamily="34" charset="-120"/>
+                <a:latin typeface="Times New Roman" pitchFamily="34" charset="0"/>
+                <a:ea typeface="Times New Roman" pitchFamily="34" charset="-122"/>
+                <a:cs typeface="Times New Roman" pitchFamily="34" charset="-120"/>
               </a:rPr>
               <a:t>Терең түсіну</a:t>
             </a:r>
@@ -5770,9 +5848,9 @@
                 <a:solidFill>
                   <a:srgbClr val="0B3D54"/>
                 </a:solidFill>
-                <a:latin typeface="Georgia" pitchFamily="34" charset="0"/>
-                <a:ea typeface="Georgia" pitchFamily="34" charset="-122"/>
-                <a:cs typeface="Georgia" pitchFamily="34" charset="-120"/>
+                <a:latin typeface="Times New Roman" pitchFamily="34" charset="0"/>
+                <a:ea typeface="Times New Roman" pitchFamily="34" charset="-122"/>
+                <a:cs typeface="Times New Roman" pitchFamily="34" charset="-120"/>
               </a:rPr>
               <a:t>Таймлайн және детальді ақпарат</a:t>
             </a:r>
@@ -6527,7 +6605,7 @@
         <p:spPr>
           <a:xfrm>
             <a:off x="7781544" y="2157984"/>
-            <a:ext cx="2862072" cy="4256532"/>
+            <a:ext cx="2862072" cy="3518288"/>
           </a:xfrm>
           <a:prstGeom prst="rect">
             <a:avLst/>
@@ -6562,7 +6640,7 @@
         <p:spPr>
           <a:xfrm>
             <a:off x="7818120" y="2194560"/>
-            <a:ext cx="2788920" cy="4183380"/>
+            <a:ext cx="2788920" cy="3445136"/>
           </a:xfrm>
           <a:prstGeom prst="rect">
             <a:avLst/>
@@ -6577,8 +6655,8 @@
         </p:nvSpPr>
         <p:spPr>
           <a:xfrm>
-            <a:off x="7818120" y="6515100"/>
-            <a:ext cx="3703320" cy="640080"/>
+            <a:off x="7772400" y="5749424"/>
+            <a:ext cx="3794760" cy="640080"/>
           </a:xfrm>
           <a:prstGeom prst="rect">
             <a:avLst/>
@@ -6597,7 +6675,7 @@
               <a:buNone/>
             </a:pPr>
             <a:r>
-              <a:rPr lang="en-US" sz="1300" dirty="0">
+              <a:rPr lang="en-US" sz="1200" dirty="0">
                 <a:solidFill>
                   <a:srgbClr val="1A2A33"/>
                 </a:solidFill>
@@ -6605,9 +6683,9 @@
                 <a:ea typeface="Calibri" pitchFamily="34" charset="-122"/>
                 <a:cs typeface="Calibri" pitchFamily="34" charset="-120"/>
               </a:rPr>
-              <a:t>Детальді ақпаратта ИИ-чатты ашатын арнайы батырма орналасқан.</a:t>
-            </a:r>
-            <a:endParaRPr lang="en-US" sz="1300" dirty="0"/>
+              <a:t>Объектіні таңдағанда фото, сипаттама және ИИ-чатты ашатын «Поговорить» батырмасы көрінеді.</a:t>
+            </a:r>
+            <a:endParaRPr lang="en-US" sz="1200" dirty="0"/>
           </a:p>
         </p:txBody>
       </p:sp>
@@ -6789,9 +6867,9 @@
                 <a:solidFill>
                   <a:srgbClr val="0B3D54"/>
                 </a:solidFill>
-                <a:latin typeface="Georgia" pitchFamily="34" charset="0"/>
-                <a:ea typeface="Georgia" pitchFamily="34" charset="-122"/>
-                <a:cs typeface="Georgia" pitchFamily="34" charset="-120"/>
+                <a:latin typeface="Times New Roman" pitchFamily="34" charset="0"/>
+                <a:ea typeface="Times New Roman" pitchFamily="34" charset="-122"/>
+                <a:cs typeface="Times New Roman" pitchFamily="34" charset="-120"/>
               </a:rPr>
               <a:t>Тарихи тұлғалармен ИИ-сұхбат</a:t>
             </a:r>
@@ -6807,8 +6885,8 @@
         </p:nvSpPr>
         <p:spPr>
           <a:xfrm>
-            <a:off x="603504" y="1746504"/>
-            <a:ext cx="6291072" cy="3570732"/>
+            <a:off x="603504" y="1700784"/>
+            <a:ext cx="3159252" cy="4187952"/>
           </a:xfrm>
           <a:prstGeom prst="rect">
             <a:avLst/>
@@ -6828,7 +6906,7 @@
       </p:sp>
       <p:pic>
         <p:nvPicPr>
-          <p:cNvPr id="5" name="Image 0" descr="/Users/bekas/Developer/tarixi-timeline/grant-presentation/screen-chat-full.png">    </p:cNvPr>
+          <p:cNvPr id="5" name="Image 0" descr="/Users/bekas/Developer/tarixi-timeline/grant-presentation/chat-modal.png">    </p:cNvPr>
           <p:cNvPicPr>
             <a:picLocks noChangeAspect="1"/>
           </p:cNvPicPr>
@@ -6842,8 +6920,8 @@
         </p:blipFill>
         <p:spPr>
           <a:xfrm>
-            <a:off x="640080" y="1783080"/>
-            <a:ext cx="6217920" cy="3497580"/>
+            <a:off x="640080" y="1737360"/>
+            <a:ext cx="3086100" cy="4114800"/>
           </a:xfrm>
           <a:prstGeom prst="rect">
             <a:avLst/>
@@ -6858,24 +6936,24 @@
         </p:nvSpPr>
         <p:spPr>
           <a:xfrm>
-            <a:off x="640080" y="5372100"/>
-            <a:ext cx="6217920" cy="365760"/>
-          </a:xfrm>
-          <a:prstGeom prst="rect">
-            <a:avLst/>
-          </a:prstGeom>
-          <a:noFill/>
-          <a:ln/>
-        </p:spPr>
-        <p:txBody>
-          <a:bodyPr wrap="square" lIns="0" tIns="0" rIns="0" bIns="0" rtlCol="0" anchor="ctr"/>
-          <a:lstStyle/>
-          <a:p>
-            <a:pPr indent="0" marL="0">
-              <a:buNone/>
-            </a:pPr>
-            <a:r>
-              <a:rPr lang="en-US" sz="1300" i="1" dirty="0">
+            <a:off x="640080" y="5961888"/>
+            <a:ext cx="4183380" cy="320040"/>
+          </a:xfrm>
+          <a:prstGeom prst="rect">
+            <a:avLst/>
+          </a:prstGeom>
+          <a:noFill/>
+          <a:ln/>
+        </p:spPr>
+        <p:txBody>
+          <a:bodyPr wrap="square" lIns="0" tIns="0" rIns="0" bIns="0" rtlCol="0" anchor="ctr"/>
+          <a:lstStyle/>
+          <a:p>
+            <a:pPr indent="0" marL="0">
+              <a:buNone/>
+            </a:pPr>
+            <a:r>
+              <a:rPr lang="en-US" sz="1200" i="1" dirty="0">
                 <a:solidFill>
                   <a:srgbClr val="5E6B72"/>
                 </a:solidFill>
@@ -6883,42 +6961,77 @@
                 <a:ea typeface="Calibri" pitchFamily="34" charset="-122"/>
                 <a:cs typeface="Calibri" pitchFamily="34" charset="-120"/>
               </a:rPr>
-              <a:t>Толық экран режиміндегі чат интерфейсі</a:t>
-            </a:r>
-            <a:endParaRPr lang="en-US" sz="1300" dirty="0"/>
-          </a:p>
-        </p:txBody>
-      </p:sp>
-      <p:sp>
-        <p:nvSpPr>
-          <p:cNvPr id="7" name="Shape 4"/>
-          <p:cNvSpPr/>
-          <p:nvPr/>
-        </p:nvSpPr>
-        <p:spPr>
-          <a:xfrm>
-            <a:off x="7278624" y="1746504"/>
-            <a:ext cx="4187952" cy="4187952"/>
-          </a:xfrm>
-          <a:prstGeom prst="rect">
+              <a:t>Нақты экран — Әл-Фарабимен қазақша диалог</a:t>
+            </a:r>
+            <a:endParaRPr lang="en-US" sz="1200" dirty="0"/>
+          </a:p>
+        </p:txBody>
+      </p:sp>
+      <p:sp>
+        <p:nvSpPr>
+          <p:cNvPr id="7" name="Text 4"/>
+          <p:cNvSpPr/>
+          <p:nvPr/>
+        </p:nvSpPr>
+        <p:spPr>
+          <a:xfrm>
+            <a:off x="4366260" y="1828800"/>
+            <a:ext cx="7157923" cy="1188720"/>
+          </a:xfrm>
+          <a:prstGeom prst="rect">
+            <a:avLst/>
+          </a:prstGeom>
+          <a:noFill/>
+          <a:ln/>
+        </p:spPr>
+        <p:txBody>
+          <a:bodyPr wrap="square" lIns="0" tIns="0" rIns="0" bIns="0" rtlCol="0" anchor="ctr"/>
+          <a:lstStyle/>
+          <a:p>
+            <a:pPr indent="0" marL="0">
+              <a:lnSpc>
+                <a:spcPct val="130000"/>
+              </a:lnSpc>
+              <a:buNone/>
+            </a:pPr>
+            <a:r>
+              <a:rPr lang="en-US" sz="1600" dirty="0">
+                <a:solidFill>
+                  <a:srgbClr val="1A2A33"/>
+                </a:solidFill>
+                <a:latin typeface="Calibri" pitchFamily="34" charset="0"/>
+                <a:ea typeface="Calibri" pitchFamily="34" charset="-122"/>
+                <a:cs typeface="Calibri" pitchFamily="34" charset="-120"/>
+              </a:rPr>
+              <a:t>Эмпатиялық терең ену — платформаның басты ерекшелігі. Оқушы тарихи тұлғамен нақты адаммен сөйлескендей сұхбаттасады, бұл білімді есте сақтауды күшейтеді.</a:t>
+            </a:r>
+            <a:endParaRPr lang="en-US" sz="1600" dirty="0"/>
+          </a:p>
+        </p:txBody>
+      </p:sp>
+      <p:sp>
+        <p:nvSpPr>
+          <p:cNvPr id="8" name="Shape 5"/>
+          <p:cNvSpPr/>
+          <p:nvPr/>
+        </p:nvSpPr>
+        <p:spPr>
+          <a:xfrm>
+            <a:off x="4366260" y="3246120"/>
+            <a:ext cx="640080" cy="640080"/>
+          </a:xfrm>
+          <a:prstGeom prst="ellipse">
             <a:avLst/>
           </a:prstGeom>
           <a:solidFill>
             <a:srgbClr val="0B3D54"/>
           </a:solidFill>
           <a:ln/>
-          <a:effectLst>
-            <a:outerShdw sx="100000" sy="100000" kx="0" ky="0" algn="bl" rotWithShape="0" blurRad="101600" dist="38100" dir="8100000">
-              <a:srgbClr val="000000">
-                <a:alpha val="18000"/>
-              </a:srgbClr>
-            </a:outerShdw>
-          </a:effectLst>
         </p:spPr>
       </p:sp>
       <p:pic>
         <p:nvPicPr>
-          <p:cNvPr id="8" name="Image 1" descr="/Users/bekas/Developer/tarixi-timeline/grant-presentation/chat-modal.png">    </p:cNvPr>
+          <p:cNvPr id="9" name="Image 1" descr="preencoded.png">    </p:cNvPr>
           <p:cNvPicPr>
             <a:picLocks noChangeAspect="1"/>
           </p:cNvPicPr>
@@ -6932,8 +7045,8 @@
         </p:blipFill>
         <p:spPr>
           <a:xfrm>
-            <a:off x="7315200" y="1783080"/>
-            <a:ext cx="4114800" cy="4114800"/>
+            <a:off x="4512564" y="3392424"/>
+            <a:ext cx="347472" cy="347472"/>
           </a:xfrm>
           <a:prstGeom prst="rect">
             <a:avLst/>
@@ -6942,14 +7055,53 @@
       </p:pic>
       <p:sp>
         <p:nvSpPr>
-          <p:cNvPr id="9" name="Text 5"/>
-          <p:cNvSpPr/>
-          <p:nvPr/>
-        </p:nvSpPr>
-        <p:spPr>
-          <a:xfrm>
-            <a:off x="7315200" y="6172200"/>
-            <a:ext cx="4114800" cy="1097280"/>
+          <p:cNvPr id="10" name="Text 6"/>
+          <p:cNvSpPr/>
+          <p:nvPr/>
+        </p:nvSpPr>
+        <p:spPr>
+          <a:xfrm>
+            <a:off x="5234940" y="3227832"/>
+            <a:ext cx="6289243" cy="365760"/>
+          </a:xfrm>
+          <a:prstGeom prst="rect">
+            <a:avLst/>
+          </a:prstGeom>
+          <a:noFill/>
+          <a:ln/>
+        </p:spPr>
+        <p:txBody>
+          <a:bodyPr wrap="square" lIns="0" tIns="0" rIns="0" bIns="0" rtlCol="0" anchor="ctr"/>
+          <a:lstStyle/>
+          <a:p>
+            <a:pPr indent="0" marL="0">
+              <a:buNone/>
+            </a:pPr>
+            <a:r>
+              <a:rPr lang="en-US" sz="1600" b="1" dirty="0">
+                <a:solidFill>
+                  <a:srgbClr val="0B3D54"/>
+                </a:solidFill>
+                <a:latin typeface="Times New Roman" pitchFamily="34" charset="0"/>
+                <a:ea typeface="Times New Roman" pitchFamily="34" charset="-122"/>
+                <a:cs typeface="Times New Roman" pitchFamily="34" charset="-120"/>
+              </a:rPr>
+              <a:t>Дәуірге дәйекті ИИ-агенттер</a:t>
+            </a:r>
+            <a:endParaRPr lang="en-US" sz="1600" dirty="0"/>
+          </a:p>
+        </p:txBody>
+      </p:sp>
+      <p:sp>
+        <p:nvSpPr>
+          <p:cNvPr id="11" name="Text 7"/>
+          <p:cNvSpPr/>
+          <p:nvPr/>
+        </p:nvSpPr>
+        <p:spPr>
+          <a:xfrm>
+            <a:off x="5234940" y="3611880"/>
+            <a:ext cx="6289243" cy="502920"/>
           </a:xfrm>
           <a:prstGeom prst="rect">
             <a:avLst/>
@@ -6963,12 +7115,12 @@
           <a:p>
             <a:pPr indent="0" marL="0">
               <a:lnSpc>
-                <a:spcPct val="115000"/>
+                <a:spcPct val="110000"/>
               </a:lnSpc>
               <a:buNone/>
             </a:pPr>
             <a:r>
-              <a:rPr lang="en-US" sz="1500" dirty="0">
+              <a:rPr lang="en-US" sz="1300" dirty="0">
                 <a:solidFill>
                   <a:srgbClr val="1A2A33"/>
                 </a:solidFill>
@@ -6976,15 +7128,265 @@
                 <a:ea typeface="Calibri" pitchFamily="34" charset="-122"/>
                 <a:cs typeface="Calibri" pitchFamily="34" charset="-120"/>
               </a:rPr>
-              <a:t>Эмпатиялық терең ену - платформаның басты ерекшелігі. Оқушылар тұлғамен нақты адаммен сөйлескендей әңгімелеседі.</a:t>
-            </a:r>
-            <a:endParaRPr lang="en-US" sz="1500" dirty="0"/>
-          </a:p>
-        </p:txBody>
-      </p:sp>
-      <p:sp>
-        <p:nvSpPr>
-          <p:cNvPr id="10" name="Text 6"/>
+              <a:t>Әр тұлғаның мінезі, білімі мен дәуір контексі сақталады.</a:t>
+            </a:r>
+            <a:endParaRPr lang="en-US" sz="1300" dirty="0"/>
+          </a:p>
+        </p:txBody>
+      </p:sp>
+      <p:sp>
+        <p:nvSpPr>
+          <p:cNvPr id="12" name="Shape 8"/>
+          <p:cNvSpPr/>
+          <p:nvPr/>
+        </p:nvSpPr>
+        <p:spPr>
+          <a:xfrm>
+            <a:off x="4366260" y="4206240"/>
+            <a:ext cx="640080" cy="640080"/>
+          </a:xfrm>
+          <a:prstGeom prst="ellipse">
+            <a:avLst/>
+          </a:prstGeom>
+          <a:solidFill>
+            <a:srgbClr val="0B3D54"/>
+          </a:solidFill>
+          <a:ln/>
+        </p:spPr>
+      </p:sp>
+      <p:pic>
+        <p:nvPicPr>
+          <p:cNvPr id="13" name="Image 2" descr="preencoded.png">    </p:cNvPr>
+          <p:cNvPicPr>
+            <a:picLocks noChangeAspect="1"/>
+          </p:cNvPicPr>
+          <p:nvPr/>
+        </p:nvPicPr>
+        <p:blipFill>
+          <a:blip r:embed="rId3"/>
+          <a:stretch>
+            <a:fillRect/>
+          </a:stretch>
+        </p:blipFill>
+        <p:spPr>
+          <a:xfrm>
+            <a:off x="4512564" y="4352544"/>
+            <a:ext cx="347472" cy="347472"/>
+          </a:xfrm>
+          <a:prstGeom prst="rect">
+            <a:avLst/>
+          </a:prstGeom>
+        </p:spPr>
+      </p:pic>
+      <p:sp>
+        <p:nvSpPr>
+          <p:cNvPr id="14" name="Text 9"/>
+          <p:cNvSpPr/>
+          <p:nvPr/>
+        </p:nvSpPr>
+        <p:spPr>
+          <a:xfrm>
+            <a:off x="5234940" y="4187952"/>
+            <a:ext cx="6289243" cy="365760"/>
+          </a:xfrm>
+          <a:prstGeom prst="rect">
+            <a:avLst/>
+          </a:prstGeom>
+          <a:noFill/>
+          <a:ln/>
+        </p:spPr>
+        <p:txBody>
+          <a:bodyPr wrap="square" lIns="0" tIns="0" rIns="0" bIns="0" rtlCol="0" anchor="ctr"/>
+          <a:lstStyle/>
+          <a:p>
+            <a:pPr indent="0" marL="0">
+              <a:buNone/>
+            </a:pPr>
+            <a:r>
+              <a:rPr lang="en-US" sz="1600" b="1" dirty="0">
+                <a:solidFill>
+                  <a:srgbClr val="0B3D54"/>
+                </a:solidFill>
+                <a:latin typeface="Times New Roman" pitchFamily="34" charset="0"/>
+                <a:ea typeface="Times New Roman" pitchFamily="34" charset="-122"/>
+                <a:cs typeface="Times New Roman" pitchFamily="34" charset="-120"/>
+              </a:rPr>
+              <a:t>Қазақ және орыс тілінде</a:t>
+            </a:r>
+            <a:endParaRPr lang="en-US" sz="1600" dirty="0"/>
+          </a:p>
+        </p:txBody>
+      </p:sp>
+      <p:sp>
+        <p:nvSpPr>
+          <p:cNvPr id="15" name="Text 10"/>
+          <p:cNvSpPr/>
+          <p:nvPr/>
+        </p:nvSpPr>
+        <p:spPr>
+          <a:xfrm>
+            <a:off x="5234940" y="4572000"/>
+            <a:ext cx="6289243" cy="502920"/>
+          </a:xfrm>
+          <a:prstGeom prst="rect">
+            <a:avLst/>
+          </a:prstGeom>
+          <a:noFill/>
+          <a:ln/>
+        </p:spPr>
+        <p:txBody>
+          <a:bodyPr wrap="square" lIns="0" tIns="0" rIns="0" bIns="0" rtlCol="0" anchor="ctr"/>
+          <a:lstStyle/>
+          <a:p>
+            <a:pPr indent="0" marL="0">
+              <a:lnSpc>
+                <a:spcPct val="110000"/>
+              </a:lnSpc>
+              <a:buNone/>
+            </a:pPr>
+            <a:r>
+              <a:rPr lang="en-US" sz="1300" dirty="0">
+                <a:solidFill>
+                  <a:srgbClr val="1A2A33"/>
+                </a:solidFill>
+                <a:latin typeface="Calibri" pitchFamily="34" charset="0"/>
+                <a:ea typeface="Calibri" pitchFamily="34" charset="-122"/>
+                <a:cs typeface="Calibri" pitchFamily="34" charset="-120"/>
+              </a:rPr>
+              <a:t>Оқушының тіліне қарай табиғи түрде жауап береді.</a:t>
+            </a:r>
+            <a:endParaRPr lang="en-US" sz="1300" dirty="0"/>
+          </a:p>
+        </p:txBody>
+      </p:sp>
+      <p:sp>
+        <p:nvSpPr>
+          <p:cNvPr id="16" name="Shape 11"/>
+          <p:cNvSpPr/>
+          <p:nvPr/>
+        </p:nvSpPr>
+        <p:spPr>
+          <a:xfrm>
+            <a:off x="4366260" y="5166360"/>
+            <a:ext cx="640080" cy="640080"/>
+          </a:xfrm>
+          <a:prstGeom prst="ellipse">
+            <a:avLst/>
+          </a:prstGeom>
+          <a:solidFill>
+            <a:srgbClr val="0B3D54"/>
+          </a:solidFill>
+          <a:ln/>
+        </p:spPr>
+      </p:sp>
+      <p:pic>
+        <p:nvPicPr>
+          <p:cNvPr id="17" name="Image 3" descr="preencoded.png">    </p:cNvPr>
+          <p:cNvPicPr>
+            <a:picLocks noChangeAspect="1"/>
+          </p:cNvPicPr>
+          <p:nvPr/>
+        </p:nvPicPr>
+        <p:blipFill>
+          <a:blip r:embed="rId4"/>
+          <a:stretch>
+            <a:fillRect/>
+          </a:stretch>
+        </p:blipFill>
+        <p:spPr>
+          <a:xfrm>
+            <a:off x="4512564" y="5312664"/>
+            <a:ext cx="347472" cy="347472"/>
+          </a:xfrm>
+          <a:prstGeom prst="rect">
+            <a:avLst/>
+          </a:prstGeom>
+        </p:spPr>
+      </p:pic>
+      <p:sp>
+        <p:nvSpPr>
+          <p:cNvPr id="18" name="Text 12"/>
+          <p:cNvSpPr/>
+          <p:nvPr/>
+        </p:nvSpPr>
+        <p:spPr>
+          <a:xfrm>
+            <a:off x="5234940" y="5148072"/>
+            <a:ext cx="6289243" cy="365760"/>
+          </a:xfrm>
+          <a:prstGeom prst="rect">
+            <a:avLst/>
+          </a:prstGeom>
+          <a:noFill/>
+          <a:ln/>
+        </p:spPr>
+        <p:txBody>
+          <a:bodyPr wrap="square" lIns="0" tIns="0" rIns="0" bIns="0" rtlCol="0" anchor="ctr"/>
+          <a:lstStyle/>
+          <a:p>
+            <a:pPr indent="0" marL="0">
+              <a:buNone/>
+            </a:pPr>
+            <a:r>
+              <a:rPr lang="en-US" sz="1600" b="1" dirty="0">
+                <a:solidFill>
+                  <a:srgbClr val="0B3D54"/>
+                </a:solidFill>
+                <a:latin typeface="Times New Roman" pitchFamily="34" charset="0"/>
+                <a:ea typeface="Times New Roman" pitchFamily="34" charset="-122"/>
+                <a:cs typeface="Times New Roman" pitchFamily="34" charset="-120"/>
+              </a:rPr>
+              <a:t>Белсенді коммуникация</a:t>
+            </a:r>
+            <a:endParaRPr lang="en-US" sz="1600" dirty="0"/>
+          </a:p>
+        </p:txBody>
+      </p:sp>
+      <p:sp>
+        <p:nvSpPr>
+          <p:cNvPr id="19" name="Text 13"/>
+          <p:cNvSpPr/>
+          <p:nvPr/>
+        </p:nvSpPr>
+        <p:spPr>
+          <a:xfrm>
+            <a:off x="5234940" y="5532120"/>
+            <a:ext cx="6289243" cy="502920"/>
+          </a:xfrm>
+          <a:prstGeom prst="rect">
+            <a:avLst/>
+          </a:prstGeom>
+          <a:noFill/>
+          <a:ln/>
+        </p:spPr>
+        <p:txBody>
+          <a:bodyPr wrap="square" lIns="0" tIns="0" rIns="0" bIns="0" rtlCol="0" anchor="ctr"/>
+          <a:lstStyle/>
+          <a:p>
+            <a:pPr indent="0" marL="0">
+              <a:lnSpc>
+                <a:spcPct val="110000"/>
+              </a:lnSpc>
+              <a:buNone/>
+            </a:pPr>
+            <a:r>
+              <a:rPr lang="en-US" sz="1300" dirty="0">
+                <a:solidFill>
+                  <a:srgbClr val="1A2A33"/>
+                </a:solidFill>
+                <a:latin typeface="Calibri" pitchFamily="34" charset="0"/>
+                <a:ea typeface="Calibri" pitchFamily="34" charset="-122"/>
+                <a:cs typeface="Calibri" pitchFamily="34" charset="-120"/>
+              </a:rPr>
+              <a:t>Пассивті оқуға қарағанда ақпарат әлдеқайда жақсы бекиді.</a:t>
+            </a:r>
+            <a:endParaRPr lang="en-US" sz="1300" dirty="0"/>
+          </a:p>
+        </p:txBody>
+      </p:sp>
+      <p:sp>
+        <p:nvSpPr>
+          <p:cNvPr id="20" name="Text 14"/>
           <p:cNvSpPr/>
           <p:nvPr/>
         </p:nvSpPr>
@@ -7023,7 +7425,7 @@
       </p:sp>
       <p:sp>
         <p:nvSpPr>
-          <p:cNvPr id="11" name="Text 7"/>
+          <p:cNvPr id="21" name="Text 15"/>
           <p:cNvSpPr/>
           <p:nvPr/>
         </p:nvSpPr>
@@ -7160,9 +7562,9 @@
                 <a:solidFill>
                   <a:srgbClr val="FFFFFF"/>
                 </a:solidFill>
-                <a:latin typeface="Georgia" pitchFamily="34" charset="0"/>
-                <a:ea typeface="Georgia" pitchFamily="34" charset="-122"/>
-                <a:cs typeface="Georgia" pitchFamily="34" charset="-120"/>
+                <a:latin typeface="Times New Roman" pitchFamily="34" charset="0"/>
+                <a:ea typeface="Times New Roman" pitchFamily="34" charset="-122"/>
+                <a:cs typeface="Times New Roman" pitchFamily="34" charset="-120"/>
               </a:rPr>
               <a:t>«Тәуелсіздік ұрпақтары» миссиясымен үндес</a:t>
             </a:r>
@@ -7270,9 +7672,9 @@
                 <a:solidFill>
                   <a:srgbClr val="0B3D54"/>
                 </a:solidFill>
-                <a:latin typeface="Georgia" pitchFamily="34" charset="0"/>
-                <a:ea typeface="Georgia" pitchFamily="34" charset="-122"/>
-                <a:cs typeface="Georgia" pitchFamily="34" charset="-120"/>
+                <a:latin typeface="Times New Roman" pitchFamily="34" charset="0"/>
+                <a:ea typeface="Times New Roman" pitchFamily="34" charset="-122"/>
+                <a:cs typeface="Times New Roman" pitchFamily="34" charset="-120"/>
               </a:rPr>
               <a:t>Оқушылар мен студенттер</a:t>
             </a:r>
@@ -7422,9 +7824,9 @@
                 <a:solidFill>
                   <a:srgbClr val="0B3D54"/>
                 </a:solidFill>
-                <a:latin typeface="Georgia" pitchFamily="34" charset="0"/>
-                <a:ea typeface="Georgia" pitchFamily="34" charset="-122"/>
-                <a:cs typeface="Georgia" pitchFamily="34" charset="-120"/>
+                <a:latin typeface="Times New Roman" pitchFamily="34" charset="0"/>
+                <a:ea typeface="Times New Roman" pitchFamily="34" charset="-122"/>
+                <a:cs typeface="Times New Roman" pitchFamily="34" charset="-120"/>
               </a:rPr>
               <a:t>Қосымша білім</a:t>
             </a:r>
@@ -7574,9 +7976,9 @@
                 <a:solidFill>
                   <a:srgbClr val="0B3D54"/>
                 </a:solidFill>
-                <a:latin typeface="Georgia" pitchFamily="34" charset="0"/>
-                <a:ea typeface="Georgia" pitchFamily="34" charset="-122"/>
-                <a:cs typeface="Georgia" pitchFamily="34" charset="-120"/>
+                <a:latin typeface="Times New Roman" pitchFamily="34" charset="0"/>
+                <a:ea typeface="Times New Roman" pitchFamily="34" charset="-122"/>
+                <a:cs typeface="Times New Roman" pitchFamily="34" charset="-120"/>
               </a:rPr>
               <a:t>Мұғалімдер</a:t>
             </a:r>
@@ -7721,9 +8123,9 @@
                 <a:solidFill>
                   <a:srgbClr val="FFFFFF"/>
                 </a:solidFill>
-                <a:latin typeface="Georgia" pitchFamily="34" charset="0"/>
-                <a:ea typeface="Georgia" pitchFamily="34" charset="-122"/>
-                <a:cs typeface="Georgia" pitchFamily="34" charset="-120"/>
+                <a:latin typeface="Times New Roman" pitchFamily="34" charset="0"/>
+                <a:ea typeface="Times New Roman" pitchFamily="34" charset="-122"/>
+                <a:cs typeface="Times New Roman" pitchFamily="34" charset="-120"/>
               </a:rPr>
               <a:t>Азаматтық бірегейлік</a:t>
             </a:r>
@@ -7869,9 +8271,9 @@
                 <a:solidFill>
                   <a:srgbClr val="FFFFFF"/>
                 </a:solidFill>
-                <a:latin typeface="Georgia" pitchFamily="34" charset="0"/>
-                <a:ea typeface="Georgia" pitchFamily="34" charset="-122"/>
-                <a:cs typeface="Georgia" pitchFamily="34" charset="-120"/>
+                <a:latin typeface="Times New Roman" pitchFamily="34" charset="0"/>
+                <a:ea typeface="Times New Roman" pitchFamily="34" charset="-122"/>
+                <a:cs typeface="Times New Roman" pitchFamily="34" charset="-120"/>
               </a:rPr>
               <a:t>Мәдени сабақтастық</a:t>
             </a:r>
@@ -8122,9 +8524,9 @@
                 <a:solidFill>
                   <a:srgbClr val="0B3D54"/>
                 </a:solidFill>
-                <a:latin typeface="Georgia" pitchFamily="34" charset="0"/>
-                <a:ea typeface="Georgia" pitchFamily="34" charset="-122"/>
-                <a:cs typeface="Georgia" pitchFamily="34" charset="-120"/>
+                <a:latin typeface="Times New Roman" pitchFamily="34" charset="0"/>
+                <a:ea typeface="Times New Roman" pitchFamily="34" charset="-122"/>
+                <a:cs typeface="Times New Roman" pitchFamily="34" charset="-120"/>
               </a:rPr>
               <a:t>Сенімді инженерлік негіз</a:t>
             </a:r>
@@ -8237,9 +8639,9 @@
                 <a:solidFill>
                   <a:srgbClr val="0B3D54"/>
                 </a:solidFill>
-                <a:latin typeface="Georgia" pitchFamily="34" charset="0"/>
-                <a:ea typeface="Georgia" pitchFamily="34" charset="-122"/>
-                <a:cs typeface="Georgia" pitchFamily="34" charset="-120"/>
+                <a:latin typeface="Times New Roman" pitchFamily="34" charset="0"/>
+                <a:ea typeface="Times New Roman" pitchFamily="34" charset="-122"/>
+                <a:cs typeface="Times New Roman" pitchFamily="34" charset="-120"/>
               </a:rPr>
               <a:t>Заманауи веб-технологиялар</a:t>
             </a:r>
@@ -8394,9 +8796,9 @@
                 <a:solidFill>
                   <a:srgbClr val="0B3D54"/>
                 </a:solidFill>
-                <a:latin typeface="Georgia" pitchFamily="34" charset="0"/>
-                <a:ea typeface="Georgia" pitchFamily="34" charset="-122"/>
-                <a:cs typeface="Georgia" pitchFamily="34" charset="-120"/>
+                <a:latin typeface="Times New Roman" pitchFamily="34" charset="0"/>
+                <a:ea typeface="Times New Roman" pitchFamily="34" charset="-122"/>
+                <a:cs typeface="Times New Roman" pitchFamily="34" charset="-120"/>
               </a:rPr>
               <a:t>Сенімді ДҚБЖ</a:t>
             </a:r>
@@ -8551,9 +8953,9 @@
                 <a:solidFill>
                   <a:srgbClr val="0B3D54"/>
                 </a:solidFill>
-                <a:latin typeface="Georgia" pitchFamily="34" charset="0"/>
-                <a:ea typeface="Georgia" pitchFamily="34" charset="-122"/>
-                <a:cs typeface="Georgia" pitchFamily="34" charset="-120"/>
+                <a:latin typeface="Times New Roman" pitchFamily="34" charset="0"/>
+                <a:ea typeface="Times New Roman" pitchFamily="34" charset="-122"/>
+                <a:cs typeface="Times New Roman" pitchFamily="34" charset="-120"/>
               </a:rPr>
               <a:t>LLM интеграциясы</a:t>
             </a:r>
@@ -8708,9 +9110,9 @@
                 <a:solidFill>
                   <a:srgbClr val="0B3D54"/>
                 </a:solidFill>
-                <a:latin typeface="Georgia" pitchFamily="34" charset="0"/>
-                <a:ea typeface="Georgia" pitchFamily="34" charset="-122"/>
-                <a:cs typeface="Georgia" pitchFamily="34" charset="-120"/>
+                <a:latin typeface="Times New Roman" pitchFamily="34" charset="0"/>
+                <a:ea typeface="Times New Roman" pitchFamily="34" charset="-122"/>
+                <a:cs typeface="Times New Roman" pitchFamily="34" charset="-120"/>
               </a:rPr>
               <a:t>Масштабталу</a:t>
             </a:r>
@@ -9061,9 +9463,9 @@
                 <a:solidFill>
                   <a:srgbClr val="0B3D54"/>
                 </a:solidFill>
-                <a:latin typeface="Georgia" pitchFamily="34" charset="0"/>
-                <a:ea typeface="Georgia" pitchFamily="34" charset="-122"/>
-                <a:cs typeface="Georgia" pitchFamily="34" charset="-120"/>
+                <a:latin typeface="Times New Roman" pitchFamily="34" charset="0"/>
+                <a:ea typeface="Times New Roman" pitchFamily="34" charset="-122"/>
+                <a:cs typeface="Times New Roman" pitchFamily="34" charset="-120"/>
               </a:rPr>
               <a:t>Грант бюджеті - 3 000 000 ₸</a:t>
             </a:r>
@@ -9166,9 +9568,9 @@
                 <a:solidFill>
                   <a:srgbClr val="FFFFFF"/>
                 </a:solidFill>
-                <a:latin typeface="Georgia" pitchFamily="34" charset="0"/>
-                <a:ea typeface="Georgia" pitchFamily="34" charset="-122"/>
-                <a:cs typeface="Georgia" pitchFamily="34" charset="-120"/>
+                <a:latin typeface="Times New Roman" pitchFamily="34" charset="0"/>
+                <a:ea typeface="Times New Roman" pitchFamily="34" charset="-122"/>
+                <a:cs typeface="Times New Roman" pitchFamily="34" charset="-120"/>
               </a:rPr>
               <a:t>3 000 000 ₸</a:t>
             </a:r>
@@ -10281,9 +10683,9 @@
                 <a:solidFill>
                   <a:srgbClr val="C9962B"/>
                 </a:solidFill>
-                <a:latin typeface="Georgia" pitchFamily="34" charset="0"/>
-                <a:ea typeface="Georgia" pitchFamily="34" charset="-122"/>
-                <a:cs typeface="Georgia" pitchFamily="34" charset="-120"/>
+                <a:latin typeface="Times New Roman" pitchFamily="34" charset="0"/>
+                <a:ea typeface="Times New Roman" pitchFamily="34" charset="-122"/>
+                <a:cs typeface="Times New Roman" pitchFamily="34" charset="-120"/>
               </a:rPr>
               <a:t>3 000 000 ₸</a:t>
             </a:r>

</xml_diff>

<commit_message>
style(presentation): dark theme matching the app palette
- Switch deck to the app's dark scheme (#0C0E15 bg, near-white text,
  gold #E6B94A + blue #38BDF8 accents)
- Budget chart now uses the app's actual tag colors
- Gold icon chips with dark glyphs; cards/panels on dark
- App screenshots now blend seamlessly into the dark slides

Co-Authored-By: Claude Opus 4.8 <noreply@anthropic.com>
</commit_message>
<xml_diff>
--- a/grant-presentation/Tarixi-Timeline_Tauelsizdik_urpaqtary.pptx
+++ b/grant-presentation/Tarixi-Timeline_Tauelsizdik_urpaqtary.pptx
@@ -1658,7 +1658,7 @@
     <p:bg>
       <p:bgPr>
         <a:solidFill>
-          <a:srgbClr val="0B3D54"/>
+          <a:srgbClr val="07080C"/>
         </a:solidFill>
       </p:bgPr>
     </p:bg>
@@ -1691,8 +1691,8 @@
             <a:avLst/>
           </a:prstGeom>
           <a:solidFill>
-            <a:srgbClr val="1C7CA5">
-              <a:alpha val="40000"/>
+            <a:srgbClr val="38BDF8">
+              <a:alpha val="12000"/>
             </a:srgbClr>
           </a:solidFill>
           <a:ln/>
@@ -1713,8 +1713,8 @@
             <a:avLst/>
           </a:prstGeom>
           <a:solidFill>
-            <a:srgbClr val="E5B23C">
-              <a:alpha val="25000"/>
+            <a:srgbClr val="E6B94A">
+              <a:alpha val="14000"/>
             </a:srgbClr>
           </a:solidFill>
           <a:ln/>
@@ -1747,7 +1747,7 @@
             <a:r>
               <a:rPr lang="en-US" sz="1400" b="1" spc="400" kern="0" dirty="0">
                 <a:solidFill>
-                  <a:srgbClr val="E5B23C"/>
+                  <a:srgbClr val="E6B94A"/>
                 </a:solidFill>
                 <a:latin typeface="Calibri" pitchFamily="34" charset="0"/>
                 <a:ea typeface="Calibri" pitchFamily="34" charset="-122"/>
@@ -1786,7 +1786,7 @@
             <a:r>
               <a:rPr lang="en-US" sz="6400" b="1" dirty="0">
                 <a:solidFill>
-                  <a:srgbClr val="FFFFFF"/>
+                  <a:srgbClr val="F5F6FA"/>
                 </a:solidFill>
                 <a:latin typeface="Times New Roman" pitchFamily="34" charset="0"/>
                 <a:ea typeface="Times New Roman" pitchFamily="34" charset="-122"/>
@@ -1828,7 +1828,7 @@
             <a:r>
               <a:rPr lang="en-US" sz="2000" dirty="0">
                 <a:solidFill>
-                  <a:srgbClr val="F6F2E9"/>
+                  <a:srgbClr val="C6CAD8"/>
                 </a:solidFill>
                 <a:latin typeface="Calibri" pitchFamily="34" charset="0"/>
                 <a:ea typeface="Calibri" pitchFamily="34" charset="-122"/>
@@ -1857,7 +1857,7 @@
           <a:noFill/>
           <a:ln w="25400">
             <a:solidFill>
-              <a:srgbClr val="E5B23C"/>
+              <a:srgbClr val="E6B94A"/>
             </a:solidFill>
             <a:prstDash val="solid"/>
           </a:ln>
@@ -1878,7 +1878,7 @@
             <a:avLst/>
           </a:prstGeom>
           <a:solidFill>
-            <a:srgbClr val="E5B23C"/>
+            <a:srgbClr val="E6B94A"/>
           </a:solidFill>
           <a:ln/>
         </p:spPr>
@@ -1898,7 +1898,7 @@
             <a:avLst/>
           </a:prstGeom>
           <a:solidFill>
-            <a:srgbClr val="E5B23C"/>
+            <a:srgbClr val="E6B94A"/>
           </a:solidFill>
           <a:ln/>
         </p:spPr>
@@ -1918,7 +1918,7 @@
             <a:avLst/>
           </a:prstGeom>
           <a:solidFill>
-            <a:srgbClr val="E5B23C"/>
+            <a:srgbClr val="E6B94A"/>
           </a:solidFill>
           <a:ln/>
         </p:spPr>
@@ -1938,7 +1938,7 @@
             <a:avLst/>
           </a:prstGeom>
           <a:solidFill>
-            <a:srgbClr val="E5B23C"/>
+            <a:srgbClr val="E6B94A"/>
           </a:solidFill>
           <a:ln/>
         </p:spPr>
@@ -1958,7 +1958,7 @@
             <a:avLst/>
           </a:prstGeom>
           <a:solidFill>
-            <a:srgbClr val="E5B23C"/>
+            <a:srgbClr val="E6B94A"/>
           </a:solidFill>
           <a:ln/>
         </p:spPr>
@@ -1978,7 +1978,7 @@
             <a:avLst/>
           </a:prstGeom>
           <a:solidFill>
-            <a:srgbClr val="E5B23C"/>
+            <a:srgbClr val="E6B94A"/>
           </a:solidFill>
           <a:ln/>
         </p:spPr>
@@ -2010,7 +2010,7 @@
             <a:r>
               <a:rPr lang="en-US" sz="1500" b="1" dirty="0">
                 <a:solidFill>
-                  <a:srgbClr val="E5B23C"/>
+                  <a:srgbClr val="E6B94A"/>
                 </a:solidFill>
                 <a:latin typeface="Calibri" pitchFamily="34" charset="0"/>
                 <a:ea typeface="Calibri" pitchFamily="34" charset="-122"/>
@@ -2024,7 +2024,7 @@
             <a:r>
               <a:rPr lang="en-US" sz="1500" dirty="0">
                 <a:solidFill>
-                  <a:srgbClr val="F6F2E9"/>
+                  <a:srgbClr val="C6CAD8"/>
                 </a:solidFill>
                 <a:latin typeface="Calibri" pitchFamily="34" charset="0"/>
                 <a:ea typeface="Calibri" pitchFamily="34" charset="-122"/>
@@ -2063,7 +2063,7 @@
             <a:r>
               <a:rPr lang="en-US" sz="1500" b="1" dirty="0">
                 <a:solidFill>
-                  <a:srgbClr val="E5B23C"/>
+                  <a:srgbClr val="E6B94A"/>
                 </a:solidFill>
                 <a:latin typeface="Calibri" pitchFamily="34" charset="0"/>
                 <a:ea typeface="Calibri" pitchFamily="34" charset="-122"/>
@@ -2077,7 +2077,7 @@
             <a:r>
               <a:rPr lang="en-US" sz="1500" dirty="0">
                 <a:solidFill>
-                  <a:srgbClr val="F6F2E9"/>
+                  <a:srgbClr val="C6CAD8"/>
                 </a:solidFill>
                 <a:latin typeface="Calibri" pitchFamily="34" charset="0"/>
                 <a:ea typeface="Calibri" pitchFamily="34" charset="-122"/>
@@ -2116,7 +2116,7 @@
             <a:r>
               <a:rPr lang="en-US" sz="1200" i="1" dirty="0">
                 <a:solidFill>
-                  <a:srgbClr val="AFC3CE"/>
+                  <a:srgbClr val="8B91A4"/>
                 </a:solidFill>
                 <a:latin typeface="Calibri" pitchFamily="34" charset="0"/>
                 <a:ea typeface="Calibri" pitchFamily="34" charset="-122"/>
@@ -2142,7 +2142,7 @@
     <p:bg>
       <p:bgPr>
         <a:solidFill>
-          <a:srgbClr val="0B3D54"/>
+          <a:srgbClr val="07080C"/>
         </a:solidFill>
       </p:bgPr>
     </p:bg>
@@ -2175,8 +2175,8 @@
             <a:avLst/>
           </a:prstGeom>
           <a:solidFill>
-            <a:srgbClr val="1C7CA5">
-              <a:alpha val="35000"/>
+            <a:srgbClr val="38BDF8">
+              <a:alpha val="10000"/>
             </a:srgbClr>
           </a:solidFill>
           <a:ln/>
@@ -2209,7 +2209,7 @@
             <a:r>
               <a:rPr lang="en-US" sz="1300" b="1" spc="300" kern="0" dirty="0">
                 <a:solidFill>
-                  <a:srgbClr val="E5B23C"/>
+                  <a:srgbClr val="E6B94A"/>
                 </a:solidFill>
                 <a:latin typeface="Calibri" pitchFamily="34" charset="0"/>
                 <a:ea typeface="Calibri" pitchFamily="34" charset="-122"/>
@@ -2248,7 +2248,7 @@
             <a:r>
               <a:rPr lang="en-US" sz="3000" b="1" dirty="0">
                 <a:solidFill>
-                  <a:srgbClr val="FFFFFF"/>
+                  <a:srgbClr val="F5F6FA"/>
                 </a:solidFill>
                 <a:latin typeface="Times New Roman" pitchFamily="34" charset="0"/>
                 <a:ea typeface="Times New Roman" pitchFamily="34" charset="-122"/>
@@ -2277,7 +2277,7 @@
           <a:noFill/>
           <a:ln w="25400">
             <a:solidFill>
-              <a:srgbClr val="E5B23C"/>
+              <a:srgbClr val="E6B94A"/>
             </a:solidFill>
             <a:prstDash val="solid"/>
           </a:ln>
@@ -2298,7 +2298,7 @@
             <a:avLst/>
           </a:prstGeom>
           <a:solidFill>
-            <a:srgbClr val="E5B23C"/>
+            <a:srgbClr val="E6B94A"/>
           </a:solidFill>
           <a:ln/>
         </p:spPr>
@@ -2318,7 +2318,7 @@
             <a:avLst/>
           </a:prstGeom>
           <a:solidFill>
-            <a:srgbClr val="E5B23C"/>
+            <a:srgbClr val="E6B94A"/>
           </a:solidFill>
           <a:ln/>
         </p:spPr>
@@ -2338,7 +2338,7 @@
             <a:avLst/>
           </a:prstGeom>
           <a:solidFill>
-            <a:srgbClr val="E5B23C"/>
+            <a:srgbClr val="E6B94A"/>
           </a:solidFill>
           <a:ln/>
         </p:spPr>
@@ -2358,7 +2358,7 @@
             <a:avLst/>
           </a:prstGeom>
           <a:solidFill>
-            <a:srgbClr val="E5B23C"/>
+            <a:srgbClr val="E6B94A"/>
           </a:solidFill>
           <a:ln/>
         </p:spPr>
@@ -2378,7 +2378,7 @@
             <a:avLst/>
           </a:prstGeom>
           <a:solidFill>
-            <a:srgbClr val="E5B23C"/>
+            <a:srgbClr val="E6B94A"/>
           </a:solidFill>
           <a:ln/>
         </p:spPr>
@@ -2410,7 +2410,7 @@
             <a:r>
               <a:rPr lang="en-US" sz="1200" b="1" dirty="0">
                 <a:solidFill>
-                  <a:srgbClr val="E5B23C"/>
+                  <a:srgbClr val="E6B94A"/>
                 </a:solidFill>
                 <a:latin typeface="Calibri" pitchFamily="34" charset="0"/>
                 <a:ea typeface="Calibri" pitchFamily="34" charset="-122"/>
@@ -2449,7 +2449,7 @@
             <a:r>
               <a:rPr lang="en-US" sz="1600" b="1" dirty="0">
                 <a:solidFill>
-                  <a:srgbClr val="FFFFFF"/>
+                  <a:srgbClr val="F5F6FA"/>
                 </a:solidFill>
                 <a:latin typeface="Times New Roman" pitchFamily="34" charset="0"/>
                 <a:ea typeface="Times New Roman" pitchFamily="34" charset="-122"/>
@@ -2491,7 +2491,7 @@
             <a:r>
               <a:rPr lang="en-US" sz="1150" dirty="0">
                 <a:solidFill>
-                  <a:srgbClr val="F6F2E9"/>
+                  <a:srgbClr val="C6CAD8"/>
                 </a:solidFill>
                 <a:latin typeface="Calibri" pitchFamily="34" charset="0"/>
                 <a:ea typeface="Calibri" pitchFamily="34" charset="-122"/>
@@ -2511,7 +2511,7 @@
             <a:r>
               <a:rPr lang="en-US" sz="1150" dirty="0">
                 <a:solidFill>
-                  <a:srgbClr val="F6F2E9"/>
+                  <a:srgbClr val="C6CAD8"/>
                 </a:solidFill>
                 <a:latin typeface="Calibri" pitchFamily="34" charset="0"/>
                 <a:ea typeface="Calibri" pitchFamily="34" charset="-122"/>
@@ -2538,7 +2538,7 @@
             <a:avLst/>
           </a:prstGeom>
           <a:solidFill>
-            <a:srgbClr val="E5B23C"/>
+            <a:srgbClr val="E6B94A"/>
           </a:solidFill>
           <a:ln/>
         </p:spPr>
@@ -2570,7 +2570,7 @@
             <a:r>
               <a:rPr lang="en-US" sz="1200" b="1" dirty="0">
                 <a:solidFill>
-                  <a:srgbClr val="E5B23C"/>
+                  <a:srgbClr val="E6B94A"/>
                 </a:solidFill>
                 <a:latin typeface="Calibri" pitchFamily="34" charset="0"/>
                 <a:ea typeface="Calibri" pitchFamily="34" charset="-122"/>
@@ -2609,7 +2609,7 @@
             <a:r>
               <a:rPr lang="en-US" sz="1600" b="1" dirty="0">
                 <a:solidFill>
-                  <a:srgbClr val="FFFFFF"/>
+                  <a:srgbClr val="F5F6FA"/>
                 </a:solidFill>
                 <a:latin typeface="Times New Roman" pitchFamily="34" charset="0"/>
                 <a:ea typeface="Times New Roman" pitchFamily="34" charset="-122"/>
@@ -2651,7 +2651,7 @@
             <a:r>
               <a:rPr lang="en-US" sz="1150" dirty="0">
                 <a:solidFill>
-                  <a:srgbClr val="F6F2E9"/>
+                  <a:srgbClr val="C6CAD8"/>
                 </a:solidFill>
                 <a:latin typeface="Calibri" pitchFamily="34" charset="0"/>
                 <a:ea typeface="Calibri" pitchFamily="34" charset="-122"/>
@@ -2671,7 +2671,7 @@
             <a:r>
               <a:rPr lang="en-US" sz="1150" dirty="0">
                 <a:solidFill>
-                  <a:srgbClr val="F6F2E9"/>
+                  <a:srgbClr val="C6CAD8"/>
                 </a:solidFill>
                 <a:latin typeface="Calibri" pitchFamily="34" charset="0"/>
                 <a:ea typeface="Calibri" pitchFamily="34" charset="-122"/>
@@ -2698,7 +2698,7 @@
             <a:avLst/>
           </a:prstGeom>
           <a:solidFill>
-            <a:srgbClr val="E5B23C"/>
+            <a:srgbClr val="E6B94A"/>
           </a:solidFill>
           <a:ln/>
         </p:spPr>
@@ -2730,7 +2730,7 @@
             <a:r>
               <a:rPr lang="en-US" sz="1200" b="1" dirty="0">
                 <a:solidFill>
-                  <a:srgbClr val="E5B23C"/>
+                  <a:srgbClr val="E6B94A"/>
                 </a:solidFill>
                 <a:latin typeface="Calibri" pitchFamily="34" charset="0"/>
                 <a:ea typeface="Calibri" pitchFamily="34" charset="-122"/>
@@ -2769,7 +2769,7 @@
             <a:r>
               <a:rPr lang="en-US" sz="1600" b="1" dirty="0">
                 <a:solidFill>
-                  <a:srgbClr val="FFFFFF"/>
+                  <a:srgbClr val="F5F6FA"/>
                 </a:solidFill>
                 <a:latin typeface="Times New Roman" pitchFamily="34" charset="0"/>
                 <a:ea typeface="Times New Roman" pitchFamily="34" charset="-122"/>
@@ -2811,7 +2811,7 @@
             <a:r>
               <a:rPr lang="en-US" sz="1150" dirty="0">
                 <a:solidFill>
-                  <a:srgbClr val="F6F2E9"/>
+                  <a:srgbClr val="C6CAD8"/>
                 </a:solidFill>
                 <a:latin typeface="Calibri" pitchFamily="34" charset="0"/>
                 <a:ea typeface="Calibri" pitchFamily="34" charset="-122"/>
@@ -2831,7 +2831,7 @@
             <a:r>
               <a:rPr lang="en-US" sz="1150" dirty="0">
                 <a:solidFill>
-                  <a:srgbClr val="F6F2E9"/>
+                  <a:srgbClr val="C6CAD8"/>
                 </a:solidFill>
                 <a:latin typeface="Calibri" pitchFamily="34" charset="0"/>
                 <a:ea typeface="Calibri" pitchFamily="34" charset="-122"/>
@@ -2858,7 +2858,7 @@
             <a:avLst/>
           </a:prstGeom>
           <a:solidFill>
-            <a:srgbClr val="E5B23C"/>
+            <a:srgbClr val="E6B94A"/>
           </a:solidFill>
           <a:ln/>
         </p:spPr>
@@ -2890,7 +2890,7 @@
             <a:r>
               <a:rPr lang="en-US" sz="1200" b="1" dirty="0">
                 <a:solidFill>
-                  <a:srgbClr val="E5B23C"/>
+                  <a:srgbClr val="E6B94A"/>
                 </a:solidFill>
                 <a:latin typeface="Calibri" pitchFamily="34" charset="0"/>
                 <a:ea typeface="Calibri" pitchFamily="34" charset="-122"/>
@@ -2929,7 +2929,7 @@
             <a:r>
               <a:rPr lang="en-US" sz="1600" b="1" dirty="0">
                 <a:solidFill>
-                  <a:srgbClr val="FFFFFF"/>
+                  <a:srgbClr val="F5F6FA"/>
                 </a:solidFill>
                 <a:latin typeface="Times New Roman" pitchFamily="34" charset="0"/>
                 <a:ea typeface="Times New Roman" pitchFamily="34" charset="-122"/>
@@ -2971,7 +2971,7 @@
             <a:r>
               <a:rPr lang="en-US" sz="1150" dirty="0">
                 <a:solidFill>
-                  <a:srgbClr val="F6F2E9"/>
+                  <a:srgbClr val="C6CAD8"/>
                 </a:solidFill>
                 <a:latin typeface="Calibri" pitchFamily="34" charset="0"/>
                 <a:ea typeface="Calibri" pitchFamily="34" charset="-122"/>
@@ -2991,7 +2991,7 @@
             <a:r>
               <a:rPr lang="en-US" sz="1150" dirty="0">
                 <a:solidFill>
-                  <a:srgbClr val="F6F2E9"/>
+                  <a:srgbClr val="C6CAD8"/>
                 </a:solidFill>
                 <a:latin typeface="Calibri" pitchFamily="34" charset="0"/>
                 <a:ea typeface="Calibri" pitchFamily="34" charset="-122"/>
@@ -3018,13 +3018,18 @@
             <a:avLst/>
           </a:prstGeom>
           <a:solidFill>
-            <a:srgbClr val="FFFFFF"/>
-          </a:solidFill>
-          <a:ln/>
+            <a:srgbClr val="181C28"/>
+          </a:solidFill>
+          <a:ln w="12700">
+            <a:solidFill>
+              <a:srgbClr val="2E3447"/>
+            </a:solidFill>
+            <a:prstDash val="solid"/>
+          </a:ln>
           <a:effectLst>
-            <a:outerShdw sx="100000" sy="100000" kx="0" ky="0" algn="bl" rotWithShape="0" blurRad="101600" dist="38100" dir="8100000">
+            <a:outerShdw sx="100000" sy="100000" kx="0" ky="0" algn="bl" rotWithShape="0" blurRad="127000" dist="38100" dir="8100000">
               <a:srgbClr val="000000">
-                <a:alpha val="18000"/>
+                <a:alpha val="40000"/>
               </a:srgbClr>
             </a:outerShdw>
           </a:effectLst>
@@ -3045,7 +3050,7 @@
             <a:avLst/>
           </a:prstGeom>
           <a:solidFill>
-            <a:srgbClr val="0B3D54"/>
+            <a:srgbClr val="E6B94A"/>
           </a:solidFill>
           <a:ln/>
         </p:spPr>
@@ -3066,8 +3071,8 @@
         </p:blipFill>
         <p:spPr>
           <a:xfrm>
-            <a:off x="996696" y="4562856"/>
-            <a:ext cx="338328" cy="338328"/>
+            <a:off x="1029157" y="4595317"/>
+            <a:ext cx="273406" cy="273406"/>
           </a:xfrm>
           <a:prstGeom prst="rect">
             <a:avLst/>
@@ -3101,7 +3106,7 @@
             <a:r>
               <a:rPr lang="en-US" sz="1650" b="1" dirty="0">
                 <a:solidFill>
-                  <a:srgbClr val="0B3D54"/>
+                  <a:srgbClr val="F5F6FA"/>
                 </a:solidFill>
                 <a:latin typeface="Times New Roman" pitchFamily="34" charset="0"/>
                 <a:ea typeface="Times New Roman" pitchFamily="34" charset="-122"/>
@@ -3143,7 +3148,7 @@
             <a:r>
               <a:rPr lang="en-US" sz="1250" dirty="0">
                 <a:solidFill>
-                  <a:srgbClr val="1A2A33"/>
+                  <a:srgbClr val="C6CAD8"/>
                 </a:solidFill>
                 <a:latin typeface="Calibri" pitchFamily="34" charset="0"/>
                 <a:ea typeface="Calibri" pitchFamily="34" charset="-122"/>
@@ -3170,7 +3175,7 @@
             <a:avLst/>
           </a:prstGeom>
           <a:solidFill>
-            <a:srgbClr val="E5B23C"/>
+            <a:srgbClr val="E6B94A"/>
           </a:solidFill>
           <a:ln/>
         </p:spPr>
@@ -3202,7 +3207,7 @@
             <a:r>
               <a:rPr lang="en-US" sz="1800" b="1" dirty="0">
                 <a:solidFill>
-                  <a:srgbClr val="0B3D54"/>
+                  <a:srgbClr val="07080C"/>
                 </a:solidFill>
                 <a:latin typeface="Times New Roman" pitchFamily="34" charset="0"/>
                 <a:ea typeface="Times New Roman" pitchFamily="34" charset="-122"/>
@@ -3304,7 +3309,7 @@
             <a:r>
               <a:rPr lang="en-US" sz="1200" b="1" dirty="0">
                 <a:solidFill>
-                  <a:srgbClr val="0B3D54"/>
+                  <a:srgbClr val="07080C"/>
                 </a:solidFill>
                 <a:latin typeface="Calibri" pitchFamily="34" charset="0"/>
                 <a:ea typeface="Calibri" pitchFamily="34" charset="-122"/>
@@ -3367,7 +3372,7 @@
             <a:r>
               <a:rPr lang="en-US" sz="1100" dirty="0">
                 <a:solidFill>
-                  <a:srgbClr val="0B3D54"/>
+                  <a:srgbClr val="07080C"/>
                 </a:solidFill>
                 <a:latin typeface="Calibri" pitchFamily="34" charset="0"/>
                 <a:ea typeface="Calibri" pitchFamily="34" charset="-122"/>
@@ -3406,7 +3411,7 @@
             <a:r>
               <a:rPr lang="en-US" sz="1000" dirty="0">
                 <a:solidFill>
-                  <a:srgbClr val="F6F2E9"/>
+                  <a:srgbClr val="5E6478"/>
                 </a:solidFill>
                 <a:latin typeface="Calibri" pitchFamily="34" charset="0"/>
                 <a:ea typeface="Calibri" pitchFamily="34" charset="-122"/>
@@ -3445,7 +3450,7 @@
             <a:r>
               <a:rPr lang="en-US" sz="1000" dirty="0">
                 <a:solidFill>
-                  <a:srgbClr val="F6F2E9"/>
+                  <a:srgbClr val="5E6478"/>
                 </a:solidFill>
                 <a:latin typeface="Calibri" pitchFamily="34" charset="0"/>
                 <a:ea typeface="Calibri" pitchFamily="34" charset="-122"/>
@@ -3471,7 +3476,7 @@
     <p:bg>
       <p:bgPr>
         <a:solidFill>
-          <a:srgbClr val="F6F2E9"/>
+          <a:srgbClr val="0C0E15"/>
         </a:solidFill>
       </p:bgPr>
     </p:bg>
@@ -3498,7 +3503,7 @@
         <p:spPr>
           <a:xfrm>
             <a:off x="640080" y="457200"/>
-            <a:ext cx="10515600" cy="320040"/>
+            <a:ext cx="10789920" cy="320040"/>
           </a:xfrm>
           <a:prstGeom prst="rect">
             <a:avLst/>
@@ -3516,7 +3521,7 @@
             <a:r>
               <a:rPr lang="en-US" sz="1200" b="1" spc="200" kern="0" dirty="0">
                 <a:solidFill>
-                  <a:srgbClr val="E5B23C"/>
+                  <a:srgbClr val="E6B94A"/>
                 </a:solidFill>
                 <a:latin typeface="Calibri" pitchFamily="34" charset="0"/>
                 <a:ea typeface="Calibri" pitchFamily="34" charset="-122"/>
@@ -3555,7 +3560,7 @@
             <a:r>
               <a:rPr lang="en-US" sz="3200" b="1" dirty="0">
                 <a:solidFill>
-                  <a:srgbClr val="0B3D54"/>
+                  <a:srgbClr val="F5F6FA"/>
                 </a:solidFill>
                 <a:latin typeface="Times New Roman" pitchFamily="34" charset="0"/>
                 <a:ea typeface="Times New Roman" pitchFamily="34" charset="-122"/>
@@ -3597,7 +3602,7 @@
             <a:r>
               <a:rPr lang="en-US" sz="1600" dirty="0">
                 <a:solidFill>
-                  <a:srgbClr val="1A2A33"/>
+                  <a:srgbClr val="C6CAD8"/>
                 </a:solidFill>
                 <a:latin typeface="Calibri" pitchFamily="34" charset="0"/>
                 <a:ea typeface="Calibri" pitchFamily="34" charset="-122"/>
@@ -3624,7 +3629,7 @@
             <a:avLst/>
           </a:prstGeom>
           <a:solidFill>
-            <a:srgbClr val="E5B23C"/>
+            <a:srgbClr val="E6B94A"/>
           </a:solidFill>
           <a:ln/>
         </p:spPr>
@@ -3659,13 +3664,13 @@
             <a:r>
               <a:rPr lang="en-US" sz="1600" b="1" dirty="0">
                 <a:solidFill>
-                  <a:srgbClr val="0B3D54"/>
-                </a:solidFill>
-                <a:latin typeface="Calibri" pitchFamily="34" charset="0"/>
-                <a:ea typeface="Calibri" pitchFamily="34" charset="-122"/>
-                <a:cs typeface="Calibri" pitchFamily="34" charset="-120"/>
-              </a:rPr>
-              <a:t>Басты кемшілік - эмпатиялық байланыстың жоқтығы.
+                  <a:srgbClr val="E6B94A"/>
+                </a:solidFill>
+                <a:latin typeface="Calibri" pitchFamily="34" charset="0"/>
+                <a:ea typeface="Calibri" pitchFamily="34" charset="-122"/>
+                <a:cs typeface="Calibri" pitchFamily="34" charset="-120"/>
+              </a:rPr>
+              <a:t>Басты кемшілік — эмпатиялық байланыстың жоқтығы.
 </a:t>
             </a:r>
             <a:pPr indent="0" marL="0">
@@ -3677,7 +3682,7 @@
             <a:r>
               <a:rPr lang="en-US" sz="1500" dirty="0">
                 <a:solidFill>
-                  <a:srgbClr val="1A2A33"/>
+                  <a:srgbClr val="C6CAD8"/>
                 </a:solidFill>
                 <a:latin typeface="Calibri" pitchFamily="34" charset="0"/>
                 <a:ea typeface="Calibri" pitchFamily="34" charset="-122"/>
@@ -3704,18 +3709,18 @@
             <a:avLst/>
           </a:prstGeom>
           <a:solidFill>
-            <a:srgbClr val="FFFFFF"/>
+            <a:srgbClr val="181C28"/>
           </a:solidFill>
           <a:ln w="12700">
             <a:solidFill>
-              <a:srgbClr val="D9D0BE"/>
+              <a:srgbClr val="2E3447"/>
             </a:solidFill>
             <a:prstDash val="solid"/>
           </a:ln>
           <a:effectLst>
-            <a:outerShdw sx="100000" sy="100000" kx="0" ky="0" algn="bl" rotWithShape="0" blurRad="101600" dist="38100" dir="8100000">
+            <a:outerShdw sx="100000" sy="100000" kx="0" ky="0" algn="bl" rotWithShape="0" blurRad="127000" dist="38100" dir="8100000">
               <a:srgbClr val="000000">
-                <a:alpha val="18000"/>
+                <a:alpha val="40000"/>
               </a:srgbClr>
             </a:outerShdw>
           </a:effectLst>
@@ -3736,7 +3741,7 @@
             <a:avLst/>
           </a:prstGeom>
           <a:solidFill>
-            <a:srgbClr val="0B3D54"/>
+            <a:srgbClr val="E6B94A"/>
           </a:solidFill>
           <a:ln/>
         </p:spPr>
@@ -3757,8 +3762,8 @@
         </p:blipFill>
         <p:spPr>
           <a:xfrm>
-            <a:off x="6830568" y="2185416"/>
-            <a:ext cx="347472" cy="347472"/>
+            <a:off x="6873911" y="2228759"/>
+            <a:ext cx="260787" cy="260787"/>
           </a:xfrm>
           <a:prstGeom prst="rect">
             <a:avLst/>
@@ -3792,7 +3797,7 @@
             <a:r>
               <a:rPr lang="en-US" sz="1900" b="1" dirty="0">
                 <a:solidFill>
-                  <a:srgbClr val="0B3D54"/>
+                  <a:srgbClr val="F5F6FA"/>
                 </a:solidFill>
                 <a:latin typeface="Times New Roman" pitchFamily="34" charset="0"/>
                 <a:ea typeface="Times New Roman" pitchFamily="34" charset="-122"/>
@@ -3831,7 +3836,7 @@
             <a:r>
               <a:rPr lang="en-US" sz="1300" dirty="0">
                 <a:solidFill>
-                  <a:srgbClr val="5E6B72"/>
+                  <a:srgbClr val="8B91A4"/>
                 </a:solidFill>
                 <a:latin typeface="Calibri" pitchFamily="34" charset="0"/>
                 <a:ea typeface="Calibri" pitchFamily="34" charset="-122"/>
@@ -3858,18 +3863,18 @@
             <a:avLst/>
           </a:prstGeom>
           <a:solidFill>
-            <a:srgbClr val="FFFFFF"/>
+            <a:srgbClr val="181C28"/>
           </a:solidFill>
           <a:ln w="12700">
             <a:solidFill>
-              <a:srgbClr val="D9D0BE"/>
+              <a:srgbClr val="2E3447"/>
             </a:solidFill>
             <a:prstDash val="solid"/>
           </a:ln>
           <a:effectLst>
-            <a:outerShdw sx="100000" sy="100000" kx="0" ky="0" algn="bl" rotWithShape="0" blurRad="101600" dist="38100" dir="8100000">
+            <a:outerShdw sx="100000" sy="100000" kx="0" ky="0" algn="bl" rotWithShape="0" blurRad="127000" dist="38100" dir="8100000">
               <a:srgbClr val="000000">
-                <a:alpha val="18000"/>
+                <a:alpha val="40000"/>
               </a:srgbClr>
             </a:outerShdw>
           </a:effectLst>
@@ -3890,7 +3895,7 @@
             <a:avLst/>
           </a:prstGeom>
           <a:solidFill>
-            <a:srgbClr val="0B3D54"/>
+            <a:srgbClr val="E6B94A"/>
           </a:solidFill>
           <a:ln/>
         </p:spPr>
@@ -3911,8 +3916,8 @@
         </p:blipFill>
         <p:spPr>
           <a:xfrm>
-            <a:off x="6830568" y="3675888"/>
-            <a:ext cx="347472" cy="347472"/>
+            <a:off x="6873911" y="3719231"/>
+            <a:ext cx="260787" cy="260787"/>
           </a:xfrm>
           <a:prstGeom prst="rect">
             <a:avLst/>
@@ -3946,7 +3951,7 @@
             <a:r>
               <a:rPr lang="en-US" sz="1900" b="1" dirty="0">
                 <a:solidFill>
-                  <a:srgbClr val="0B3D54"/>
+                  <a:srgbClr val="F5F6FA"/>
                 </a:solidFill>
                 <a:latin typeface="Times New Roman" pitchFamily="34" charset="0"/>
                 <a:ea typeface="Times New Roman" pitchFamily="34" charset="-122"/>
@@ -3985,7 +3990,7 @@
             <a:r>
               <a:rPr lang="en-US" sz="1300" dirty="0">
                 <a:solidFill>
-                  <a:srgbClr val="5E6B72"/>
+                  <a:srgbClr val="8B91A4"/>
                 </a:solidFill>
                 <a:latin typeface="Calibri" pitchFamily="34" charset="0"/>
                 <a:ea typeface="Calibri" pitchFamily="34" charset="-122"/>
@@ -4012,18 +4017,18 @@
             <a:avLst/>
           </a:prstGeom>
           <a:solidFill>
-            <a:srgbClr val="FFFFFF"/>
+            <a:srgbClr val="181C28"/>
           </a:solidFill>
           <a:ln w="12700">
             <a:solidFill>
-              <a:srgbClr val="D9D0BE"/>
+              <a:srgbClr val="2E3447"/>
             </a:solidFill>
             <a:prstDash val="solid"/>
           </a:ln>
           <a:effectLst>
-            <a:outerShdw sx="100000" sy="100000" kx="0" ky="0" algn="bl" rotWithShape="0" blurRad="101600" dist="38100" dir="8100000">
+            <a:outerShdw sx="100000" sy="100000" kx="0" ky="0" algn="bl" rotWithShape="0" blurRad="127000" dist="38100" dir="8100000">
               <a:srgbClr val="000000">
-                <a:alpha val="18000"/>
+                <a:alpha val="40000"/>
               </a:srgbClr>
             </a:outerShdw>
           </a:effectLst>
@@ -4044,7 +4049,7 @@
             <a:avLst/>
           </a:prstGeom>
           <a:solidFill>
-            <a:srgbClr val="0B3D54"/>
+            <a:srgbClr val="E6B94A"/>
           </a:solidFill>
           <a:ln/>
         </p:spPr>
@@ -4065,8 +4070,8 @@
         </p:blipFill>
         <p:spPr>
           <a:xfrm>
-            <a:off x="6830568" y="5166360"/>
-            <a:ext cx="347472" cy="347472"/>
+            <a:off x="6873911" y="5209703"/>
+            <a:ext cx="260787" cy="260787"/>
           </a:xfrm>
           <a:prstGeom prst="rect">
             <a:avLst/>
@@ -4100,7 +4105,7 @@
             <a:r>
               <a:rPr lang="en-US" sz="1900" b="1" dirty="0">
                 <a:solidFill>
-                  <a:srgbClr val="0B3D54"/>
+                  <a:srgbClr val="F5F6FA"/>
                 </a:solidFill>
                 <a:latin typeface="Times New Roman" pitchFamily="34" charset="0"/>
                 <a:ea typeface="Times New Roman" pitchFamily="34" charset="-122"/>
@@ -4139,7 +4144,7 @@
             <a:r>
               <a:rPr lang="en-US" sz="1300" dirty="0">
                 <a:solidFill>
-                  <a:srgbClr val="5E6B72"/>
+                  <a:srgbClr val="8B91A4"/>
                 </a:solidFill>
                 <a:latin typeface="Calibri" pitchFamily="34" charset="0"/>
                 <a:ea typeface="Calibri" pitchFamily="34" charset="-122"/>
@@ -4178,7 +4183,7 @@
             <a:r>
               <a:rPr lang="en-US" sz="1000" dirty="0">
                 <a:solidFill>
-                  <a:srgbClr val="5E6B72"/>
+                  <a:srgbClr val="5E6478"/>
                 </a:solidFill>
                 <a:latin typeface="Calibri" pitchFamily="34" charset="0"/>
                 <a:ea typeface="Calibri" pitchFamily="34" charset="-122"/>
@@ -4217,7 +4222,7 @@
             <a:r>
               <a:rPr lang="en-US" sz="1000" dirty="0">
                 <a:solidFill>
-                  <a:srgbClr val="5E6B72"/>
+                  <a:srgbClr val="5E6478"/>
                 </a:solidFill>
                 <a:latin typeface="Calibri" pitchFamily="34" charset="0"/>
                 <a:ea typeface="Calibri" pitchFamily="34" charset="-122"/>
@@ -4243,7 +4248,7 @@
     <p:bg>
       <p:bgPr>
         <a:solidFill>
-          <a:srgbClr val="0B3D54"/>
+          <a:srgbClr val="0C0E15"/>
         </a:solidFill>
       </p:bgPr>
     </p:bg>
@@ -4270,7 +4275,7 @@
         <p:spPr>
           <a:xfrm>
             <a:off x="640080" y="457200"/>
-            <a:ext cx="10515600" cy="320040"/>
+            <a:ext cx="10789920" cy="320040"/>
           </a:xfrm>
           <a:prstGeom prst="rect">
             <a:avLst/>
@@ -4288,7 +4293,7 @@
             <a:r>
               <a:rPr lang="en-US" sz="1200" b="1" spc="200" kern="0" dirty="0">
                 <a:solidFill>
-                  <a:srgbClr val="E5B23C"/>
+                  <a:srgbClr val="E6B94A"/>
                 </a:solidFill>
                 <a:latin typeface="Calibri" pitchFamily="34" charset="0"/>
                 <a:ea typeface="Calibri" pitchFamily="34" charset="-122"/>
@@ -4327,13 +4332,13 @@
             <a:r>
               <a:rPr lang="en-US" sz="3200" b="1" dirty="0">
                 <a:solidFill>
-                  <a:srgbClr val="FFFFFF"/>
+                  <a:srgbClr val="F5F6FA"/>
                 </a:solidFill>
                 <a:latin typeface="Times New Roman" pitchFamily="34" charset="0"/>
                 <a:ea typeface="Times New Roman" pitchFamily="34" charset="-122"/>
                 <a:cs typeface="Times New Roman" pitchFamily="34" charset="-120"/>
               </a:rPr>
-              <a:t>Оқудан - сұхбатқа</a:t>
+              <a:t>Оқудан — сұхбатқа</a:t>
             </a:r>
             <a:endParaRPr lang="en-US" sz="3200" dirty="0"/>
           </a:p>
@@ -4369,7 +4374,7 @@
             <a:r>
               <a:rPr lang="en-US" sz="1700" dirty="0">
                 <a:solidFill>
-                  <a:srgbClr val="F6F2E9"/>
+                  <a:srgbClr val="C6CAD8"/>
                 </a:solidFill>
                 <a:latin typeface="Calibri" pitchFamily="34" charset="0"/>
                 <a:ea typeface="Calibri" pitchFamily="34" charset="-122"/>
@@ -4396,13 +4401,18 @@
             <a:avLst/>
           </a:prstGeom>
           <a:solidFill>
-            <a:srgbClr val="FFFFFF"/>
-          </a:solidFill>
-          <a:ln/>
+            <a:srgbClr val="181C28"/>
+          </a:solidFill>
+          <a:ln w="12700">
+            <a:solidFill>
+              <a:srgbClr val="2E3447"/>
+            </a:solidFill>
+            <a:prstDash val="solid"/>
+          </a:ln>
           <a:effectLst>
-            <a:outerShdw sx="100000" sy="100000" kx="0" ky="0" algn="bl" rotWithShape="0" blurRad="101600" dist="38100" dir="8100000">
+            <a:outerShdw sx="100000" sy="100000" kx="0" ky="0" algn="bl" rotWithShape="0" blurRad="127000" dist="38100" dir="8100000">
               <a:srgbClr val="000000">
-                <a:alpha val="18000"/>
+                <a:alpha val="40000"/>
               </a:srgbClr>
             </a:outerShdw>
           </a:effectLst>
@@ -4423,7 +4433,7 @@
             <a:avLst/>
           </a:prstGeom>
           <a:solidFill>
-            <a:srgbClr val="E5B23C"/>
+            <a:srgbClr val="E6B94A"/>
           </a:solidFill>
           <a:ln/>
         </p:spPr>
@@ -4443,7 +4453,7 @@
             <a:avLst/>
           </a:prstGeom>
           <a:solidFill>
-            <a:srgbClr val="0B3D54"/>
+            <a:srgbClr val="E6B94A"/>
           </a:solidFill>
           <a:ln/>
         </p:spPr>
@@ -4464,8 +4474,8 @@
         </p:blipFill>
         <p:spPr>
           <a:xfrm>
-            <a:off x="1261872" y="3273552"/>
-            <a:ext cx="457200" cy="457200"/>
+            <a:off x="1286104" y="3297784"/>
+            <a:ext cx="399593" cy="399593"/>
           </a:xfrm>
           <a:prstGeom prst="rect">
             <a:avLst/>
@@ -4502,7 +4512,7 @@
             <a:r>
               <a:rPr lang="en-US" sz="1900" b="1" dirty="0">
                 <a:solidFill>
-                  <a:srgbClr val="0B3D54"/>
+                  <a:srgbClr val="F5F6FA"/>
                 </a:solidFill>
                 <a:latin typeface="Times New Roman" pitchFamily="34" charset="0"/>
                 <a:ea typeface="Times New Roman" pitchFamily="34" charset="-122"/>
@@ -4544,7 +4554,7 @@
             <a:r>
               <a:rPr lang="en-US" sz="1300" dirty="0">
                 <a:solidFill>
-                  <a:srgbClr val="1A2A33"/>
+                  <a:srgbClr val="C6CAD8"/>
                 </a:solidFill>
                 <a:latin typeface="Calibri" pitchFamily="34" charset="0"/>
                 <a:ea typeface="Calibri" pitchFamily="34" charset="-122"/>
@@ -4571,13 +4581,18 @@
             <a:avLst/>
           </a:prstGeom>
           <a:solidFill>
-            <a:srgbClr val="FFFFFF"/>
-          </a:solidFill>
-          <a:ln/>
+            <a:srgbClr val="181C28"/>
+          </a:solidFill>
+          <a:ln w="12700">
+            <a:solidFill>
+              <a:srgbClr val="2E3447"/>
+            </a:solidFill>
+            <a:prstDash val="solid"/>
+          </a:ln>
           <a:effectLst>
-            <a:outerShdw sx="100000" sy="100000" kx="0" ky="0" algn="bl" rotWithShape="0" blurRad="101600" dist="38100" dir="8100000">
+            <a:outerShdw sx="100000" sy="100000" kx="0" ky="0" algn="bl" rotWithShape="0" blurRad="127000" dist="38100" dir="8100000">
               <a:srgbClr val="000000">
-                <a:alpha val="18000"/>
+                <a:alpha val="40000"/>
               </a:srgbClr>
             </a:outerShdw>
           </a:effectLst>
@@ -4598,7 +4613,7 @@
             <a:avLst/>
           </a:prstGeom>
           <a:solidFill>
-            <a:srgbClr val="E5B23C"/>
+            <a:srgbClr val="E6B94A"/>
           </a:solidFill>
           <a:ln/>
         </p:spPr>
@@ -4618,7 +4633,7 @@
             <a:avLst/>
           </a:prstGeom>
           <a:solidFill>
-            <a:srgbClr val="0B3D54"/>
+            <a:srgbClr val="E6B94A"/>
           </a:solidFill>
           <a:ln/>
         </p:spPr>
@@ -4639,8 +4654,8 @@
         </p:blipFill>
         <p:spPr>
           <a:xfrm>
-            <a:off x="6931152" y="3273552"/>
-            <a:ext cx="457200" cy="457200"/>
+            <a:off x="6955384" y="3297784"/>
+            <a:ext cx="399593" cy="399593"/>
           </a:xfrm>
           <a:prstGeom prst="rect">
             <a:avLst/>
@@ -4677,7 +4692,7 @@
             <a:r>
               <a:rPr lang="en-US" sz="1900" b="1" dirty="0">
                 <a:solidFill>
-                  <a:srgbClr val="0B3D54"/>
+                  <a:srgbClr val="F5F6FA"/>
                 </a:solidFill>
                 <a:latin typeface="Times New Roman" pitchFamily="34" charset="0"/>
                 <a:ea typeface="Times New Roman" pitchFamily="34" charset="-122"/>
@@ -4719,7 +4734,7 @@
             <a:r>
               <a:rPr lang="en-US" sz="1300" dirty="0">
                 <a:solidFill>
-                  <a:srgbClr val="1A2A33"/>
+                  <a:srgbClr val="C6CAD8"/>
                 </a:solidFill>
                 <a:latin typeface="Calibri" pitchFamily="34" charset="0"/>
                 <a:ea typeface="Calibri" pitchFamily="34" charset="-122"/>
@@ -4758,7 +4773,7 @@
             <a:r>
               <a:rPr lang="en-US" sz="1000" dirty="0">
                 <a:solidFill>
-                  <a:srgbClr val="F6F2E9"/>
+                  <a:srgbClr val="5E6478"/>
                 </a:solidFill>
                 <a:latin typeface="Calibri" pitchFamily="34" charset="0"/>
                 <a:ea typeface="Calibri" pitchFamily="34" charset="-122"/>
@@ -4797,7 +4812,7 @@
             <a:r>
               <a:rPr lang="en-US" sz="1000" dirty="0">
                 <a:solidFill>
-                  <a:srgbClr val="F6F2E9"/>
+                  <a:srgbClr val="5E6478"/>
                 </a:solidFill>
                 <a:latin typeface="Calibri" pitchFamily="34" charset="0"/>
                 <a:ea typeface="Calibri" pitchFamily="34" charset="-122"/>
@@ -4823,7 +4838,7 @@
     <p:bg>
       <p:bgPr>
         <a:solidFill>
-          <a:srgbClr val="F6F2E9"/>
+          <a:srgbClr val="0C0E15"/>
         </a:solidFill>
       </p:bgPr>
     </p:bg>
@@ -4850,7 +4865,7 @@
         <p:spPr>
           <a:xfrm>
             <a:off x="640080" y="457200"/>
-            <a:ext cx="10515600" cy="320040"/>
+            <a:ext cx="10789920" cy="320040"/>
           </a:xfrm>
           <a:prstGeom prst="rect">
             <a:avLst/>
@@ -4868,7 +4883,7 @@
             <a:r>
               <a:rPr lang="en-US" sz="1200" b="1" spc="200" kern="0" dirty="0">
                 <a:solidFill>
-                  <a:srgbClr val="E5B23C"/>
+                  <a:srgbClr val="E6B94A"/>
                 </a:solidFill>
                 <a:latin typeface="Calibri" pitchFamily="34" charset="0"/>
                 <a:ea typeface="Calibri" pitchFamily="34" charset="-122"/>
@@ -4907,13 +4922,13 @@
             <a:r>
               <a:rPr lang="en-US" sz="3200" b="1" dirty="0">
                 <a:solidFill>
-                  <a:srgbClr val="0B3D54"/>
+                  <a:srgbClr val="F5F6FA"/>
                 </a:solidFill>
                 <a:latin typeface="Times New Roman" pitchFamily="34" charset="0"/>
                 <a:ea typeface="Times New Roman" pitchFamily="34" charset="-122"/>
                 <a:cs typeface="Times New Roman" pitchFamily="34" charset="-120"/>
               </a:rPr>
-              <a:t>Үш қадамда - тарихпен жанды байланыс</a:t>
+              <a:t>Үш қадамда — тарихпен жанды байланыс</a:t>
             </a:r>
             <a:endParaRPr lang="en-US" sz="3200" dirty="0"/>
           </a:p>
@@ -4934,18 +4949,18 @@
             <a:avLst/>
           </a:prstGeom>
           <a:solidFill>
-            <a:srgbClr val="FFFFFF"/>
+            <a:srgbClr val="181C28"/>
           </a:solidFill>
           <a:ln w="12700">
             <a:solidFill>
-              <a:srgbClr val="D9D0BE"/>
+              <a:srgbClr val="2E3447"/>
             </a:solidFill>
             <a:prstDash val="solid"/>
           </a:ln>
           <a:effectLst>
-            <a:outerShdw sx="100000" sy="100000" kx="0" ky="0" algn="bl" rotWithShape="0" blurRad="101600" dist="38100" dir="8100000">
+            <a:outerShdw sx="100000" sy="100000" kx="0" ky="0" algn="bl" rotWithShape="0" blurRad="127000" dist="38100" dir="8100000">
               <a:srgbClr val="000000">
-                <a:alpha val="18000"/>
+                <a:alpha val="40000"/>
               </a:srgbClr>
             </a:outerShdw>
           </a:effectLst>
@@ -4978,7 +4993,7 @@
             <a:r>
               <a:rPr lang="en-US" sz="4000" b="1" dirty="0">
                 <a:solidFill>
-                  <a:srgbClr val="D6BE8C"/>
+                  <a:srgbClr val="5E6478"/>
                 </a:solidFill>
                 <a:latin typeface="Times New Roman" pitchFamily="34" charset="0"/>
                 <a:ea typeface="Times New Roman" pitchFamily="34" charset="-122"/>
@@ -5005,7 +5020,7 @@
             <a:avLst/>
           </a:prstGeom>
           <a:solidFill>
-            <a:srgbClr val="0B3D54"/>
+            <a:srgbClr val="E6B94A"/>
           </a:solidFill>
           <a:ln/>
         </p:spPr>
@@ -5026,8 +5041,8 @@
         </p:blipFill>
         <p:spPr>
           <a:xfrm>
-            <a:off x="3282696" y="2414016"/>
-            <a:ext cx="402336" cy="402336"/>
+            <a:off x="3311408" y="2442728"/>
+            <a:ext cx="344912" cy="344912"/>
           </a:xfrm>
           <a:prstGeom prst="rect">
             <a:avLst/>
@@ -5061,7 +5076,7 @@
             <a:r>
               <a:rPr lang="en-US" sz="1650" b="1" dirty="0">
                 <a:solidFill>
-                  <a:srgbClr val="0B3D54"/>
+                  <a:srgbClr val="F5F6FA"/>
                 </a:solidFill>
                 <a:latin typeface="Times New Roman" pitchFamily="34" charset="0"/>
                 <a:ea typeface="Times New Roman" pitchFamily="34" charset="-122"/>
@@ -5103,7 +5118,7 @@
             <a:r>
               <a:rPr lang="en-US" sz="1250" dirty="0">
                 <a:solidFill>
-                  <a:srgbClr val="1A2A33"/>
+                  <a:srgbClr val="C6CAD8"/>
                 </a:solidFill>
                 <a:latin typeface="Calibri" pitchFamily="34" charset="0"/>
                 <a:ea typeface="Calibri" pitchFamily="34" charset="-122"/>
@@ -5130,18 +5145,18 @@
             <a:avLst/>
           </a:prstGeom>
           <a:solidFill>
-            <a:srgbClr val="FFFFFF"/>
+            <a:srgbClr val="181C28"/>
           </a:solidFill>
           <a:ln w="12700">
             <a:solidFill>
-              <a:srgbClr val="D9D0BE"/>
+              <a:srgbClr val="2E3447"/>
             </a:solidFill>
             <a:prstDash val="solid"/>
           </a:ln>
           <a:effectLst>
-            <a:outerShdw sx="100000" sy="100000" kx="0" ky="0" algn="bl" rotWithShape="0" blurRad="101600" dist="38100" dir="8100000">
+            <a:outerShdw sx="100000" sy="100000" kx="0" ky="0" algn="bl" rotWithShape="0" blurRad="127000" dist="38100" dir="8100000">
               <a:srgbClr val="000000">
-                <a:alpha val="18000"/>
+                <a:alpha val="40000"/>
               </a:srgbClr>
             </a:outerShdw>
           </a:effectLst>
@@ -5174,7 +5189,7 @@
             <a:r>
               <a:rPr lang="en-US" sz="4000" b="1" dirty="0">
                 <a:solidFill>
-                  <a:srgbClr val="D6BE8C"/>
+                  <a:srgbClr val="5E6478"/>
                 </a:solidFill>
                 <a:latin typeface="Times New Roman" pitchFamily="34" charset="0"/>
                 <a:ea typeface="Times New Roman" pitchFamily="34" charset="-122"/>
@@ -5201,7 +5216,7 @@
             <a:avLst/>
           </a:prstGeom>
           <a:solidFill>
-            <a:srgbClr val="0B3D54"/>
+            <a:srgbClr val="E6B94A"/>
           </a:solidFill>
           <a:ln/>
         </p:spPr>
@@ -5222,8 +5237,8 @@
         </p:blipFill>
         <p:spPr>
           <a:xfrm>
-            <a:off x="7004304" y="2414016"/>
-            <a:ext cx="402336" cy="402336"/>
+            <a:off x="7033016" y="2442728"/>
+            <a:ext cx="344912" cy="344912"/>
           </a:xfrm>
           <a:prstGeom prst="rect">
             <a:avLst/>
@@ -5257,7 +5272,7 @@
             <a:r>
               <a:rPr lang="en-US" sz="1650" b="1" dirty="0">
                 <a:solidFill>
-                  <a:srgbClr val="0B3D54"/>
+                  <a:srgbClr val="F5F6FA"/>
                 </a:solidFill>
                 <a:latin typeface="Times New Roman" pitchFamily="34" charset="0"/>
                 <a:ea typeface="Times New Roman" pitchFamily="34" charset="-122"/>
@@ -5299,7 +5314,7 @@
             <a:r>
               <a:rPr lang="en-US" sz="1250" dirty="0">
                 <a:solidFill>
-                  <a:srgbClr val="1A2A33"/>
+                  <a:srgbClr val="C6CAD8"/>
                 </a:solidFill>
                 <a:latin typeface="Calibri" pitchFamily="34" charset="0"/>
                 <a:ea typeface="Calibri" pitchFamily="34" charset="-122"/>
@@ -5326,18 +5341,18 @@
             <a:avLst/>
           </a:prstGeom>
           <a:solidFill>
-            <a:srgbClr val="FFFFFF"/>
+            <a:srgbClr val="181C28"/>
           </a:solidFill>
           <a:ln w="12700">
             <a:solidFill>
-              <a:srgbClr val="D9D0BE"/>
+              <a:srgbClr val="2E3447"/>
             </a:solidFill>
             <a:prstDash val="solid"/>
           </a:ln>
           <a:effectLst>
-            <a:outerShdw sx="100000" sy="100000" kx="0" ky="0" algn="bl" rotWithShape="0" blurRad="101600" dist="38100" dir="8100000">
+            <a:outerShdw sx="100000" sy="100000" kx="0" ky="0" algn="bl" rotWithShape="0" blurRad="127000" dist="38100" dir="8100000">
               <a:srgbClr val="000000">
-                <a:alpha val="18000"/>
+                <a:alpha val="40000"/>
               </a:srgbClr>
             </a:outerShdw>
           </a:effectLst>
@@ -5370,7 +5385,7 @@
             <a:r>
               <a:rPr lang="en-US" sz="4000" b="1" dirty="0">
                 <a:solidFill>
-                  <a:srgbClr val="D6BE8C"/>
+                  <a:srgbClr val="5E6478"/>
                 </a:solidFill>
                 <a:latin typeface="Times New Roman" pitchFamily="34" charset="0"/>
                 <a:ea typeface="Times New Roman" pitchFamily="34" charset="-122"/>
@@ -5397,7 +5412,7 @@
             <a:avLst/>
           </a:prstGeom>
           <a:solidFill>
-            <a:srgbClr val="0B3D54"/>
+            <a:srgbClr val="E6B94A"/>
           </a:solidFill>
           <a:ln/>
         </p:spPr>
@@ -5418,8 +5433,8 @@
         </p:blipFill>
         <p:spPr>
           <a:xfrm>
-            <a:off x="10725912" y="2414016"/>
-            <a:ext cx="402336" cy="402336"/>
+            <a:off x="10754624" y="2442728"/>
+            <a:ext cx="344912" cy="344912"/>
           </a:xfrm>
           <a:prstGeom prst="rect">
             <a:avLst/>
@@ -5453,7 +5468,7 @@
             <a:r>
               <a:rPr lang="en-US" sz="1650" b="1" dirty="0">
                 <a:solidFill>
-                  <a:srgbClr val="0B3D54"/>
+                  <a:srgbClr val="F5F6FA"/>
                 </a:solidFill>
                 <a:latin typeface="Times New Roman" pitchFamily="34" charset="0"/>
                 <a:ea typeface="Times New Roman" pitchFamily="34" charset="-122"/>
@@ -5495,7 +5510,7 @@
             <a:r>
               <a:rPr lang="en-US" sz="1250" dirty="0">
                 <a:solidFill>
-                  <a:srgbClr val="1A2A33"/>
+                  <a:srgbClr val="C6CAD8"/>
                 </a:solidFill>
                 <a:latin typeface="Calibri" pitchFamily="34" charset="0"/>
                 <a:ea typeface="Calibri" pitchFamily="34" charset="-122"/>
@@ -5524,7 +5539,7 @@
           <a:noFill/>
           <a:ln w="25400">
             <a:solidFill>
-              <a:srgbClr val="C9962B"/>
+              <a:srgbClr val="E6B94A"/>
             </a:solidFill>
             <a:prstDash val="solid"/>
           </a:ln>
@@ -5545,7 +5560,7 @@
             <a:avLst/>
           </a:prstGeom>
           <a:solidFill>
-            <a:srgbClr val="C9962B"/>
+            <a:srgbClr val="E6B94A"/>
           </a:solidFill>
           <a:ln/>
         </p:spPr>
@@ -5565,7 +5580,7 @@
             <a:avLst/>
           </a:prstGeom>
           <a:solidFill>
-            <a:srgbClr val="C9962B"/>
+            <a:srgbClr val="E6B94A"/>
           </a:solidFill>
           <a:ln/>
         </p:spPr>
@@ -5585,7 +5600,7 @@
             <a:avLst/>
           </a:prstGeom>
           <a:solidFill>
-            <a:srgbClr val="C9962B"/>
+            <a:srgbClr val="E6B94A"/>
           </a:solidFill>
           <a:ln/>
         </p:spPr>
@@ -5605,7 +5620,7 @@
             <a:avLst/>
           </a:prstGeom>
           <a:solidFill>
-            <a:srgbClr val="C9962B"/>
+            <a:srgbClr val="E6B94A"/>
           </a:solidFill>
           <a:ln/>
         </p:spPr>
@@ -5625,7 +5640,7 @@
             <a:avLst/>
           </a:prstGeom>
           <a:solidFill>
-            <a:srgbClr val="C9962B"/>
+            <a:srgbClr val="E6B94A"/>
           </a:solidFill>
           <a:ln/>
         </p:spPr>
@@ -5645,7 +5660,7 @@
             <a:avLst/>
           </a:prstGeom>
           <a:solidFill>
-            <a:srgbClr val="C9962B"/>
+            <a:srgbClr val="E6B94A"/>
           </a:solidFill>
           <a:ln/>
         </p:spPr>
@@ -5665,7 +5680,7 @@
             <a:avLst/>
           </a:prstGeom>
           <a:solidFill>
-            <a:srgbClr val="C9962B"/>
+            <a:srgbClr val="E6B94A"/>
           </a:solidFill>
           <a:ln/>
         </p:spPr>
@@ -5697,7 +5712,7 @@
             <a:r>
               <a:rPr lang="en-US" sz="1000" dirty="0">
                 <a:solidFill>
-                  <a:srgbClr val="5E6B72"/>
+                  <a:srgbClr val="5E6478"/>
                 </a:solidFill>
                 <a:latin typeface="Calibri" pitchFamily="34" charset="0"/>
                 <a:ea typeface="Calibri" pitchFamily="34" charset="-122"/>
@@ -5736,7 +5751,7 @@
             <a:r>
               <a:rPr lang="en-US" sz="1000" dirty="0">
                 <a:solidFill>
-                  <a:srgbClr val="5E6B72"/>
+                  <a:srgbClr val="5E6478"/>
                 </a:solidFill>
                 <a:latin typeface="Calibri" pitchFamily="34" charset="0"/>
                 <a:ea typeface="Calibri" pitchFamily="34" charset="-122"/>
@@ -5762,7 +5777,7 @@
     <p:bg>
       <p:bgPr>
         <a:solidFill>
-          <a:srgbClr val="F6F2E9"/>
+          <a:srgbClr val="0C0E15"/>
         </a:solidFill>
       </p:bgPr>
     </p:bg>
@@ -5789,7 +5804,7 @@
         <p:spPr>
           <a:xfrm>
             <a:off x="640080" y="457200"/>
-            <a:ext cx="10515600" cy="320040"/>
+            <a:ext cx="10789920" cy="320040"/>
           </a:xfrm>
           <a:prstGeom prst="rect">
             <a:avLst/>
@@ -5807,7 +5822,7 @@
             <a:r>
               <a:rPr lang="en-US" sz="1200" b="1" spc="200" kern="0" dirty="0">
                 <a:solidFill>
-                  <a:srgbClr val="E5B23C"/>
+                  <a:srgbClr val="E6B94A"/>
                 </a:solidFill>
                 <a:latin typeface="Calibri" pitchFamily="34" charset="0"/>
                 <a:ea typeface="Calibri" pitchFamily="34" charset="-122"/>
@@ -5846,7 +5861,7 @@
             <a:r>
               <a:rPr lang="en-US" sz="3200" b="1" dirty="0">
                 <a:solidFill>
-                  <a:srgbClr val="0B3D54"/>
+                  <a:srgbClr val="F5F6FA"/>
                 </a:solidFill>
                 <a:latin typeface="Times New Roman" pitchFamily="34" charset="0"/>
                 <a:ea typeface="Times New Roman" pitchFamily="34" charset="-122"/>
@@ -5866,20 +5881,25 @@
         </p:nvSpPr>
         <p:spPr>
           <a:xfrm>
-            <a:off x="603504" y="1746504"/>
-            <a:ext cx="6839712" cy="3879342"/>
-          </a:xfrm>
-          <a:prstGeom prst="rect">
-            <a:avLst/>
-          </a:prstGeom>
-          <a:solidFill>
-            <a:srgbClr val="0B3D54"/>
-          </a:solidFill>
-          <a:ln/>
+            <a:off x="598932" y="1741932"/>
+            <a:ext cx="6848856" cy="3888486"/>
+          </a:xfrm>
+          <a:prstGeom prst="rect">
+            <a:avLst/>
+          </a:prstGeom>
+          <a:solidFill>
+            <a:srgbClr val="181C28"/>
+          </a:solidFill>
+          <a:ln w="12700">
+            <a:solidFill>
+              <a:srgbClr val="2E3447"/>
+            </a:solidFill>
+            <a:prstDash val="solid"/>
+          </a:ln>
           <a:effectLst>
-            <a:outerShdw sx="100000" sy="100000" kx="0" ky="0" algn="bl" rotWithShape="0" blurRad="101600" dist="38100" dir="8100000">
+            <a:outerShdw sx="100000" sy="100000" kx="0" ky="0" algn="bl" rotWithShape="0" blurRad="127000" dist="38100" dir="8100000">
               <a:srgbClr val="000000">
-                <a:alpha val="18000"/>
+                <a:alpha val="40000"/>
               </a:srgbClr>
             </a:outerShdw>
           </a:effectLst>
@@ -5924,11 +5944,11 @@
             <a:avLst/>
           </a:prstGeom>
           <a:solidFill>
-            <a:srgbClr val="E5B23C"/>
+            <a:srgbClr val="E6B94A"/>
           </a:solidFill>
           <a:ln w="19050">
             <a:solidFill>
-              <a:srgbClr val="FFFFFF"/>
+              <a:srgbClr val="F5F6FA"/>
             </a:solidFill>
             <a:prstDash val="solid"/>
           </a:ln>
@@ -5961,7 +5981,7 @@
             <a:r>
               <a:rPr lang="en-US" sz="1300" b="1" dirty="0">
                 <a:solidFill>
-                  <a:srgbClr val="0B3D54"/>
+                  <a:srgbClr val="07080C"/>
                 </a:solidFill>
                 <a:latin typeface="Calibri" pitchFamily="34" charset="0"/>
                 <a:ea typeface="Calibri" pitchFamily="34" charset="-122"/>
@@ -5988,11 +6008,11 @@
             <a:avLst/>
           </a:prstGeom>
           <a:solidFill>
-            <a:srgbClr val="E5B23C"/>
+            <a:srgbClr val="E6B94A"/>
           </a:solidFill>
           <a:ln w="19050">
             <a:solidFill>
-              <a:srgbClr val="FFFFFF"/>
+              <a:srgbClr val="F5F6FA"/>
             </a:solidFill>
             <a:prstDash val="solid"/>
           </a:ln>
@@ -6025,7 +6045,7 @@
             <a:r>
               <a:rPr lang="en-US" sz="1300" b="1" dirty="0">
                 <a:solidFill>
-                  <a:srgbClr val="0B3D54"/>
+                  <a:srgbClr val="07080C"/>
                 </a:solidFill>
                 <a:latin typeface="Calibri" pitchFamily="34" charset="0"/>
                 <a:ea typeface="Calibri" pitchFamily="34" charset="-122"/>
@@ -6052,11 +6072,11 @@
             <a:avLst/>
           </a:prstGeom>
           <a:solidFill>
-            <a:srgbClr val="E5B23C"/>
+            <a:srgbClr val="E6B94A"/>
           </a:solidFill>
           <a:ln w="19050">
             <a:solidFill>
-              <a:srgbClr val="FFFFFF"/>
+              <a:srgbClr val="F5F6FA"/>
             </a:solidFill>
             <a:prstDash val="solid"/>
           </a:ln>
@@ -6089,7 +6109,7 @@
             <a:r>
               <a:rPr lang="en-US" sz="1300" b="1" dirty="0">
                 <a:solidFill>
-                  <a:srgbClr val="0B3D54"/>
+                  <a:srgbClr val="07080C"/>
                 </a:solidFill>
                 <a:latin typeface="Calibri" pitchFamily="34" charset="0"/>
                 <a:ea typeface="Calibri" pitchFamily="34" charset="-122"/>
@@ -6116,11 +6136,11 @@
             <a:avLst/>
           </a:prstGeom>
           <a:solidFill>
-            <a:srgbClr val="E5B23C"/>
+            <a:srgbClr val="E6B94A"/>
           </a:solidFill>
           <a:ln w="19050">
             <a:solidFill>
-              <a:srgbClr val="FFFFFF"/>
+              <a:srgbClr val="F5F6FA"/>
             </a:solidFill>
             <a:prstDash val="solid"/>
           </a:ln>
@@ -6153,7 +6173,7 @@
             <a:r>
               <a:rPr lang="en-US" sz="1300" b="1" dirty="0">
                 <a:solidFill>
-                  <a:srgbClr val="0B3D54"/>
+                  <a:srgbClr val="07080C"/>
                 </a:solidFill>
                 <a:latin typeface="Calibri" pitchFamily="34" charset="0"/>
                 <a:ea typeface="Calibri" pitchFamily="34" charset="-122"/>
@@ -6180,7 +6200,7 @@
             <a:avLst/>
           </a:prstGeom>
           <a:solidFill>
-            <a:srgbClr val="0B3D54"/>
+            <a:srgbClr val="E6B94A"/>
           </a:solidFill>
           <a:ln/>
         </p:spPr>
@@ -6212,7 +6232,7 @@
             <a:r>
               <a:rPr lang="en-US" sz="1100" b="1" dirty="0">
                 <a:solidFill>
-                  <a:srgbClr val="E5B23C"/>
+                  <a:srgbClr val="07080C"/>
                 </a:solidFill>
                 <a:latin typeface="Calibri" pitchFamily="34" charset="0"/>
                 <a:ea typeface="Calibri" pitchFamily="34" charset="-122"/>
@@ -6251,7 +6271,7 @@
             <a:r>
               <a:rPr lang="en-US" sz="1150" dirty="0">
                 <a:solidFill>
-                  <a:srgbClr val="1A2A33"/>
+                  <a:srgbClr val="C6CAD8"/>
                 </a:solidFill>
                 <a:latin typeface="Calibri" pitchFamily="34" charset="0"/>
                 <a:ea typeface="Calibri" pitchFamily="34" charset="-122"/>
@@ -6278,7 +6298,7 @@
             <a:avLst/>
           </a:prstGeom>
           <a:solidFill>
-            <a:srgbClr val="0B3D54"/>
+            <a:srgbClr val="E6B94A"/>
           </a:solidFill>
           <a:ln/>
         </p:spPr>
@@ -6310,7 +6330,7 @@
             <a:r>
               <a:rPr lang="en-US" sz="1100" b="1" dirty="0">
                 <a:solidFill>
-                  <a:srgbClr val="E5B23C"/>
+                  <a:srgbClr val="07080C"/>
                 </a:solidFill>
                 <a:latin typeface="Calibri" pitchFamily="34" charset="0"/>
                 <a:ea typeface="Calibri" pitchFamily="34" charset="-122"/>
@@ -6349,7 +6369,7 @@
             <a:r>
               <a:rPr lang="en-US" sz="1150" dirty="0">
                 <a:solidFill>
-                  <a:srgbClr val="1A2A33"/>
+                  <a:srgbClr val="C6CAD8"/>
                 </a:solidFill>
                 <a:latin typeface="Calibri" pitchFamily="34" charset="0"/>
                 <a:ea typeface="Calibri" pitchFamily="34" charset="-122"/>
@@ -6376,7 +6396,7 @@
             <a:avLst/>
           </a:prstGeom>
           <a:solidFill>
-            <a:srgbClr val="0B3D54"/>
+            <a:srgbClr val="E6B94A"/>
           </a:solidFill>
           <a:ln/>
         </p:spPr>
@@ -6408,7 +6428,7 @@
             <a:r>
               <a:rPr lang="en-US" sz="1100" b="1" dirty="0">
                 <a:solidFill>
-                  <a:srgbClr val="E5B23C"/>
+                  <a:srgbClr val="07080C"/>
                 </a:solidFill>
                 <a:latin typeface="Calibri" pitchFamily="34" charset="0"/>
                 <a:ea typeface="Calibri" pitchFamily="34" charset="-122"/>
@@ -6447,7 +6467,7 @@
             <a:r>
               <a:rPr lang="en-US" sz="1150" dirty="0">
                 <a:solidFill>
-                  <a:srgbClr val="1A2A33"/>
+                  <a:srgbClr val="C6CAD8"/>
                 </a:solidFill>
                 <a:latin typeface="Calibri" pitchFamily="34" charset="0"/>
                 <a:ea typeface="Calibri" pitchFamily="34" charset="-122"/>
@@ -6474,7 +6494,7 @@
             <a:avLst/>
           </a:prstGeom>
           <a:solidFill>
-            <a:srgbClr val="0B3D54"/>
+            <a:srgbClr val="E6B94A"/>
           </a:solidFill>
           <a:ln/>
         </p:spPr>
@@ -6506,7 +6526,7 @@
             <a:r>
               <a:rPr lang="en-US" sz="1100" b="1" dirty="0">
                 <a:solidFill>
-                  <a:srgbClr val="E5B23C"/>
+                  <a:srgbClr val="07080C"/>
                 </a:solidFill>
                 <a:latin typeface="Calibri" pitchFamily="34" charset="0"/>
                 <a:ea typeface="Calibri" pitchFamily="34" charset="-122"/>
@@ -6545,7 +6565,7 @@
             <a:r>
               <a:rPr lang="en-US" sz="1150" dirty="0">
                 <a:solidFill>
-                  <a:srgbClr val="1A2A33"/>
+                  <a:srgbClr val="C6CAD8"/>
                 </a:solidFill>
                 <a:latin typeface="Calibri" pitchFamily="34" charset="0"/>
                 <a:ea typeface="Calibri" pitchFamily="34" charset="-122"/>
@@ -6584,7 +6604,7 @@
             <a:r>
               <a:rPr lang="en-US" sz="1200" b="1" spc="300" kern="0" dirty="0">
                 <a:solidFill>
-                  <a:srgbClr val="E5B23C"/>
+                  <a:srgbClr val="E6B94A"/>
                 </a:solidFill>
                 <a:latin typeface="Calibri" pitchFamily="34" charset="0"/>
                 <a:ea typeface="Calibri" pitchFamily="34" charset="-122"/>
@@ -6604,20 +6624,25 @@
         </p:nvSpPr>
         <p:spPr>
           <a:xfrm>
-            <a:off x="7781544" y="2157984"/>
-            <a:ext cx="2862072" cy="3518288"/>
-          </a:xfrm>
-          <a:prstGeom prst="rect">
-            <a:avLst/>
-          </a:prstGeom>
-          <a:solidFill>
-            <a:srgbClr val="0B3D54"/>
-          </a:solidFill>
-          <a:ln/>
+            <a:off x="7776972" y="2153412"/>
+            <a:ext cx="2871216" cy="3527432"/>
+          </a:xfrm>
+          <a:prstGeom prst="rect">
+            <a:avLst/>
+          </a:prstGeom>
+          <a:solidFill>
+            <a:srgbClr val="181C28"/>
+          </a:solidFill>
+          <a:ln w="12700">
+            <a:solidFill>
+              <a:srgbClr val="2E3447"/>
+            </a:solidFill>
+            <a:prstDash val="solid"/>
+          </a:ln>
           <a:effectLst>
-            <a:outerShdw sx="100000" sy="100000" kx="0" ky="0" algn="bl" rotWithShape="0" blurRad="101600" dist="38100" dir="8100000">
+            <a:outerShdw sx="100000" sy="100000" kx="0" ky="0" algn="bl" rotWithShape="0" blurRad="127000" dist="38100" dir="8100000">
               <a:srgbClr val="000000">
-                <a:alpha val="18000"/>
+                <a:alpha val="40000"/>
               </a:srgbClr>
             </a:outerShdw>
           </a:effectLst>
@@ -6677,7 +6702,7 @@
             <a:r>
               <a:rPr lang="en-US" sz="1200" dirty="0">
                 <a:solidFill>
-                  <a:srgbClr val="1A2A33"/>
+                  <a:srgbClr val="C6CAD8"/>
                 </a:solidFill>
                 <a:latin typeface="Calibri" pitchFamily="34" charset="0"/>
                 <a:ea typeface="Calibri" pitchFamily="34" charset="-122"/>
@@ -6716,7 +6741,7 @@
             <a:r>
               <a:rPr lang="en-US" sz="1000" dirty="0">
                 <a:solidFill>
-                  <a:srgbClr val="5E6B72"/>
+                  <a:srgbClr val="5E6478"/>
                 </a:solidFill>
                 <a:latin typeface="Calibri" pitchFamily="34" charset="0"/>
                 <a:ea typeface="Calibri" pitchFamily="34" charset="-122"/>
@@ -6755,7 +6780,7 @@
             <a:r>
               <a:rPr lang="en-US" sz="1000" dirty="0">
                 <a:solidFill>
-                  <a:srgbClr val="5E6B72"/>
+                  <a:srgbClr val="5E6478"/>
                 </a:solidFill>
                 <a:latin typeface="Calibri" pitchFamily="34" charset="0"/>
                 <a:ea typeface="Calibri" pitchFamily="34" charset="-122"/>
@@ -6781,7 +6806,7 @@
     <p:bg>
       <p:bgPr>
         <a:solidFill>
-          <a:srgbClr val="F6F2E9"/>
+          <a:srgbClr val="0C0E15"/>
         </a:solidFill>
       </p:bgPr>
     </p:bg>
@@ -6808,7 +6833,7 @@
         <p:spPr>
           <a:xfrm>
             <a:off x="640080" y="457200"/>
-            <a:ext cx="10515600" cy="320040"/>
+            <a:ext cx="10789920" cy="320040"/>
           </a:xfrm>
           <a:prstGeom prst="rect">
             <a:avLst/>
@@ -6826,7 +6851,7 @@
             <a:r>
               <a:rPr lang="en-US" sz="1200" b="1" spc="200" kern="0" dirty="0">
                 <a:solidFill>
-                  <a:srgbClr val="E5B23C"/>
+                  <a:srgbClr val="E6B94A"/>
                 </a:solidFill>
                 <a:latin typeface="Calibri" pitchFamily="34" charset="0"/>
                 <a:ea typeface="Calibri" pitchFamily="34" charset="-122"/>
@@ -6865,7 +6890,7 @@
             <a:r>
               <a:rPr lang="en-US" sz="3200" b="1" dirty="0">
                 <a:solidFill>
-                  <a:srgbClr val="0B3D54"/>
+                  <a:srgbClr val="F5F6FA"/>
                 </a:solidFill>
                 <a:latin typeface="Times New Roman" pitchFamily="34" charset="0"/>
                 <a:ea typeface="Times New Roman" pitchFamily="34" charset="-122"/>
@@ -6885,20 +6910,25 @@
         </p:nvSpPr>
         <p:spPr>
           <a:xfrm>
-            <a:off x="603504" y="1700784"/>
-            <a:ext cx="3159252" cy="4187952"/>
-          </a:xfrm>
-          <a:prstGeom prst="rect">
-            <a:avLst/>
-          </a:prstGeom>
-          <a:solidFill>
-            <a:srgbClr val="0B3D54"/>
-          </a:solidFill>
-          <a:ln/>
+            <a:off x="598932" y="1696212"/>
+            <a:ext cx="3168396" cy="4197096"/>
+          </a:xfrm>
+          <a:prstGeom prst="rect">
+            <a:avLst/>
+          </a:prstGeom>
+          <a:solidFill>
+            <a:srgbClr val="181C28"/>
+          </a:solidFill>
+          <a:ln w="12700">
+            <a:solidFill>
+              <a:srgbClr val="2E3447"/>
+            </a:solidFill>
+            <a:prstDash val="solid"/>
+          </a:ln>
           <a:effectLst>
-            <a:outerShdw sx="100000" sy="100000" kx="0" ky="0" algn="bl" rotWithShape="0" blurRad="101600" dist="38100" dir="8100000">
+            <a:outerShdw sx="100000" sy="100000" kx="0" ky="0" algn="bl" rotWithShape="0" blurRad="127000" dist="38100" dir="8100000">
               <a:srgbClr val="000000">
-                <a:alpha val="18000"/>
+                <a:alpha val="40000"/>
               </a:srgbClr>
             </a:outerShdw>
           </a:effectLst>
@@ -6955,7 +6985,7 @@
             <a:r>
               <a:rPr lang="en-US" sz="1200" i="1" dirty="0">
                 <a:solidFill>
-                  <a:srgbClr val="5E6B72"/>
+                  <a:srgbClr val="8B91A4"/>
                 </a:solidFill>
                 <a:latin typeface="Calibri" pitchFamily="34" charset="0"/>
                 <a:ea typeface="Calibri" pitchFamily="34" charset="-122"/>
@@ -6997,7 +7027,7 @@
             <a:r>
               <a:rPr lang="en-US" sz="1600" dirty="0">
                 <a:solidFill>
-                  <a:srgbClr val="1A2A33"/>
+                  <a:srgbClr val="C6CAD8"/>
                 </a:solidFill>
                 <a:latin typeface="Calibri" pitchFamily="34" charset="0"/>
                 <a:ea typeface="Calibri" pitchFamily="34" charset="-122"/>
@@ -7024,7 +7054,7 @@
             <a:avLst/>
           </a:prstGeom>
           <a:solidFill>
-            <a:srgbClr val="0B3D54"/>
+            <a:srgbClr val="E6B94A"/>
           </a:solidFill>
           <a:ln/>
         </p:spPr>
@@ -7045,8 +7075,8 @@
         </p:blipFill>
         <p:spPr>
           <a:xfrm>
-            <a:off x="4512564" y="3392424"/>
-            <a:ext cx="347472" cy="347472"/>
+            <a:off x="4539082" y="3418942"/>
+            <a:ext cx="294437" cy="294437"/>
           </a:xfrm>
           <a:prstGeom prst="rect">
             <a:avLst/>
@@ -7080,7 +7110,7 @@
             <a:r>
               <a:rPr lang="en-US" sz="1600" b="1" dirty="0">
                 <a:solidFill>
-                  <a:srgbClr val="0B3D54"/>
+                  <a:srgbClr val="F5F6FA"/>
                 </a:solidFill>
                 <a:latin typeface="Times New Roman" pitchFamily="34" charset="0"/>
                 <a:ea typeface="Times New Roman" pitchFamily="34" charset="-122"/>
@@ -7122,7 +7152,7 @@
             <a:r>
               <a:rPr lang="en-US" sz="1300" dirty="0">
                 <a:solidFill>
-                  <a:srgbClr val="1A2A33"/>
+                  <a:srgbClr val="C6CAD8"/>
                 </a:solidFill>
                 <a:latin typeface="Calibri" pitchFamily="34" charset="0"/>
                 <a:ea typeface="Calibri" pitchFamily="34" charset="-122"/>
@@ -7149,7 +7179,7 @@
             <a:avLst/>
           </a:prstGeom>
           <a:solidFill>
-            <a:srgbClr val="0B3D54"/>
+            <a:srgbClr val="E6B94A"/>
           </a:solidFill>
           <a:ln/>
         </p:spPr>
@@ -7170,8 +7200,8 @@
         </p:blipFill>
         <p:spPr>
           <a:xfrm>
-            <a:off x="4512564" y="4352544"/>
-            <a:ext cx="347472" cy="347472"/>
+            <a:off x="4539082" y="4379062"/>
+            <a:ext cx="294437" cy="294437"/>
           </a:xfrm>
           <a:prstGeom prst="rect">
             <a:avLst/>
@@ -7205,7 +7235,7 @@
             <a:r>
               <a:rPr lang="en-US" sz="1600" b="1" dirty="0">
                 <a:solidFill>
-                  <a:srgbClr val="0B3D54"/>
+                  <a:srgbClr val="F5F6FA"/>
                 </a:solidFill>
                 <a:latin typeface="Times New Roman" pitchFamily="34" charset="0"/>
                 <a:ea typeface="Times New Roman" pitchFamily="34" charset="-122"/>
@@ -7247,7 +7277,7 @@
             <a:r>
               <a:rPr lang="en-US" sz="1300" dirty="0">
                 <a:solidFill>
-                  <a:srgbClr val="1A2A33"/>
+                  <a:srgbClr val="C6CAD8"/>
                 </a:solidFill>
                 <a:latin typeface="Calibri" pitchFamily="34" charset="0"/>
                 <a:ea typeface="Calibri" pitchFamily="34" charset="-122"/>
@@ -7274,7 +7304,7 @@
             <a:avLst/>
           </a:prstGeom>
           <a:solidFill>
-            <a:srgbClr val="0B3D54"/>
+            <a:srgbClr val="E6B94A"/>
           </a:solidFill>
           <a:ln/>
         </p:spPr>
@@ -7295,8 +7325,8 @@
         </p:blipFill>
         <p:spPr>
           <a:xfrm>
-            <a:off x="4512564" y="5312664"/>
-            <a:ext cx="347472" cy="347472"/>
+            <a:off x="4539082" y="5339182"/>
+            <a:ext cx="294437" cy="294437"/>
           </a:xfrm>
           <a:prstGeom prst="rect">
             <a:avLst/>
@@ -7330,7 +7360,7 @@
             <a:r>
               <a:rPr lang="en-US" sz="1600" b="1" dirty="0">
                 <a:solidFill>
-                  <a:srgbClr val="0B3D54"/>
+                  <a:srgbClr val="F5F6FA"/>
                 </a:solidFill>
                 <a:latin typeface="Times New Roman" pitchFamily="34" charset="0"/>
                 <a:ea typeface="Times New Roman" pitchFamily="34" charset="-122"/>
@@ -7372,7 +7402,7 @@
             <a:r>
               <a:rPr lang="en-US" sz="1300" dirty="0">
                 <a:solidFill>
-                  <a:srgbClr val="1A2A33"/>
+                  <a:srgbClr val="C6CAD8"/>
                 </a:solidFill>
                 <a:latin typeface="Calibri" pitchFamily="34" charset="0"/>
                 <a:ea typeface="Calibri" pitchFamily="34" charset="-122"/>
@@ -7411,7 +7441,7 @@
             <a:r>
               <a:rPr lang="en-US" sz="1000" dirty="0">
                 <a:solidFill>
-                  <a:srgbClr val="5E6B72"/>
+                  <a:srgbClr val="5E6478"/>
                 </a:solidFill>
                 <a:latin typeface="Calibri" pitchFamily="34" charset="0"/>
                 <a:ea typeface="Calibri" pitchFamily="34" charset="-122"/>
@@ -7450,7 +7480,7 @@
             <a:r>
               <a:rPr lang="en-US" sz="1000" dirty="0">
                 <a:solidFill>
-                  <a:srgbClr val="5E6B72"/>
+                  <a:srgbClr val="5E6478"/>
                 </a:solidFill>
                 <a:latin typeface="Calibri" pitchFamily="34" charset="0"/>
                 <a:ea typeface="Calibri" pitchFamily="34" charset="-122"/>
@@ -7476,7 +7506,7 @@
     <p:bg>
       <p:bgPr>
         <a:solidFill>
-          <a:srgbClr val="0B3D54"/>
+          <a:srgbClr val="0C0E15"/>
         </a:solidFill>
       </p:bgPr>
     </p:bg>
@@ -7503,7 +7533,7 @@
         <p:spPr>
           <a:xfrm>
             <a:off x="640080" y="457200"/>
-            <a:ext cx="10515600" cy="320040"/>
+            <a:ext cx="10789920" cy="320040"/>
           </a:xfrm>
           <a:prstGeom prst="rect">
             <a:avLst/>
@@ -7521,7 +7551,7 @@
             <a:r>
               <a:rPr lang="en-US" sz="1200" b="1" spc="200" kern="0" dirty="0">
                 <a:solidFill>
-                  <a:srgbClr val="E5B23C"/>
+                  <a:srgbClr val="E6B94A"/>
                 </a:solidFill>
                 <a:latin typeface="Calibri" pitchFamily="34" charset="0"/>
                 <a:ea typeface="Calibri" pitchFamily="34" charset="-122"/>
@@ -7560,7 +7590,7 @@
             <a:r>
               <a:rPr lang="en-US" sz="3200" b="1" dirty="0">
                 <a:solidFill>
-                  <a:srgbClr val="FFFFFF"/>
+                  <a:srgbClr val="F5F6FA"/>
                 </a:solidFill>
                 <a:latin typeface="Times New Roman" pitchFamily="34" charset="0"/>
                 <a:ea typeface="Times New Roman" pitchFamily="34" charset="-122"/>
@@ -7587,13 +7617,18 @@
             <a:avLst/>
           </a:prstGeom>
           <a:solidFill>
-            <a:srgbClr val="FFFFFF"/>
-          </a:solidFill>
-          <a:ln/>
+            <a:srgbClr val="181C28"/>
+          </a:solidFill>
+          <a:ln w="12700">
+            <a:solidFill>
+              <a:srgbClr val="2E3447"/>
+            </a:solidFill>
+            <a:prstDash val="solid"/>
+          </a:ln>
           <a:effectLst>
-            <a:outerShdw sx="100000" sy="100000" kx="0" ky="0" algn="bl" rotWithShape="0" blurRad="101600" dist="38100" dir="8100000">
+            <a:outerShdw sx="100000" sy="100000" kx="0" ky="0" algn="bl" rotWithShape="0" blurRad="127000" dist="38100" dir="8100000">
               <a:srgbClr val="000000">
-                <a:alpha val="18000"/>
+                <a:alpha val="40000"/>
               </a:srgbClr>
             </a:outerShdw>
           </a:effectLst>
@@ -7614,7 +7649,7 @@
             <a:avLst/>
           </a:prstGeom>
           <a:solidFill>
-            <a:srgbClr val="0B3D54"/>
+            <a:srgbClr val="E6B94A"/>
           </a:solidFill>
           <a:ln/>
         </p:spPr>
@@ -7635,8 +7670,8 @@
         </p:blipFill>
         <p:spPr>
           <a:xfrm>
-            <a:off x="1143000" y="2148840"/>
-            <a:ext cx="411480" cy="411480"/>
+            <a:off x="1169975" y="2175815"/>
+            <a:ext cx="357530" cy="357530"/>
           </a:xfrm>
           <a:prstGeom prst="rect">
             <a:avLst/>
@@ -7670,7 +7705,7 @@
             <a:r>
               <a:rPr lang="en-US" sz="1600" b="1" dirty="0">
                 <a:solidFill>
-                  <a:srgbClr val="0B3D54"/>
+                  <a:srgbClr val="F5F6FA"/>
                 </a:solidFill>
                 <a:latin typeface="Times New Roman" pitchFamily="34" charset="0"/>
                 <a:ea typeface="Times New Roman" pitchFamily="34" charset="-122"/>
@@ -7712,7 +7747,7 @@
             <a:r>
               <a:rPr lang="en-US" sz="1250" dirty="0">
                 <a:solidFill>
-                  <a:srgbClr val="5E6B72"/>
+                  <a:srgbClr val="8B91A4"/>
                 </a:solidFill>
                 <a:latin typeface="Calibri" pitchFamily="34" charset="0"/>
                 <a:ea typeface="Calibri" pitchFamily="34" charset="-122"/>
@@ -7739,13 +7774,18 @@
             <a:avLst/>
           </a:prstGeom>
           <a:solidFill>
-            <a:srgbClr val="FFFFFF"/>
-          </a:solidFill>
-          <a:ln/>
+            <a:srgbClr val="181C28"/>
+          </a:solidFill>
+          <a:ln w="12700">
+            <a:solidFill>
+              <a:srgbClr val="2E3447"/>
+            </a:solidFill>
+            <a:prstDash val="solid"/>
+          </a:ln>
           <a:effectLst>
-            <a:outerShdw sx="100000" sy="100000" kx="0" ky="0" algn="bl" rotWithShape="0" blurRad="101600" dist="38100" dir="8100000">
+            <a:outerShdw sx="100000" sy="100000" kx="0" ky="0" algn="bl" rotWithShape="0" blurRad="127000" dist="38100" dir="8100000">
               <a:srgbClr val="000000">
-                <a:alpha val="18000"/>
+                <a:alpha val="40000"/>
               </a:srgbClr>
             </a:outerShdw>
           </a:effectLst>
@@ -7766,7 +7806,7 @@
             <a:avLst/>
           </a:prstGeom>
           <a:solidFill>
-            <a:srgbClr val="0B3D54"/>
+            <a:srgbClr val="E6B94A"/>
           </a:solidFill>
           <a:ln/>
         </p:spPr>
@@ -7787,8 +7827,8 @@
         </p:blipFill>
         <p:spPr>
           <a:xfrm>
-            <a:off x="4864608" y="2148840"/>
-            <a:ext cx="411480" cy="411480"/>
+            <a:off x="4891583" y="2175815"/>
+            <a:ext cx="357530" cy="357530"/>
           </a:xfrm>
           <a:prstGeom prst="rect">
             <a:avLst/>
@@ -7822,7 +7862,7 @@
             <a:r>
               <a:rPr lang="en-US" sz="1600" b="1" dirty="0">
                 <a:solidFill>
-                  <a:srgbClr val="0B3D54"/>
+                  <a:srgbClr val="F5F6FA"/>
                 </a:solidFill>
                 <a:latin typeface="Times New Roman" pitchFamily="34" charset="0"/>
                 <a:ea typeface="Times New Roman" pitchFamily="34" charset="-122"/>
@@ -7864,7 +7904,7 @@
             <a:r>
               <a:rPr lang="en-US" sz="1250" dirty="0">
                 <a:solidFill>
-                  <a:srgbClr val="5E6B72"/>
+                  <a:srgbClr val="8B91A4"/>
                 </a:solidFill>
                 <a:latin typeface="Calibri" pitchFamily="34" charset="0"/>
                 <a:ea typeface="Calibri" pitchFamily="34" charset="-122"/>
@@ -7891,13 +7931,18 @@
             <a:avLst/>
           </a:prstGeom>
           <a:solidFill>
-            <a:srgbClr val="FFFFFF"/>
-          </a:solidFill>
-          <a:ln/>
+            <a:srgbClr val="181C28"/>
+          </a:solidFill>
+          <a:ln w="12700">
+            <a:solidFill>
+              <a:srgbClr val="2E3447"/>
+            </a:solidFill>
+            <a:prstDash val="solid"/>
+          </a:ln>
           <a:effectLst>
-            <a:outerShdw sx="100000" sy="100000" kx="0" ky="0" algn="bl" rotWithShape="0" blurRad="101600" dist="38100" dir="8100000">
+            <a:outerShdw sx="100000" sy="100000" kx="0" ky="0" algn="bl" rotWithShape="0" blurRad="127000" dist="38100" dir="8100000">
               <a:srgbClr val="000000">
-                <a:alpha val="18000"/>
+                <a:alpha val="40000"/>
               </a:srgbClr>
             </a:outerShdw>
           </a:effectLst>
@@ -7918,7 +7963,7 @@
             <a:avLst/>
           </a:prstGeom>
           <a:solidFill>
-            <a:srgbClr val="0B3D54"/>
+            <a:srgbClr val="E6B94A"/>
           </a:solidFill>
           <a:ln/>
         </p:spPr>
@@ -7939,8 +7984,8 @@
         </p:blipFill>
         <p:spPr>
           <a:xfrm>
-            <a:off x="8586216" y="2148840"/>
-            <a:ext cx="411480" cy="411480"/>
+            <a:off x="8613191" y="2175815"/>
+            <a:ext cx="357530" cy="357530"/>
           </a:xfrm>
           <a:prstGeom prst="rect">
             <a:avLst/>
@@ -7974,7 +8019,7 @@
             <a:r>
               <a:rPr lang="en-US" sz="1600" b="1" dirty="0">
                 <a:solidFill>
-                  <a:srgbClr val="0B3D54"/>
+                  <a:srgbClr val="F5F6FA"/>
                 </a:solidFill>
                 <a:latin typeface="Times New Roman" pitchFamily="34" charset="0"/>
                 <a:ea typeface="Times New Roman" pitchFamily="34" charset="-122"/>
@@ -8016,7 +8061,7 @@
             <a:r>
               <a:rPr lang="en-US" sz="1250" dirty="0">
                 <a:solidFill>
-                  <a:srgbClr val="5E6B72"/>
+                  <a:srgbClr val="8B91A4"/>
                 </a:solidFill>
                 <a:latin typeface="Calibri" pitchFamily="34" charset="0"/>
                 <a:ea typeface="Calibri" pitchFamily="34" charset="-122"/>
@@ -8043,11 +8088,14 @@
             <a:avLst/>
           </a:prstGeom>
           <a:solidFill>
-            <a:srgbClr val="1C7CA5">
-              <a:alpha val="70000"/>
-            </a:srgbClr>
-          </a:solidFill>
-          <a:ln/>
+            <a:srgbClr val="141826"/>
+          </a:solidFill>
+          <a:ln w="12700">
+            <a:solidFill>
+              <a:srgbClr val="232838"/>
+            </a:solidFill>
+            <a:prstDash val="solid"/>
+          </a:ln>
         </p:spPr>
       </p:sp>
       <p:sp>
@@ -8065,7 +8113,7 @@
             <a:avLst/>
           </a:prstGeom>
           <a:solidFill>
-            <a:srgbClr val="0B3D54"/>
+            <a:srgbClr val="E6B94A"/>
           </a:solidFill>
           <a:ln/>
         </p:spPr>
@@ -8086,8 +8134,8 @@
         </p:blipFill>
         <p:spPr>
           <a:xfrm>
-            <a:off x="1042416" y="4608576"/>
-            <a:ext cx="338328" cy="338328"/>
+            <a:off x="1074877" y="4641037"/>
+            <a:ext cx="273406" cy="273406"/>
           </a:xfrm>
           <a:prstGeom prst="rect">
             <a:avLst/>
@@ -8121,7 +8169,7 @@
             <a:r>
               <a:rPr lang="en-US" sz="1650" b="1" dirty="0">
                 <a:solidFill>
-                  <a:srgbClr val="FFFFFF"/>
+                  <a:srgbClr val="F5F6FA"/>
                 </a:solidFill>
                 <a:latin typeface="Times New Roman" pitchFamily="34" charset="0"/>
                 <a:ea typeface="Times New Roman" pitchFamily="34" charset="-122"/>
@@ -8150,7 +8198,7 @@
           <a:noFill/>
           <a:ln w="12700">
             <a:solidFill>
-              <a:srgbClr val="D9D0BE"/>
+              <a:srgbClr val="2E3447"/>
             </a:solidFill>
             <a:prstDash val="solid"/>
           </a:ln>
@@ -8186,7 +8234,7 @@
             <a:r>
               <a:rPr lang="en-US" sz="1450" dirty="0">
                 <a:solidFill>
-                  <a:srgbClr val="F6F2E9"/>
+                  <a:srgbClr val="C6CAD8"/>
                 </a:solidFill>
                 <a:latin typeface="Calibri" pitchFamily="34" charset="0"/>
                 <a:ea typeface="Calibri" pitchFamily="34" charset="-122"/>
@@ -8213,7 +8261,7 @@
             <a:avLst/>
           </a:prstGeom>
           <a:solidFill>
-            <a:srgbClr val="0B3D54"/>
+            <a:srgbClr val="E6B94A"/>
           </a:solidFill>
           <a:ln/>
         </p:spPr>
@@ -8234,8 +8282,8 @@
         </p:blipFill>
         <p:spPr>
           <a:xfrm>
-            <a:off x="1042416" y="5522976"/>
-            <a:ext cx="338328" cy="338328"/>
+            <a:off x="1074877" y="5555437"/>
+            <a:ext cx="273406" cy="273406"/>
           </a:xfrm>
           <a:prstGeom prst="rect">
             <a:avLst/>
@@ -8269,7 +8317,7 @@
             <a:r>
               <a:rPr lang="en-US" sz="1650" b="1" dirty="0">
                 <a:solidFill>
-                  <a:srgbClr val="FFFFFF"/>
+                  <a:srgbClr val="F5F6FA"/>
                 </a:solidFill>
                 <a:latin typeface="Times New Roman" pitchFamily="34" charset="0"/>
                 <a:ea typeface="Times New Roman" pitchFamily="34" charset="-122"/>
@@ -8298,7 +8346,7 @@
           <a:noFill/>
           <a:ln w="12700">
             <a:solidFill>
-              <a:srgbClr val="D9D0BE"/>
+              <a:srgbClr val="2E3447"/>
             </a:solidFill>
             <a:prstDash val="solid"/>
           </a:ln>
@@ -8334,7 +8382,7 @@
             <a:r>
               <a:rPr lang="en-US" sz="1450" dirty="0">
                 <a:solidFill>
-                  <a:srgbClr val="F6F2E9"/>
+                  <a:srgbClr val="C6CAD8"/>
                 </a:solidFill>
                 <a:latin typeface="Calibri" pitchFamily="34" charset="0"/>
                 <a:ea typeface="Calibri" pitchFamily="34" charset="-122"/>
@@ -8373,7 +8421,7 @@
             <a:r>
               <a:rPr lang="en-US" sz="1000" dirty="0">
                 <a:solidFill>
-                  <a:srgbClr val="F6F2E9"/>
+                  <a:srgbClr val="5E6478"/>
                 </a:solidFill>
                 <a:latin typeface="Calibri" pitchFamily="34" charset="0"/>
                 <a:ea typeface="Calibri" pitchFamily="34" charset="-122"/>
@@ -8412,7 +8460,7 @@
             <a:r>
               <a:rPr lang="en-US" sz="1000" dirty="0">
                 <a:solidFill>
-                  <a:srgbClr val="F6F2E9"/>
+                  <a:srgbClr val="5E6478"/>
                 </a:solidFill>
                 <a:latin typeface="Calibri" pitchFamily="34" charset="0"/>
                 <a:ea typeface="Calibri" pitchFamily="34" charset="-122"/>
@@ -8438,7 +8486,7 @@
     <p:bg>
       <p:bgPr>
         <a:solidFill>
-          <a:srgbClr val="F6F2E9"/>
+          <a:srgbClr val="0C0E15"/>
         </a:solidFill>
       </p:bgPr>
     </p:bg>
@@ -8465,7 +8513,7 @@
         <p:spPr>
           <a:xfrm>
             <a:off x="640080" y="457200"/>
-            <a:ext cx="10515600" cy="320040"/>
+            <a:ext cx="10789920" cy="320040"/>
           </a:xfrm>
           <a:prstGeom prst="rect">
             <a:avLst/>
@@ -8483,7 +8531,7 @@
             <a:r>
               <a:rPr lang="en-US" sz="1200" b="1" spc="200" kern="0" dirty="0">
                 <a:solidFill>
-                  <a:srgbClr val="E5B23C"/>
+                  <a:srgbClr val="E6B94A"/>
                 </a:solidFill>
                 <a:latin typeface="Calibri" pitchFamily="34" charset="0"/>
                 <a:ea typeface="Calibri" pitchFamily="34" charset="-122"/>
@@ -8522,7 +8570,7 @@
             <a:r>
               <a:rPr lang="en-US" sz="3200" b="1" dirty="0">
                 <a:solidFill>
-                  <a:srgbClr val="0B3D54"/>
+                  <a:srgbClr val="F5F6FA"/>
                 </a:solidFill>
                 <a:latin typeface="Times New Roman" pitchFamily="34" charset="0"/>
                 <a:ea typeface="Times New Roman" pitchFamily="34" charset="-122"/>
@@ -8549,18 +8597,18 @@
             <a:avLst/>
           </a:prstGeom>
           <a:solidFill>
-            <a:srgbClr val="FFFFFF"/>
+            <a:srgbClr val="181C28"/>
           </a:solidFill>
           <a:ln w="12700">
             <a:solidFill>
-              <a:srgbClr val="D9D0BE"/>
+              <a:srgbClr val="2E3447"/>
             </a:solidFill>
             <a:prstDash val="solid"/>
           </a:ln>
           <a:effectLst>
-            <a:outerShdw sx="100000" sy="100000" kx="0" ky="0" algn="bl" rotWithShape="0" blurRad="101600" dist="38100" dir="8100000">
+            <a:outerShdw sx="100000" sy="100000" kx="0" ky="0" algn="bl" rotWithShape="0" blurRad="127000" dist="38100" dir="8100000">
               <a:srgbClr val="000000">
-                <a:alpha val="18000"/>
+                <a:alpha val="40000"/>
               </a:srgbClr>
             </a:outerShdw>
           </a:effectLst>
@@ -8581,7 +8629,7 @@
             <a:avLst/>
           </a:prstGeom>
           <a:solidFill>
-            <a:srgbClr val="0B3D54"/>
+            <a:srgbClr val="E6B94A"/>
           </a:solidFill>
           <a:ln/>
         </p:spPr>
@@ -8602,8 +8650,8 @@
         </p:blipFill>
         <p:spPr>
           <a:xfrm>
-            <a:off x="1106424" y="2267712"/>
-            <a:ext cx="438912" cy="438912"/>
+            <a:off x="1136599" y="2297887"/>
+            <a:ext cx="378562" cy="378562"/>
           </a:xfrm>
           <a:prstGeom prst="rect">
             <a:avLst/>
@@ -8637,7 +8685,7 @@
             <a:r>
               <a:rPr lang="en-US" sz="1550" b="1" dirty="0">
                 <a:solidFill>
-                  <a:srgbClr val="0B3D54"/>
+                  <a:srgbClr val="F5F6FA"/>
                 </a:solidFill>
                 <a:latin typeface="Times New Roman" pitchFamily="34" charset="0"/>
                 <a:ea typeface="Times New Roman" pitchFamily="34" charset="-122"/>
@@ -8679,7 +8727,7 @@
             <a:r>
               <a:rPr lang="en-US" sz="1200" dirty="0">
                 <a:solidFill>
-                  <a:srgbClr val="1A2A33"/>
+                  <a:srgbClr val="C6CAD8"/>
                 </a:solidFill>
                 <a:latin typeface="Calibri" pitchFamily="34" charset="0"/>
                 <a:ea typeface="Calibri" pitchFamily="34" charset="-122"/>
@@ -8706,18 +8754,18 @@
             <a:avLst/>
           </a:prstGeom>
           <a:solidFill>
-            <a:srgbClr val="FFFFFF"/>
+            <a:srgbClr val="181C28"/>
           </a:solidFill>
           <a:ln w="12700">
             <a:solidFill>
-              <a:srgbClr val="D9D0BE"/>
+              <a:srgbClr val="2E3447"/>
             </a:solidFill>
             <a:prstDash val="solid"/>
           </a:ln>
           <a:effectLst>
-            <a:outerShdw sx="100000" sy="100000" kx="0" ky="0" algn="bl" rotWithShape="0" blurRad="101600" dist="38100" dir="8100000">
+            <a:outerShdw sx="100000" sy="100000" kx="0" ky="0" algn="bl" rotWithShape="0" blurRad="127000" dist="38100" dir="8100000">
               <a:srgbClr val="000000">
-                <a:alpha val="18000"/>
+                <a:alpha val="40000"/>
               </a:srgbClr>
             </a:outerShdw>
           </a:effectLst>
@@ -8738,7 +8786,7 @@
             <a:avLst/>
           </a:prstGeom>
           <a:solidFill>
-            <a:srgbClr val="0B3D54"/>
+            <a:srgbClr val="E6B94A"/>
           </a:solidFill>
           <a:ln/>
         </p:spPr>
@@ -8759,8 +8807,8 @@
         </p:blipFill>
         <p:spPr>
           <a:xfrm>
-            <a:off x="6684264" y="2267712"/>
-            <a:ext cx="438912" cy="438912"/>
+            <a:off x="6714439" y="2297887"/>
+            <a:ext cx="378562" cy="378562"/>
           </a:xfrm>
           <a:prstGeom prst="rect">
             <a:avLst/>
@@ -8794,7 +8842,7 @@
             <a:r>
               <a:rPr lang="en-US" sz="1550" b="1" dirty="0">
                 <a:solidFill>
-                  <a:srgbClr val="0B3D54"/>
+                  <a:srgbClr val="F5F6FA"/>
                 </a:solidFill>
                 <a:latin typeface="Times New Roman" pitchFamily="34" charset="0"/>
                 <a:ea typeface="Times New Roman" pitchFamily="34" charset="-122"/>
@@ -8836,7 +8884,7 @@
             <a:r>
               <a:rPr lang="en-US" sz="1200" dirty="0">
                 <a:solidFill>
-                  <a:srgbClr val="1A2A33"/>
+                  <a:srgbClr val="C6CAD8"/>
                 </a:solidFill>
                 <a:latin typeface="Calibri" pitchFamily="34" charset="0"/>
                 <a:ea typeface="Calibri" pitchFamily="34" charset="-122"/>
@@ -8863,18 +8911,18 @@
             <a:avLst/>
           </a:prstGeom>
           <a:solidFill>
-            <a:srgbClr val="FFFFFF"/>
+            <a:srgbClr val="181C28"/>
           </a:solidFill>
           <a:ln w="12700">
             <a:solidFill>
-              <a:srgbClr val="D9D0BE"/>
+              <a:srgbClr val="2E3447"/>
             </a:solidFill>
             <a:prstDash val="solid"/>
           </a:ln>
           <a:effectLst>
-            <a:outerShdw sx="100000" sy="100000" kx="0" ky="0" algn="bl" rotWithShape="0" blurRad="101600" dist="38100" dir="8100000">
+            <a:outerShdw sx="100000" sy="100000" kx="0" ky="0" algn="bl" rotWithShape="0" blurRad="127000" dist="38100" dir="8100000">
               <a:srgbClr val="000000">
-                <a:alpha val="18000"/>
+                <a:alpha val="40000"/>
               </a:srgbClr>
             </a:outerShdw>
           </a:effectLst>
@@ -8895,7 +8943,7 @@
             <a:avLst/>
           </a:prstGeom>
           <a:solidFill>
-            <a:srgbClr val="0B3D54"/>
+            <a:srgbClr val="E6B94A"/>
           </a:solidFill>
           <a:ln/>
         </p:spPr>
@@ -8916,8 +8964,8 @@
         </p:blipFill>
         <p:spPr>
           <a:xfrm>
-            <a:off x="1106424" y="3867912"/>
-            <a:ext cx="438912" cy="438912"/>
+            <a:off x="1136599" y="3898087"/>
+            <a:ext cx="378562" cy="378562"/>
           </a:xfrm>
           <a:prstGeom prst="rect">
             <a:avLst/>
@@ -8951,7 +8999,7 @@
             <a:r>
               <a:rPr lang="en-US" sz="1550" b="1" dirty="0">
                 <a:solidFill>
-                  <a:srgbClr val="0B3D54"/>
+                  <a:srgbClr val="F5F6FA"/>
                 </a:solidFill>
                 <a:latin typeface="Times New Roman" pitchFamily="34" charset="0"/>
                 <a:ea typeface="Times New Roman" pitchFamily="34" charset="-122"/>
@@ -8993,7 +9041,7 @@
             <a:r>
               <a:rPr lang="en-US" sz="1200" dirty="0">
                 <a:solidFill>
-                  <a:srgbClr val="1A2A33"/>
+                  <a:srgbClr val="C6CAD8"/>
                 </a:solidFill>
                 <a:latin typeface="Calibri" pitchFamily="34" charset="0"/>
                 <a:ea typeface="Calibri" pitchFamily="34" charset="-122"/>
@@ -9020,18 +9068,18 @@
             <a:avLst/>
           </a:prstGeom>
           <a:solidFill>
-            <a:srgbClr val="FFFFFF"/>
+            <a:srgbClr val="181C28"/>
           </a:solidFill>
           <a:ln w="12700">
             <a:solidFill>
-              <a:srgbClr val="D9D0BE"/>
+              <a:srgbClr val="2E3447"/>
             </a:solidFill>
             <a:prstDash val="solid"/>
           </a:ln>
           <a:effectLst>
-            <a:outerShdw sx="100000" sy="100000" kx="0" ky="0" algn="bl" rotWithShape="0" blurRad="101600" dist="38100" dir="8100000">
+            <a:outerShdw sx="100000" sy="100000" kx="0" ky="0" algn="bl" rotWithShape="0" blurRad="127000" dist="38100" dir="8100000">
               <a:srgbClr val="000000">
-                <a:alpha val="18000"/>
+                <a:alpha val="40000"/>
               </a:srgbClr>
             </a:outerShdw>
           </a:effectLst>
@@ -9052,7 +9100,7 @@
             <a:avLst/>
           </a:prstGeom>
           <a:solidFill>
-            <a:srgbClr val="0B3D54"/>
+            <a:srgbClr val="E6B94A"/>
           </a:solidFill>
           <a:ln/>
         </p:spPr>
@@ -9073,8 +9121,8 @@
         </p:blipFill>
         <p:spPr>
           <a:xfrm>
-            <a:off x="6684264" y="3867912"/>
-            <a:ext cx="438912" cy="438912"/>
+            <a:off x="6714439" y="3898087"/>
+            <a:ext cx="378562" cy="378562"/>
           </a:xfrm>
           <a:prstGeom prst="rect">
             <a:avLst/>
@@ -9108,7 +9156,7 @@
             <a:r>
               <a:rPr lang="en-US" sz="1550" b="1" dirty="0">
                 <a:solidFill>
-                  <a:srgbClr val="0B3D54"/>
+                  <a:srgbClr val="F5F6FA"/>
                 </a:solidFill>
                 <a:latin typeface="Times New Roman" pitchFamily="34" charset="0"/>
                 <a:ea typeface="Times New Roman" pitchFamily="34" charset="-122"/>
@@ -9150,7 +9198,7 @@
             <a:r>
               <a:rPr lang="en-US" sz="1200" dirty="0">
                 <a:solidFill>
-                  <a:srgbClr val="1A2A33"/>
+                  <a:srgbClr val="C6CAD8"/>
                 </a:solidFill>
                 <a:latin typeface="Calibri" pitchFamily="34" charset="0"/>
                 <a:ea typeface="Calibri" pitchFamily="34" charset="-122"/>
@@ -9177,9 +9225,14 @@
             <a:avLst/>
           </a:prstGeom>
           <a:solidFill>
-            <a:srgbClr val="0B3D54"/>
-          </a:solidFill>
-          <a:ln/>
+            <a:srgbClr val="141826"/>
+          </a:solidFill>
+          <a:ln w="12700">
+            <a:solidFill>
+              <a:srgbClr val="232838"/>
+            </a:solidFill>
+            <a:prstDash val="solid"/>
+          </a:ln>
         </p:spPr>
       </p:sp>
       <p:sp>
@@ -9197,7 +9250,7 @@
             <a:avLst/>
           </a:prstGeom>
           <a:solidFill>
-            <a:srgbClr val="E5B23C"/>
+            <a:srgbClr val="E6B94A"/>
           </a:solidFill>
           <a:ln/>
         </p:spPr>
@@ -9218,8 +9271,8 @@
         </p:blipFill>
         <p:spPr>
           <a:xfrm>
-            <a:off x="1106424" y="5495544"/>
-            <a:ext cx="347472" cy="347472"/>
+            <a:off x="1132942" y="5522062"/>
+            <a:ext cx="294437" cy="294437"/>
           </a:xfrm>
           <a:prstGeom prst="rect">
             <a:avLst/>
@@ -9256,7 +9309,7 @@
             <a:r>
               <a:rPr lang="en-US" sz="1250" b="1" dirty="0">
                 <a:solidFill>
-                  <a:srgbClr val="E5B23C"/>
+                  <a:srgbClr val="E6B94A"/>
                 </a:solidFill>
                 <a:latin typeface="Calibri" pitchFamily="34" charset="0"/>
                 <a:ea typeface="Calibri" pitchFamily="34" charset="-122"/>
@@ -9273,7 +9326,7 @@
             <a:r>
               <a:rPr lang="en-US" sz="1250" dirty="0">
                 <a:solidFill>
-                  <a:srgbClr val="F6F2E9"/>
+                  <a:srgbClr val="C6CAD8"/>
                 </a:solidFill>
                 <a:latin typeface="Calibri" pitchFamily="34" charset="0"/>
                 <a:ea typeface="Calibri" pitchFamily="34" charset="-122"/>
@@ -9312,7 +9365,7 @@
             <a:r>
               <a:rPr lang="en-US" sz="1000" dirty="0">
                 <a:solidFill>
-                  <a:srgbClr val="5E6B72"/>
+                  <a:srgbClr val="5E6478"/>
                 </a:solidFill>
                 <a:latin typeface="Calibri" pitchFamily="34" charset="0"/>
                 <a:ea typeface="Calibri" pitchFamily="34" charset="-122"/>
@@ -9351,7 +9404,7 @@
             <a:r>
               <a:rPr lang="en-US" sz="1000" dirty="0">
                 <a:solidFill>
-                  <a:srgbClr val="5E6B72"/>
+                  <a:srgbClr val="5E6478"/>
                 </a:solidFill>
                 <a:latin typeface="Calibri" pitchFamily="34" charset="0"/>
                 <a:ea typeface="Calibri" pitchFamily="34" charset="-122"/>
@@ -9377,7 +9430,7 @@
     <p:bg>
       <p:bgPr>
         <a:solidFill>
-          <a:srgbClr val="F6F2E9"/>
+          <a:srgbClr val="0C0E15"/>
         </a:solidFill>
       </p:bgPr>
     </p:bg>
@@ -9404,7 +9457,7 @@
         <p:spPr>
           <a:xfrm>
             <a:off x="640080" y="457200"/>
-            <a:ext cx="10515600" cy="320040"/>
+            <a:ext cx="10789920" cy="320040"/>
           </a:xfrm>
           <a:prstGeom prst="rect">
             <a:avLst/>
@@ -9422,7 +9475,7 @@
             <a:r>
               <a:rPr lang="en-US" sz="1200" b="1" spc="200" kern="0" dirty="0">
                 <a:solidFill>
-                  <a:srgbClr val="E5B23C"/>
+                  <a:srgbClr val="E6B94A"/>
                 </a:solidFill>
                 <a:latin typeface="Calibri" pitchFamily="34" charset="0"/>
                 <a:ea typeface="Calibri" pitchFamily="34" charset="-122"/>
@@ -9461,13 +9514,13 @@
             <a:r>
               <a:rPr lang="en-US" sz="3200" b="1" dirty="0">
                 <a:solidFill>
-                  <a:srgbClr val="0B3D54"/>
+                  <a:srgbClr val="F5F6FA"/>
                 </a:solidFill>
                 <a:latin typeface="Times New Roman" pitchFamily="34" charset="0"/>
                 <a:ea typeface="Times New Roman" pitchFamily="34" charset="-122"/>
                 <a:cs typeface="Times New Roman" pitchFamily="34" charset="-120"/>
               </a:rPr>
-              <a:t>Грант бюджеті - 3 000 000 ₸</a:t>
+              <a:t>Грант бюджеті — 3 000 000 ₸</a:t>
             </a:r>
             <a:endParaRPr lang="en-US" sz="3200" dirty="0"/>
           </a:p>
@@ -9488,13 +9541,18 @@
             <a:avLst/>
           </a:prstGeom>
           <a:solidFill>
-            <a:srgbClr val="0B3D54"/>
-          </a:solidFill>
-          <a:ln/>
+            <a:srgbClr val="181C28"/>
+          </a:solidFill>
+          <a:ln w="12700">
+            <a:solidFill>
+              <a:srgbClr val="2E3447"/>
+            </a:solidFill>
+            <a:prstDash val="solid"/>
+          </a:ln>
           <a:effectLst>
-            <a:outerShdw sx="100000" sy="100000" kx="0" ky="0" algn="bl" rotWithShape="0" blurRad="101600" dist="38100" dir="8100000">
+            <a:outerShdw sx="100000" sy="100000" kx="0" ky="0" algn="bl" rotWithShape="0" blurRad="127000" dist="38100" dir="8100000">
               <a:srgbClr val="000000">
-                <a:alpha val="18000"/>
+                <a:alpha val="40000"/>
               </a:srgbClr>
             </a:outerShdw>
           </a:effectLst>
@@ -9527,7 +9585,7 @@
             <a:r>
               <a:rPr lang="en-US" sz="1300" b="1" spc="300" kern="0" dirty="0">
                 <a:solidFill>
-                  <a:srgbClr val="E5B23C"/>
+                  <a:srgbClr val="E6B94A"/>
                 </a:solidFill>
                 <a:latin typeface="Calibri" pitchFamily="34" charset="0"/>
                 <a:ea typeface="Calibri" pitchFamily="34" charset="-122"/>
@@ -9566,7 +9624,7 @@
             <a:r>
               <a:rPr lang="en-US" sz="4400" b="1" dirty="0">
                 <a:solidFill>
-                  <a:srgbClr val="FFFFFF"/>
+                  <a:srgbClr val="F5F6FA"/>
                 </a:solidFill>
                 <a:latin typeface="Times New Roman" pitchFamily="34" charset="0"/>
                 <a:ea typeface="Times New Roman" pitchFamily="34" charset="-122"/>
@@ -9605,7 +9663,7 @@
             <a:r>
               <a:rPr lang="en-US" sz="1400" dirty="0">
                 <a:solidFill>
-                  <a:srgbClr val="F6F2E9"/>
+                  <a:srgbClr val="C6CAD8"/>
                 </a:solidFill>
                 <a:latin typeface="Calibri" pitchFamily="34" charset="0"/>
                 <a:ea typeface="Calibri" pitchFamily="34" charset="-122"/>
@@ -9632,7 +9690,7 @@
             <a:avLst/>
           </a:prstGeom>
           <a:solidFill>
-            <a:srgbClr val="0B3D54"/>
+            <a:srgbClr val="38BDF8"/>
           </a:solidFill>
           <a:ln/>
         </p:spPr>
@@ -9652,7 +9710,7 @@
             <a:avLst/>
           </a:prstGeom>
           <a:solidFill>
-            <a:srgbClr val="1C7CA5"/>
+            <a:srgbClr val="5CD4EC"/>
           </a:solidFill>
           <a:ln/>
         </p:spPr>
@@ -9672,7 +9730,7 @@
             <a:avLst/>
           </a:prstGeom>
           <a:solidFill>
-            <a:srgbClr val="E5B23C"/>
+            <a:srgbClr val="E6B94A"/>
           </a:solidFill>
           <a:ln/>
         </p:spPr>
@@ -9692,7 +9750,7 @@
             <a:avLst/>
           </a:prstGeom>
           <a:solidFill>
-            <a:srgbClr val="C9962B"/>
+            <a:srgbClr val="F7903A"/>
           </a:solidFill>
           <a:ln/>
         </p:spPr>
@@ -9712,7 +9770,7 @@
             <a:avLst/>
           </a:prstGeom>
           <a:solidFill>
-            <a:srgbClr val="5E8CA0"/>
+            <a:srgbClr val="B27CFF"/>
           </a:solidFill>
           <a:ln/>
         </p:spPr>
@@ -9732,7 +9790,7 @@
             <a:avLst/>
           </a:prstGeom>
           <a:solidFill>
-            <a:srgbClr val="8FB3C4"/>
+            <a:srgbClr val="EF5A6A"/>
           </a:solidFill>
           <a:ln/>
         </p:spPr>
@@ -9752,7 +9810,7 @@
             <a:avLst/>
           </a:prstGeom>
           <a:solidFill>
-            <a:srgbClr val="A8742E"/>
+            <a:srgbClr val="5FD49A"/>
           </a:solidFill>
           <a:ln/>
         </p:spPr>
@@ -9773,7 +9831,7 @@
           </a:prstGeom>
           <a:ln w="9525">
             <a:solidFill>
-              <a:srgbClr val="FFFFFF"/>
+              <a:srgbClr val="2E3447"/>
             </a:solidFill>
             <a:prstDash val="solid"/>
           </a:ln>
@@ -9809,7 +9867,7 @@
             <a:r>
               <a:rPr lang="en-US" sz="1250" b="1" dirty="0">
                 <a:solidFill>
-                  <a:srgbClr val="E5B23C"/>
+                  <a:srgbClr val="E6B94A"/>
                 </a:solidFill>
                 <a:latin typeface="Calibri" pitchFamily="34" charset="0"/>
                 <a:ea typeface="Calibri" pitchFamily="34" charset="-122"/>
@@ -9826,7 +9884,7 @@
             <a:r>
               <a:rPr lang="en-US" sz="1250" dirty="0">
                 <a:solidFill>
-                  <a:srgbClr val="F6F2E9"/>
+                  <a:srgbClr val="C6CAD8"/>
                 </a:solidFill>
                 <a:latin typeface="Calibri" pitchFamily="34" charset="0"/>
                 <a:ea typeface="Calibri" pitchFamily="34" charset="-122"/>
@@ -9843,7 +9901,7 @@
             <a:r>
               <a:rPr lang="en-US" sz="1250" b="1" dirty="0">
                 <a:solidFill>
-                  <a:srgbClr val="E5B23C"/>
+                  <a:srgbClr val="E6B94A"/>
                 </a:solidFill>
                 <a:latin typeface="Calibri" pitchFamily="34" charset="0"/>
                 <a:ea typeface="Calibri" pitchFamily="34" charset="-122"/>
@@ -9860,7 +9918,7 @@
             <a:r>
               <a:rPr lang="en-US" sz="1250" dirty="0">
                 <a:solidFill>
-                  <a:srgbClr val="F6F2E9"/>
+                  <a:srgbClr val="C6CAD8"/>
                 </a:solidFill>
                 <a:latin typeface="Calibri" pitchFamily="34" charset="0"/>
                 <a:ea typeface="Calibri" pitchFamily="34" charset="-122"/>
@@ -9877,7 +9935,7 @@
             <a:r>
               <a:rPr lang="en-US" sz="1250" b="1" dirty="0">
                 <a:solidFill>
-                  <a:srgbClr val="E5B23C"/>
+                  <a:srgbClr val="E6B94A"/>
                 </a:solidFill>
                 <a:latin typeface="Calibri" pitchFamily="34" charset="0"/>
                 <a:ea typeface="Calibri" pitchFamily="34" charset="-122"/>
@@ -9894,7 +9952,7 @@
             <a:r>
               <a:rPr lang="en-US" sz="1250" dirty="0">
                 <a:solidFill>
-                  <a:srgbClr val="F6F2E9"/>
+                  <a:srgbClr val="C6CAD8"/>
                 </a:solidFill>
                 <a:latin typeface="Calibri" pitchFamily="34" charset="0"/>
                 <a:ea typeface="Calibri" pitchFamily="34" charset="-122"/>
@@ -9921,7 +9979,7 @@
             <a:avLst/>
           </a:prstGeom>
           <a:solidFill>
-            <a:srgbClr val="0B3D54"/>
+            <a:srgbClr val="38BDF8"/>
           </a:solidFill>
           <a:ln/>
         </p:spPr>
@@ -9953,7 +10011,7 @@
             <a:r>
               <a:rPr lang="en-US" sz="1300" dirty="0">
                 <a:solidFill>
-                  <a:srgbClr val="1A2A33"/>
+                  <a:srgbClr val="C6CAD8"/>
                 </a:solidFill>
                 <a:latin typeface="Calibri" pitchFamily="34" charset="0"/>
                 <a:ea typeface="Calibri" pitchFamily="34" charset="-122"/>
@@ -9992,7 +10050,7 @@
             <a:r>
               <a:rPr lang="en-US" sz="1300" b="1" dirty="0">
                 <a:solidFill>
-                  <a:srgbClr val="0B3D54"/>
+                  <a:srgbClr val="F5F6FA"/>
                 </a:solidFill>
                 <a:latin typeface="Calibri" pitchFamily="34" charset="0"/>
                 <a:ea typeface="Calibri" pitchFamily="34" charset="-122"/>
@@ -10019,7 +10077,7 @@
             <a:avLst/>
           </a:prstGeom>
           <a:solidFill>
-            <a:srgbClr val="1C7CA5"/>
+            <a:srgbClr val="5CD4EC"/>
           </a:solidFill>
           <a:ln/>
         </p:spPr>
@@ -10051,7 +10109,7 @@
             <a:r>
               <a:rPr lang="en-US" sz="1300" dirty="0">
                 <a:solidFill>
-                  <a:srgbClr val="1A2A33"/>
+                  <a:srgbClr val="C6CAD8"/>
                 </a:solidFill>
                 <a:latin typeface="Calibri" pitchFamily="34" charset="0"/>
                 <a:ea typeface="Calibri" pitchFamily="34" charset="-122"/>
@@ -10090,7 +10148,7 @@
             <a:r>
               <a:rPr lang="en-US" sz="1300" b="1" dirty="0">
                 <a:solidFill>
-                  <a:srgbClr val="0B3D54"/>
+                  <a:srgbClr val="F5F6FA"/>
                 </a:solidFill>
                 <a:latin typeface="Calibri" pitchFamily="34" charset="0"/>
                 <a:ea typeface="Calibri" pitchFamily="34" charset="-122"/>
@@ -10117,7 +10175,7 @@
             <a:avLst/>
           </a:prstGeom>
           <a:solidFill>
-            <a:srgbClr val="E5B23C"/>
+            <a:srgbClr val="E6B94A"/>
           </a:solidFill>
           <a:ln/>
         </p:spPr>
@@ -10149,7 +10207,7 @@
             <a:r>
               <a:rPr lang="en-US" sz="1300" dirty="0">
                 <a:solidFill>
-                  <a:srgbClr val="1A2A33"/>
+                  <a:srgbClr val="C6CAD8"/>
                 </a:solidFill>
                 <a:latin typeface="Calibri" pitchFamily="34" charset="0"/>
                 <a:ea typeface="Calibri" pitchFamily="34" charset="-122"/>
@@ -10188,7 +10246,7 @@
             <a:r>
               <a:rPr lang="en-US" sz="1300" b="1" dirty="0">
                 <a:solidFill>
-                  <a:srgbClr val="0B3D54"/>
+                  <a:srgbClr val="F5F6FA"/>
                 </a:solidFill>
                 <a:latin typeface="Calibri" pitchFamily="34" charset="0"/>
                 <a:ea typeface="Calibri" pitchFamily="34" charset="-122"/>
@@ -10215,7 +10273,7 @@
             <a:avLst/>
           </a:prstGeom>
           <a:solidFill>
-            <a:srgbClr val="C9962B"/>
+            <a:srgbClr val="F7903A"/>
           </a:solidFill>
           <a:ln/>
         </p:spPr>
@@ -10247,7 +10305,7 @@
             <a:r>
               <a:rPr lang="en-US" sz="1300" dirty="0">
                 <a:solidFill>
-                  <a:srgbClr val="1A2A33"/>
+                  <a:srgbClr val="C6CAD8"/>
                 </a:solidFill>
                 <a:latin typeface="Calibri" pitchFamily="34" charset="0"/>
                 <a:ea typeface="Calibri" pitchFamily="34" charset="-122"/>
@@ -10286,7 +10344,7 @@
             <a:r>
               <a:rPr lang="en-US" sz="1300" b="1" dirty="0">
                 <a:solidFill>
-                  <a:srgbClr val="0B3D54"/>
+                  <a:srgbClr val="F5F6FA"/>
                 </a:solidFill>
                 <a:latin typeface="Calibri" pitchFamily="34" charset="0"/>
                 <a:ea typeface="Calibri" pitchFamily="34" charset="-122"/>
@@ -10313,7 +10371,7 @@
             <a:avLst/>
           </a:prstGeom>
           <a:solidFill>
-            <a:srgbClr val="5E8CA0"/>
+            <a:srgbClr val="B27CFF"/>
           </a:solidFill>
           <a:ln/>
         </p:spPr>
@@ -10345,7 +10403,7 @@
             <a:r>
               <a:rPr lang="en-US" sz="1300" dirty="0">
                 <a:solidFill>
-                  <a:srgbClr val="1A2A33"/>
+                  <a:srgbClr val="C6CAD8"/>
                 </a:solidFill>
                 <a:latin typeface="Calibri" pitchFamily="34" charset="0"/>
                 <a:ea typeface="Calibri" pitchFamily="34" charset="-122"/>
@@ -10384,7 +10442,7 @@
             <a:r>
               <a:rPr lang="en-US" sz="1300" b="1" dirty="0">
                 <a:solidFill>
-                  <a:srgbClr val="0B3D54"/>
+                  <a:srgbClr val="F5F6FA"/>
                 </a:solidFill>
                 <a:latin typeface="Calibri" pitchFamily="34" charset="0"/>
                 <a:ea typeface="Calibri" pitchFamily="34" charset="-122"/>
@@ -10411,7 +10469,7 @@
             <a:avLst/>
           </a:prstGeom>
           <a:solidFill>
-            <a:srgbClr val="8FB3C4"/>
+            <a:srgbClr val="EF5A6A"/>
           </a:solidFill>
           <a:ln/>
         </p:spPr>
@@ -10443,7 +10501,7 @@
             <a:r>
               <a:rPr lang="en-US" sz="1300" dirty="0">
                 <a:solidFill>
-                  <a:srgbClr val="1A2A33"/>
+                  <a:srgbClr val="C6CAD8"/>
                 </a:solidFill>
                 <a:latin typeface="Calibri" pitchFamily="34" charset="0"/>
                 <a:ea typeface="Calibri" pitchFamily="34" charset="-122"/>
@@ -10482,7 +10540,7 @@
             <a:r>
               <a:rPr lang="en-US" sz="1300" b="1" dirty="0">
                 <a:solidFill>
-                  <a:srgbClr val="0B3D54"/>
+                  <a:srgbClr val="F5F6FA"/>
                 </a:solidFill>
                 <a:latin typeface="Calibri" pitchFamily="34" charset="0"/>
                 <a:ea typeface="Calibri" pitchFamily="34" charset="-122"/>
@@ -10509,7 +10567,7 @@
             <a:avLst/>
           </a:prstGeom>
           <a:solidFill>
-            <a:srgbClr val="A8742E"/>
+            <a:srgbClr val="5FD49A"/>
           </a:solidFill>
           <a:ln/>
         </p:spPr>
@@ -10541,7 +10599,7 @@
             <a:r>
               <a:rPr lang="en-US" sz="1300" dirty="0">
                 <a:solidFill>
-                  <a:srgbClr val="1A2A33"/>
+                  <a:srgbClr val="C6CAD8"/>
                 </a:solidFill>
                 <a:latin typeface="Calibri" pitchFamily="34" charset="0"/>
                 <a:ea typeface="Calibri" pitchFamily="34" charset="-122"/>
@@ -10580,7 +10638,7 @@
             <a:r>
               <a:rPr lang="en-US" sz="1300" b="1" dirty="0">
                 <a:solidFill>
-                  <a:srgbClr val="0B3D54"/>
+                  <a:srgbClr val="F5F6FA"/>
                 </a:solidFill>
                 <a:latin typeface="Calibri" pitchFamily="34" charset="0"/>
                 <a:ea typeface="Calibri" pitchFamily="34" charset="-122"/>
@@ -10609,7 +10667,7 @@
           <a:noFill/>
           <a:ln w="19050">
             <a:solidFill>
-              <a:srgbClr val="E5B23C"/>
+              <a:srgbClr val="E6B94A"/>
             </a:solidFill>
             <a:prstDash val="solid"/>
           </a:ln>
@@ -10642,7 +10700,7 @@
             <a:r>
               <a:rPr lang="en-US" sz="1400" b="1" dirty="0">
                 <a:solidFill>
-                  <a:srgbClr val="0B3D54"/>
+                  <a:srgbClr val="F5F6FA"/>
                 </a:solidFill>
                 <a:latin typeface="Calibri" pitchFamily="34" charset="0"/>
                 <a:ea typeface="Calibri" pitchFamily="34" charset="-122"/>
@@ -10681,7 +10739,7 @@
             <a:r>
               <a:rPr lang="en-US" sz="1600" b="1" dirty="0">
                 <a:solidFill>
-                  <a:srgbClr val="C9962B"/>
+                  <a:srgbClr val="E6B94A"/>
                 </a:solidFill>
                 <a:latin typeface="Times New Roman" pitchFamily="34" charset="0"/>
                 <a:ea typeface="Times New Roman" pitchFamily="34" charset="-122"/>
@@ -10720,7 +10778,7 @@
             <a:r>
               <a:rPr lang="en-US" sz="1000" dirty="0">
                 <a:solidFill>
-                  <a:srgbClr val="5E6B72"/>
+                  <a:srgbClr val="5E6478"/>
                 </a:solidFill>
                 <a:latin typeface="Calibri" pitchFamily="34" charset="0"/>
                 <a:ea typeface="Calibri" pitchFamily="34" charset="-122"/>
@@ -10759,7 +10817,7 @@
             <a:r>
               <a:rPr lang="en-US" sz="1000" dirty="0">
                 <a:solidFill>
-                  <a:srgbClr val="5E6B72"/>
+                  <a:srgbClr val="5E6478"/>
                 </a:solidFill>
                 <a:latin typeface="Calibri" pitchFamily="34" charset="0"/>
                 <a:ea typeface="Calibri" pitchFamily="34" charset="-122"/>

</xml_diff>

<commit_message>
docs(presentation): reposition copy — companion, not edu-platform
- Rewrite slide-1 subtitle: history in world/cultural context + AI
  dialogue with figures (drop "education platform" / "тірілтетін")
- Drop "literature" framing (slides 1, 2, 7)
- Use Kazakh AI abbreviation ЖИ instead of ИИ across the deck

Co-Authored-By: Claude Opus 4.8 <noreply@anthropic.com>
</commit_message>
<xml_diff>
--- a/grant-presentation/Tarixi-Timeline_Tauelsizdik_urpaqtary.pptx
+++ b/grant-presentation/Tarixi-Timeline_Tauelsizdik_urpaqtary.pptx
@@ -1807,7 +1807,7 @@
         <p:spPr>
           <a:xfrm>
             <a:off x="822960" y="3063240"/>
-            <a:ext cx="8961120" cy="822960"/>
+            <a:ext cx="9326880" cy="914400"/>
           </a:xfrm>
           <a:prstGeom prst="rect">
             <a:avLst/>
@@ -1821,12 +1821,12 @@
           <a:p>
             <a:pPr indent="0" marL="0">
               <a:lnSpc>
-                <a:spcPct val="110000"/>
+                <a:spcPct val="115000"/>
               </a:lnSpc>
               <a:buNone/>
             </a:pPr>
             <a:r>
-              <a:rPr lang="en-US" sz="2000" dirty="0">
+              <a:rPr lang="en-US" sz="1900" dirty="0">
                 <a:solidFill>
                   <a:srgbClr val="C6CAD8"/>
                 </a:solidFill>
@@ -1834,9 +1834,9 @@
                 <a:ea typeface="Calibri" pitchFamily="34" charset="-122"/>
                 <a:cs typeface="Calibri" pitchFamily="34" charset="-120"/>
               </a:rPr>
-              <a:t>Қазақстан тарихы мен әдебиетін зерттеуге арналған интерактивті білім беру платформасы</a:t>
-            </a:r>
-            <a:endParaRPr lang="en-US" sz="2000" dirty="0"/>
+              <a:t>Қазақстан тарихын әлемдік тарих пен жаһандық мәдени контексте көрсетіп, тарихи тұлғалармен ЖИ-сұхбат арқылы жақындататын интерактивті платформа.</a:t>
+            </a:r>
+            <a:endParaRPr lang="en-US" sz="1900" dirty="0"/>
           </a:p>
         </p:txBody>
       </p:sp>
@@ -2615,7 +2615,7 @@
                 <a:ea typeface="Times New Roman" pitchFamily="34" charset="-122"/>
                 <a:cs typeface="Times New Roman" pitchFamily="34" charset="-120"/>
               </a:rPr>
-              <a:t>ИИ-чат</a:t>
+              <a:t>ЖИ-сұхбат</a:t>
             </a:r>
             <a:endParaRPr lang="en-US" sz="1600" dirty="0"/>
           </a:p>
@@ -3154,7 +3154,7 @@
                 <a:ea typeface="Calibri" pitchFamily="34" charset="-122"/>
                 <a:cs typeface="Calibri" pitchFamily="34" charset="-120"/>
               </a:rPr>
-              <a:t>Кеңістік пен уақыт синхроны. Таймлайндағы ползунокты жылжыту арқылы картадағы шекаралардың өзгеруін бақылау. Оқиғаны, оның орналасқан жерін және ИИ-тұлғаның пікірін бір жүйеде біріктіру.</a:t>
+              <a:t>Кеңістік пен уақыт синхроны. Таймлайндағы ползунокты жылжыту арқылы картадағы шекаралардың өзгеруін бақылау. Оқиғаны, оның орналасқан жерін және ЖИ-тұлғаның пікірін бір жүйеде біріктіру.</a:t>
             </a:r>
             <a:endParaRPr lang="en-US" sz="1250" dirty="0"/>
           </a:p>
@@ -3608,7 +3608,7 @@
                 <a:ea typeface="Calibri" pitchFamily="34" charset="-122"/>
                 <a:cs typeface="Calibri" pitchFamily="34" charset="-120"/>
               </a:rPr>
-              <a:t>Қазіргі мектептегі Қазақстан тарихы мен әдебиетін оқыту негізінен даталар мен фактілерді механикалық жаттауға бағытталған. Бұл пәнді үстірт қабылдауды қалыптастырады және оқушылардың қызығушылығын төмендетеді.</a:t>
+              <a:t>Қазіргі мектептегі Қазақстан тарихын оқыту негізінен даталар мен фактілерді механикалық жаттауға бағытталған. Бұл пәнді үстірт қабылдауды қалыптастырады және оқушылардың қызығушылығын төмендетеді.</a:t>
             </a:r>
             <a:endParaRPr lang="en-US" sz="1600" dirty="0"/>
           </a:p>
@@ -4698,7 +4698,7 @@
                 <a:ea typeface="Times New Roman" pitchFamily="34" charset="-122"/>
                 <a:cs typeface="Times New Roman" pitchFamily="34" charset="-120"/>
               </a:rPr>
-              <a:t>Тарихи тұлғалармен ИИ-чат</a:t>
+              <a:t>Тарихи тұлғалармен ЖИ-сұхбат</a:t>
             </a:r>
             <a:endParaRPr lang="en-US" sz="1900" dirty="0"/>
           </a:p>
@@ -5320,7 +5320,7 @@
                 <a:ea typeface="Calibri" pitchFamily="34" charset="-122"/>
                 <a:cs typeface="Calibri" pitchFamily="34" charset="-120"/>
               </a:rPr>
-              <a:t>Әл-Фараби, Абай немесе хан-билермен ИИ арқылы сұхбаттасады - нақты адаммен сөйлескендей.</a:t>
+              <a:t>Әл-Фараби, Абай немесе хан-билермен ЖИ арқылы сұхбаттасады - нақты адаммен сөйлескендей.</a:t>
             </a:r>
             <a:endParaRPr lang="en-US" sz="1250" dirty="0"/>
           </a:p>
@@ -6708,7 +6708,7 @@
                 <a:ea typeface="Calibri" pitchFamily="34" charset="-122"/>
                 <a:cs typeface="Calibri" pitchFamily="34" charset="-120"/>
               </a:rPr>
-              <a:t>Объектіні таңдағанда фото, сипаттама және ИИ-чатты ашатын «Поговорить» батырмасы көрінеді.</a:t>
+              <a:t>Объектіні таңдағанда фото, сипаттама және ЖИ-сұхбатты ашатын «Поговорить» батырмасы көрінеді.</a:t>
             </a:r>
             <a:endParaRPr lang="en-US" sz="1200" dirty="0"/>
           </a:p>
@@ -6896,7 +6896,7 @@
                 <a:ea typeface="Times New Roman" pitchFamily="34" charset="-122"/>
                 <a:cs typeface="Times New Roman" pitchFamily="34" charset="-120"/>
               </a:rPr>
-              <a:t>Тарихи тұлғалармен ИИ-сұхбат</a:t>
+              <a:t>Тарихи тұлғалармен ЖИ-сұхбат</a:t>
             </a:r>
             <a:endParaRPr lang="en-US" sz="3200" dirty="0"/>
           </a:p>
@@ -7116,7 +7116,7 @@
                 <a:ea typeface="Times New Roman" pitchFamily="34" charset="-122"/>
                 <a:cs typeface="Times New Roman" pitchFamily="34" charset="-120"/>
               </a:rPr>
-              <a:t>Дәуірге дәйекті ИИ-агенттер</a:t>
+              <a:t>Дәуірге дәйекті ЖИ-агенттер</a:t>
             </a:r>
             <a:endParaRPr lang="en-US" sz="1600" dirty="0"/>
           </a:p>
@@ -7753,7 +7753,7 @@
                 <a:ea typeface="Calibri" pitchFamily="34" charset="-122"/>
                 <a:cs typeface="Calibri" pitchFamily="34" charset="-120"/>
               </a:rPr>
-              <a:t>Тарих пен әдебиетке қызығатын жастар</a:t>
+              <a:t>Тарих пен мәдениетке қызығатын жастар</a:t>
             </a:r>
             <a:endParaRPr lang="en-US" sz="1250" dirty="0"/>
           </a:p>
@@ -7910,7 +7910,7 @@
                 <a:ea typeface="Calibri" pitchFamily="34" charset="-122"/>
                 <a:cs typeface="Calibri" pitchFamily="34" charset="-120"/>
               </a:rPr>
-              <a:t>Тарих және әдебиет бойынша курстар, орталықтар</a:t>
+              <a:t>Тарих бойынша курстар мен орталықтар</a:t>
             </a:r>
             <a:endParaRPr lang="en-US" sz="1250" dirty="0"/>
           </a:p>

</xml_diff>